<commit_message>
fix(deck): calibrate 16:9 viewport bounds to prevent content overflow in HTML and PPTX
</commit_message>
<xml_diff>
--- a/presentation.pptx
+++ b/presentation.pptx
@@ -14,8 +14,8 @@
   <p:notesMasterIdLst>
     <p:notesMasterId r:id="rId7"/>
   </p:notesMasterIdLst>
-  <p:sldSz cx="9144000" cy="5143500"/>
-  <p:notesSz cx="5143500" cy="9144000"/>
+  <p:sldSz cx="12191695" cy="6858000"/>
+  <p:notesSz cx="6858000" cy="12191695"/>
   <p:defaultTextStyle>
     <a:lvl1pPr marL="0" algn="l" defTabSz="914400" rtl="0" eaLnBrk="1" latinLnBrk="0" hangingPunct="1">
       <a:defRPr sz="1800" kern="1200">
@@ -1239,8 +1239,8 @@
         </p:nvSpPr>
         <p:spPr>
           <a:xfrm>
-            <a:off x="731520" y="457200"/>
-            <a:ext cx="7315200" cy="365760"/>
+            <a:off x="731520" y="411480"/>
+            <a:ext cx="7315200" cy="274320"/>
           </a:xfrm>
           <a:prstGeom prst="rect">
             <a:avLst/>
@@ -1256,14 +1256,14 @@
               <a:buNone/>
             </a:pPr>
             <a:r>
-              <a:rPr lang="en-US" sz="1100" b="1" spc="200" kern="0" dirty="0">
+              <a:rPr lang="en-US" sz="1000" b="1" spc="200" kern="0" dirty="0">
                 <a:solidFill>
                   <a:srgbClr val="F59E0B"/>
                 </a:solidFill>
               </a:rPr>
               <a:t>UNDERWORLD ENGINE • TEAM BRIEFING</a:t>
             </a:r>
-            <a:endParaRPr lang="en-US" sz="1100" dirty="0"/>
+            <a:endParaRPr lang="en-US" sz="1000" dirty="0"/>
           </a:p>
         </p:txBody>
       </p:sp>
@@ -1275,8 +1275,8 @@
         </p:nvSpPr>
         <p:spPr>
           <a:xfrm>
-            <a:off x="731520" y="731520"/>
-            <a:ext cx="10058400" cy="731520"/>
+            <a:off x="731520" y="685800"/>
+            <a:ext cx="10698480" cy="548640"/>
           </a:xfrm>
           <a:prstGeom prst="rect">
             <a:avLst/>
@@ -1292,14 +1292,14 @@
               <a:buNone/>
             </a:pPr>
             <a:r>
-              <a:rPr lang="en-US" sz="3200" b="1" dirty="0">
+              <a:rPr lang="en-US" sz="2600" b="1" dirty="0">
                 <a:solidFill>
                   <a:srgbClr val="FEF3C7"/>
                 </a:solidFill>
               </a:rPr>
               <a:t>ESCAPE FROM TARTARUS</a:t>
             </a:r>
-            <a:endParaRPr lang="en-US" sz="3200" dirty="0"/>
+            <a:endParaRPr lang="en-US" sz="2600" dirty="0"/>
           </a:p>
         </p:txBody>
       </p:sp>
@@ -1311,8 +1311,8 @@
         </p:nvSpPr>
         <p:spPr>
           <a:xfrm>
-            <a:off x="731520" y="1371600"/>
-            <a:ext cx="9144000" cy="365760"/>
+            <a:off x="731520" y="1234440"/>
+            <a:ext cx="10698480" cy="320040"/>
           </a:xfrm>
           <a:prstGeom prst="rect">
             <a:avLst/>
@@ -1328,14 +1328,14 @@
               <a:buNone/>
             </a:pPr>
             <a:r>
-              <a:rPr lang="en-US" sz="1400" dirty="0">
+              <a:rPr lang="en-US" sz="1200" dirty="0">
                 <a:solidFill>
                   <a:srgbClr val="94A3B8"/>
                 </a:solidFill>
               </a:rPr>
-              <a:t>Complete Game Flow &amp; 3-Round Journey</a:t>
-            </a:r>
-            <a:endParaRPr lang="en-US" sz="1400" dirty="0"/>
+              <a:t>Complete Game Overview &amp; 3-Round Journey</a:t>
+            </a:r>
+            <a:endParaRPr lang="en-US" sz="1200" dirty="0"/>
           </a:p>
         </p:txBody>
       </p:sp>
@@ -1347,16 +1347,16 @@
         </p:nvSpPr>
         <p:spPr>
           <a:xfrm>
-            <a:off x="731520" y="1920240"/>
-            <a:ext cx="2423160" cy="1097280"/>
+            <a:off x="731520" y="1691640"/>
+            <a:ext cx="2514600" cy="1005840"/>
           </a:xfrm>
           <a:prstGeom prst="roundRect">
             <a:avLst>
-              <a:gd name="adj" fmla="val 8333"/>
+              <a:gd name="adj" fmla="val 7273"/>
             </a:avLst>
           </a:prstGeom>
           <a:solidFill>
-            <a:srgbClr val="151B2E"/>
+            <a:srgbClr val="141A2A"/>
           </a:solidFill>
           <a:ln w="19050">
             <a:solidFill>
@@ -1374,8 +1374,8 @@
         </p:nvSpPr>
         <p:spPr>
           <a:xfrm>
-            <a:off x="822960" y="2011680"/>
-            <a:ext cx="2240280" cy="274320"/>
+            <a:off x="822960" y="1783080"/>
+            <a:ext cx="2331720" cy="228600"/>
           </a:xfrm>
           <a:prstGeom prst="rect">
             <a:avLst/>
@@ -1391,14 +1391,14 @@
               <a:buNone/>
             </a:pPr>
             <a:r>
-              <a:rPr lang="en-US" sz="1000" b="1" dirty="0">
+              <a:rPr lang="en-US" sz="900" b="1" dirty="0">
                 <a:solidFill>
                   <a:srgbClr val="F59E0B"/>
                 </a:solidFill>
               </a:rPr>
               <a:t>0. LOBBY</a:t>
             </a:r>
-            <a:endParaRPr lang="en-US" sz="1000" dirty="0"/>
+            <a:endParaRPr lang="en-US" sz="900" dirty="0"/>
           </a:p>
         </p:txBody>
       </p:sp>
@@ -1410,8 +1410,8 @@
         </p:nvSpPr>
         <p:spPr>
           <a:xfrm>
-            <a:off x="822960" y="2286000"/>
-            <a:ext cx="2240280" cy="320040"/>
+            <a:off x="822960" y="2011680"/>
+            <a:ext cx="2331720" cy="320040"/>
           </a:xfrm>
           <a:prstGeom prst="rect">
             <a:avLst/>
@@ -1446,8 +1446,8 @@
         </p:nvSpPr>
         <p:spPr>
           <a:xfrm>
-            <a:off x="822960" y="2606040"/>
-            <a:ext cx="2240280" cy="320040"/>
+            <a:off x="822960" y="2331720"/>
+            <a:ext cx="2331720" cy="274320"/>
           </a:xfrm>
           <a:prstGeom prst="rect">
             <a:avLst/>
@@ -1463,14 +1463,14 @@
               <a:buNone/>
             </a:pPr>
             <a:r>
-              <a:rPr lang="en-US" sz="1000" dirty="0">
+              <a:rPr lang="en-US" sz="950" dirty="0">
                 <a:solidFill>
                   <a:srgbClr val="94A3B8"/>
                 </a:solidFill>
               </a:rPr>
-              <a:t>3-Emoji Keypad &amp; 5 Roles</a:t>
-            </a:r>
-            <a:endParaRPr lang="en-US" sz="1000" dirty="0"/>
+              <a:t>3-Emoji Keypad &amp; Roles</a:t>
+            </a:r>
+            <a:endParaRPr lang="en-US" sz="950" dirty="0"/>
           </a:p>
         </p:txBody>
       </p:sp>
@@ -1482,16 +1482,16 @@
         </p:nvSpPr>
         <p:spPr>
           <a:xfrm>
-            <a:off x="3337560" y="1920240"/>
-            <a:ext cx="2423160" cy="1097280"/>
+            <a:off x="3465576" y="1691640"/>
+            <a:ext cx="2514600" cy="1005840"/>
           </a:xfrm>
           <a:prstGeom prst="roundRect">
             <a:avLst>
-              <a:gd name="adj" fmla="val 8333"/>
+              <a:gd name="adj" fmla="val 7273"/>
             </a:avLst>
           </a:prstGeom>
           <a:solidFill>
-            <a:srgbClr val="151B2E"/>
+            <a:srgbClr val="141A2A"/>
           </a:solidFill>
           <a:ln w="19050">
             <a:solidFill>
@@ -1509,8 +1509,8 @@
         </p:nvSpPr>
         <p:spPr>
           <a:xfrm>
-            <a:off x="3429000" y="2011680"/>
-            <a:ext cx="2240280" cy="274320"/>
+            <a:off x="3557016" y="1783080"/>
+            <a:ext cx="2331720" cy="228600"/>
           </a:xfrm>
           <a:prstGeom prst="rect">
             <a:avLst/>
@@ -1526,14 +1526,14 @@
               <a:buNone/>
             </a:pPr>
             <a:r>
-              <a:rPr lang="en-US" sz="1000" b="1" dirty="0">
+              <a:rPr lang="en-US" sz="900" b="1" dirty="0">
                 <a:solidFill>
                   <a:srgbClr val="F59E0B"/>
                 </a:solidFill>
               </a:rPr>
               <a:t>1. ROUND 1</a:t>
             </a:r>
-            <a:endParaRPr lang="en-US" sz="1000" dirty="0"/>
+            <a:endParaRPr lang="en-US" sz="900" dirty="0"/>
           </a:p>
         </p:txBody>
       </p:sp>
@@ -1545,8 +1545,8 @@
         </p:nvSpPr>
         <p:spPr>
           <a:xfrm>
-            <a:off x="3429000" y="2286000"/>
-            <a:ext cx="2240280" cy="320040"/>
+            <a:off x="3557016" y="2011680"/>
+            <a:ext cx="2331720" cy="320040"/>
           </a:xfrm>
           <a:prstGeom prst="rect">
             <a:avLst/>
@@ -1581,8 +1581,8 @@
         </p:nvSpPr>
         <p:spPr>
           <a:xfrm>
-            <a:off x="3429000" y="2606040"/>
-            <a:ext cx="2240280" cy="320040"/>
+            <a:off x="3557016" y="2331720"/>
+            <a:ext cx="2331720" cy="274320"/>
           </a:xfrm>
           <a:prstGeom prst="rect">
             <a:avLst/>
@@ -1598,14 +1598,14 @@
               <a:buNone/>
             </a:pPr>
             <a:r>
-              <a:rPr lang="en-US" sz="1000" dirty="0">
+              <a:rPr lang="en-US" sz="950" dirty="0">
                 <a:solidFill>
                   <a:srgbClr val="94A3B8"/>
                 </a:solidFill>
               </a:rPr>
-              <a:t>Physical Phone Alignment</a:t>
-            </a:r>
-            <a:endParaRPr lang="en-US" sz="1000" dirty="0"/>
+              <a:t>Physical Phone Puzzle</a:t>
+            </a:r>
+            <a:endParaRPr lang="en-US" sz="950" dirty="0"/>
           </a:p>
         </p:txBody>
       </p:sp>
@@ -1617,16 +1617,16 @@
         </p:nvSpPr>
         <p:spPr>
           <a:xfrm>
-            <a:off x="5943600" y="1920240"/>
-            <a:ext cx="2423160" cy="1097280"/>
+            <a:off x="6199632" y="1691640"/>
+            <a:ext cx="2514600" cy="1005840"/>
           </a:xfrm>
           <a:prstGeom prst="roundRect">
             <a:avLst>
-              <a:gd name="adj" fmla="val 8333"/>
+              <a:gd name="adj" fmla="val 7273"/>
             </a:avLst>
           </a:prstGeom>
           <a:solidFill>
-            <a:srgbClr val="151B2E"/>
+            <a:srgbClr val="141A2A"/>
           </a:solidFill>
           <a:ln w="19050">
             <a:solidFill>
@@ -1644,8 +1644,8 @@
         </p:nvSpPr>
         <p:spPr>
           <a:xfrm>
-            <a:off x="6035040" y="2011680"/>
-            <a:ext cx="2240280" cy="274320"/>
+            <a:off x="6291072" y="1783080"/>
+            <a:ext cx="2331720" cy="228600"/>
           </a:xfrm>
           <a:prstGeom prst="rect">
             <a:avLst/>
@@ -1661,14 +1661,14 @@
               <a:buNone/>
             </a:pPr>
             <a:r>
-              <a:rPr lang="en-US" sz="1000" b="1" dirty="0">
+              <a:rPr lang="en-US" sz="900" b="1" dirty="0">
                 <a:solidFill>
                   <a:srgbClr val="F59E0B"/>
                 </a:solidFill>
               </a:rPr>
               <a:t>2. ROUND 2</a:t>
             </a:r>
-            <a:endParaRPr lang="en-US" sz="1000" dirty="0"/>
+            <a:endParaRPr lang="en-US" sz="900" dirty="0"/>
           </a:p>
         </p:txBody>
       </p:sp>
@@ -1680,8 +1680,8 @@
         </p:nvSpPr>
         <p:spPr>
           <a:xfrm>
-            <a:off x="6035040" y="2286000"/>
-            <a:ext cx="2240280" cy="320040"/>
+            <a:off x="6291072" y="2011680"/>
+            <a:ext cx="2331720" cy="320040"/>
           </a:xfrm>
           <a:prstGeom prst="rect">
             <a:avLst/>
@@ -1716,8 +1716,8 @@
         </p:nvSpPr>
         <p:spPr>
           <a:xfrm>
-            <a:off x="6035040" y="2606040"/>
-            <a:ext cx="2240280" cy="320040"/>
+            <a:off x="6291072" y="2331720"/>
+            <a:ext cx="2331720" cy="274320"/>
           </a:xfrm>
           <a:prstGeom prst="rect">
             <a:avLst/>
@@ -1733,14 +1733,14 @@
               <a:buNone/>
             </a:pPr>
             <a:r>
-              <a:rPr lang="en-US" sz="1000" dirty="0">
+              <a:rPr lang="en-US" sz="950" dirty="0">
                 <a:solidFill>
                   <a:srgbClr val="94A3B8"/>
                 </a:solidFill>
               </a:rPr>
               <a:t>Social Dilemma &amp; Bluffing</a:t>
             </a:r>
-            <a:endParaRPr lang="en-US" sz="1000" dirty="0"/>
+            <a:endParaRPr lang="en-US" sz="950" dirty="0"/>
           </a:p>
         </p:txBody>
       </p:sp>
@@ -1752,16 +1752,16 @@
         </p:nvSpPr>
         <p:spPr>
           <a:xfrm>
-            <a:off x="8549640" y="1920240"/>
-            <a:ext cx="2423160" cy="1097280"/>
+            <a:off x="8933688" y="1691640"/>
+            <a:ext cx="2514600" cy="1005840"/>
           </a:xfrm>
           <a:prstGeom prst="roundRect">
             <a:avLst>
-              <a:gd name="adj" fmla="val 8333"/>
+              <a:gd name="adj" fmla="val 7273"/>
             </a:avLst>
           </a:prstGeom>
           <a:solidFill>
-            <a:srgbClr val="151B2E"/>
+            <a:srgbClr val="141A2A"/>
           </a:solidFill>
           <a:ln w="19050">
             <a:solidFill>
@@ -1779,8 +1779,8 @@
         </p:nvSpPr>
         <p:spPr>
           <a:xfrm>
-            <a:off x="8641080" y="2011680"/>
-            <a:ext cx="2240280" cy="274320"/>
+            <a:off x="9025128" y="1783080"/>
+            <a:ext cx="2331720" cy="228600"/>
           </a:xfrm>
           <a:prstGeom prst="rect">
             <a:avLst/>
@@ -1796,14 +1796,14 @@
               <a:buNone/>
             </a:pPr>
             <a:r>
-              <a:rPr lang="en-US" sz="1000" b="1" dirty="0">
+              <a:rPr lang="en-US" sz="900" b="1" dirty="0">
                 <a:solidFill>
                   <a:srgbClr val="F59E0B"/>
                 </a:solidFill>
               </a:rPr>
               <a:t>3. ROUND 3</a:t>
             </a:r>
-            <a:endParaRPr lang="en-US" sz="1000" dirty="0"/>
+            <a:endParaRPr lang="en-US" sz="900" dirty="0"/>
           </a:p>
         </p:txBody>
       </p:sp>
@@ -1815,8 +1815,8 @@
         </p:nvSpPr>
         <p:spPr>
           <a:xfrm>
-            <a:off x="8641080" y="2286000"/>
-            <a:ext cx="2240280" cy="320040"/>
+            <a:off x="9025128" y="2011680"/>
+            <a:ext cx="2331720" cy="320040"/>
           </a:xfrm>
           <a:prstGeom prst="rect">
             <a:avLst/>
@@ -1851,8 +1851,8 @@
         </p:nvSpPr>
         <p:spPr>
           <a:xfrm>
-            <a:off x="8641080" y="2606040"/>
-            <a:ext cx="2240280" cy="320040"/>
+            <a:off x="9025128" y="2331720"/>
+            <a:ext cx="2331720" cy="274320"/>
           </a:xfrm>
           <a:prstGeom prst="rect">
             <a:avLst/>
@@ -1868,14 +1868,14 @@
               <a:buNone/>
             </a:pPr>
             <a:r>
-              <a:rPr lang="en-US" sz="1000" dirty="0">
+              <a:rPr lang="en-US" sz="950" dirty="0">
                 <a:solidFill>
                   <a:srgbClr val="94A3B8"/>
                 </a:solidFill>
               </a:rPr>
               <a:t>1,000m Vessel Royale</a:t>
             </a:r>
-            <a:endParaRPr lang="en-US" sz="1000" dirty="0"/>
+            <a:endParaRPr lang="en-US" sz="950" dirty="0"/>
           </a:p>
         </p:txBody>
       </p:sp>
@@ -1887,16 +1887,16 @@
         </p:nvSpPr>
         <p:spPr>
           <a:xfrm>
-            <a:off x="731520" y="3291840"/>
-            <a:ext cx="5120640" cy="2926080"/>
+            <a:off x="731520" y="2926080"/>
+            <a:ext cx="5257800" cy="3337560"/>
           </a:xfrm>
           <a:prstGeom prst="roundRect">
             <a:avLst>
-              <a:gd name="adj" fmla="val 3125"/>
+              <a:gd name="adj" fmla="val 2192"/>
             </a:avLst>
           </a:prstGeom>
           <a:solidFill>
-            <a:srgbClr val="151B2E"/>
+            <a:srgbClr val="141A2A"/>
           </a:solidFill>
           <a:ln w="12700">
             <a:solidFill>
@@ -1914,8 +1914,8 @@
         </p:nvSpPr>
         <p:spPr>
           <a:xfrm>
-            <a:off x="914400" y="3474720"/>
-            <a:ext cx="4754880" cy="365760"/>
+            <a:off x="960120" y="3108960"/>
+            <a:ext cx="4800600" cy="365760"/>
           </a:xfrm>
           <a:prstGeom prst="rect">
             <a:avLst/>
@@ -1950,8 +1950,8 @@
         </p:nvSpPr>
         <p:spPr>
           <a:xfrm>
-            <a:off x="914400" y="3931920"/>
-            <a:ext cx="4754880" cy="2103120"/>
+            <a:off x="960120" y="3566160"/>
+            <a:ext cx="4800600" cy="2560320"/>
           </a:xfrm>
           <a:prstGeom prst="rect">
             <a:avLst/>
@@ -1965,91 +1965,120 @@
           <a:p>
             <a:pPr indent="0" marL="0">
               <a:lnSpc>
-                <a:spcPct val="120000"/>
-              </a:lnSpc>
-              <a:buNone/>
-            </a:pPr>
-            <a:r>
-              <a:rPr lang="en-US" sz="1200" b="1" dirty="0">
+                <a:spcPct val="115000"/>
+              </a:lnSpc>
+              <a:buNone/>
+            </a:pPr>
+            <a:r>
+              <a:rPr lang="en-US" sz="1150" b="1" dirty="0">
                 <a:solidFill>
                   <a:srgbClr val="E2E8F0"/>
                 </a:solidFill>
               </a:rPr>
-              <a:t>• 5 Crew Member Identities: </a:t>
-            </a:r>
-            <a:pPr indent="0" marL="0">
-              <a:lnSpc>
-                <a:spcPct val="120000"/>
-              </a:lnSpc>
-              <a:buNone/>
-            </a:pPr>
-            <a:r>
-              <a:rPr lang="en-US" sz="1200" dirty="0">
+              <a:t>• 5 Distinct Roles: </a:t>
+            </a:r>
+            <a:pPr indent="0" marL="0">
+              <a:lnSpc>
+                <a:spcPct val="115000"/>
+              </a:lnSpc>
+              <a:buNone/>
+            </a:pPr>
+            <a:r>
+              <a:rPr lang="en-US" sz="1150" dirty="0">
                 <a:solidFill>
                   <a:srgbClr val="94A3B8"/>
                 </a:solidFill>
               </a:rPr>
-              <a:t>Navigator, Oracle, Scholar, Torchbearer, Negotiator (roles serve as identity and tablet slots; no complex powers to memorize).
+              <a:t>Navigator, Oracle, Scholar, Torchbearer, Negotiator.
 </a:t>
             </a:r>
             <a:pPr indent="0" marL="0">
               <a:lnSpc>
-                <a:spcPct val="120000"/>
-              </a:lnSpc>
-              <a:buNone/>
-            </a:pPr>
-            <a:r>
-              <a:rPr lang="en-US" sz="1200" b="1" dirty="0">
+                <a:spcPct val="115000"/>
+              </a:lnSpc>
+              <a:buNone/>
+            </a:pPr>
+            <a:r>
+              <a:rPr lang="en-US" sz="1150" b="1" dirty="0">
                 <a:solidFill>
                   <a:srgbClr val="E2E8F0"/>
                 </a:solidFill>
               </a:rPr>
+              <a:t>• Simple Identity (No Complex Powers): </a:t>
+            </a:r>
+            <a:pPr indent="0" marL="0">
+              <a:lnSpc>
+                <a:spcPct val="115000"/>
+              </a:lnSpc>
+              <a:buNone/>
+            </a:pPr>
+            <a:r>
+              <a:rPr lang="en-US" sz="1150" dirty="0">
+                <a:solidFill>
+                  <a:srgbClr val="94A3B8"/>
+                </a:solidFill>
+              </a:rPr>
+              <a:t>Roles serve as crew member identities and tablet puzzle slots. Players don't need to learn complicated abilities.
+</a:t>
+            </a:r>
+            <a:pPr indent="0" marL="0">
+              <a:lnSpc>
+                <a:spcPct val="115000"/>
+              </a:lnSpc>
+              <a:buNone/>
+            </a:pPr>
+            <a:r>
+              <a:rPr lang="en-US" sz="1150" b="1" dirty="0">
+                <a:solidFill>
+                  <a:srgbClr val="E2E8F0"/>
+                </a:solidFill>
+              </a:rPr>
               <a:t>• 1-Tap Emoji Joining: </a:t>
             </a:r>
             <a:pPr indent="0" marL="0">
               <a:lnSpc>
-                <a:spcPct val="120000"/>
-              </a:lnSpc>
-              <a:buNone/>
-            </a:pPr>
-            <a:r>
-              <a:rPr lang="en-US" sz="1200" dirty="0">
+                <a:spcPct val="115000"/>
+              </a:lnSpc>
+              <a:buNone/>
+            </a:pPr>
+            <a:r>
+              <a:rPr lang="en-US" sz="1150" dirty="0">
                 <a:solidFill>
                   <a:srgbClr val="94A3B8"/>
                 </a:solidFill>
               </a:rPr>
-              <a:t>One teammate creates the crew; others tap a 3-emoji code (e.g. Skull • Bolt • Shield) on screen.
+              <a:t>One player creates the crew; teammates join by tapping 3 emojis on screen (e.g. Skull • Bolt • Shield).
 </a:t>
             </a:r>
             <a:pPr indent="0" marL="0">
               <a:lnSpc>
-                <a:spcPct val="120000"/>
-              </a:lnSpc>
-              <a:buNone/>
-            </a:pPr>
-            <a:r>
-              <a:rPr lang="en-US" sz="1200" b="1" dirty="0">
+                <a:spcPct val="115000"/>
+              </a:lnSpc>
+              <a:buNone/>
+            </a:pPr>
+            <a:r>
+              <a:rPr lang="en-US" sz="1150" b="1" dirty="0">
                 <a:solidFill>
                   <a:srgbClr val="E2E8F0"/>
                 </a:solidFill>
               </a:rPr>
-              <a:t>• Frictionless: </a:t>
-            </a:r>
-            <a:pPr indent="0" marL="0">
-              <a:lnSpc>
-                <a:spcPct val="120000"/>
-              </a:lnSpc>
-              <a:buNone/>
-            </a:pPr>
-            <a:r>
-              <a:rPr lang="en-US" sz="1200" dirty="0">
-                <a:solidFill>
-                  <a:srgbClr val="94A3B8"/>
-                </a:solidFill>
-              </a:rPr>
-              <a:t>No app downloads, no typing, no camera permissions required.</a:t>
-            </a:r>
-            <a:endParaRPr lang="en-US" sz="1200" dirty="0"/>
+              <a:t>• Zero Friction: </a:t>
+            </a:r>
+            <a:pPr indent="0" marL="0">
+              <a:lnSpc>
+                <a:spcPct val="115000"/>
+              </a:lnSpc>
+              <a:buNone/>
+            </a:pPr>
+            <a:r>
+              <a:rPr lang="en-US" sz="1150" dirty="0">
+                <a:solidFill>
+                  <a:srgbClr val="10B981"/>
+                </a:solidFill>
+              </a:rPr>
+              <a:t>No app to download, no typing, no camera permissions.</a:t>
+            </a:r>
+            <a:endParaRPr lang="en-US" sz="1150" dirty="0"/>
           </a:p>
         </p:txBody>
       </p:sp>
@@ -2061,16 +2090,16 @@
         </p:nvSpPr>
         <p:spPr>
           <a:xfrm>
-            <a:off x="6126480" y="3291840"/>
-            <a:ext cx="5303520" cy="2926080"/>
+            <a:off x="6199632" y="2926080"/>
+            <a:ext cx="5257800" cy="3337560"/>
           </a:xfrm>
           <a:prstGeom prst="roundRect">
             <a:avLst>
-              <a:gd name="adj" fmla="val 3125"/>
+              <a:gd name="adj" fmla="val 2192"/>
             </a:avLst>
           </a:prstGeom>
           <a:solidFill>
-            <a:srgbClr val="151B2E"/>
+            <a:srgbClr val="141A2A"/>
           </a:solidFill>
           <a:ln w="12700">
             <a:solidFill>
@@ -2088,8 +2117,8 @@
         </p:nvSpPr>
         <p:spPr>
           <a:xfrm>
-            <a:off x="6309360" y="3474720"/>
-            <a:ext cx="4937760" cy="365760"/>
+            <a:off x="6428232" y="3108960"/>
+            <a:ext cx="4800600" cy="365760"/>
           </a:xfrm>
           <a:prstGeom prst="rect">
             <a:avLst/>
@@ -2110,7 +2139,7 @@
                   <a:srgbClr val="FEF3C7"/>
                 </a:solidFill>
               </a:rPr>
-              <a:t>🏆 The Grand Objective</a:t>
+              <a:t>🏆 The Ultimate Objective</a:t>
             </a:r>
             <a:endParaRPr lang="en-US" sz="1600" dirty="0"/>
           </a:p>
@@ -2124,8 +2153,8 @@
         </p:nvSpPr>
         <p:spPr>
           <a:xfrm>
-            <a:off x="6309360" y="3931920"/>
-            <a:ext cx="4937760" cy="2103120"/>
+            <a:off x="6428232" y="3566160"/>
+            <a:ext cx="4800600" cy="2560320"/>
           </a:xfrm>
           <a:prstGeom prst="rect">
             <a:avLst/>
@@ -2139,26 +2168,26 @@
           <a:p>
             <a:pPr indent="0" marL="0">
               <a:lnSpc>
-                <a:spcPct val="120000"/>
-              </a:lnSpc>
-              <a:buNone/>
-            </a:pPr>
-            <a:r>
-              <a:rPr lang="en-US" sz="1200" b="1" dirty="0">
+                <a:spcPct val="115000"/>
+              </a:lnSpc>
+              <a:buNone/>
+            </a:pPr>
+            <a:r>
+              <a:rPr lang="en-US" sz="1150" b="1" dirty="0">
                 <a:solidFill>
                   <a:srgbClr val="E2E8F0"/>
                 </a:solidFill>
               </a:rPr>
-              <a:t>• Rounds 1 &amp; 2 (Point Accumulation): </a:t>
-            </a:r>
-            <a:pPr indent="0" marL="0">
-              <a:lnSpc>
-                <a:spcPct val="120000"/>
-              </a:lnSpc>
-              <a:buNone/>
-            </a:pPr>
-            <a:r>
-              <a:rPr lang="en-US" sz="1200" dirty="0">
+              <a:t>• Rounds 1 &amp; 2 (Points Pool): </a:t>
+            </a:r>
+            <a:pPr indent="0" marL="0">
+              <a:lnSpc>
+                <a:spcPct val="115000"/>
+              </a:lnSpc>
+              <a:buNone/>
+            </a:pPr>
+            <a:r>
+              <a:rPr lang="en-US" sz="1150" dirty="0">
                 <a:solidFill>
                   <a:srgbClr val="94A3B8"/>
                 </a:solidFill>
@@ -2168,12 +2197,12 @@
             </a:r>
             <a:pPr indent="0" marL="0">
               <a:lnSpc>
-                <a:spcPct val="120000"/>
-              </a:lnSpc>
-              <a:buNone/>
-            </a:pPr>
-            <a:r>
-              <a:rPr lang="en-US" sz="1200" b="1" dirty="0">
+                <a:spcPct val="115000"/>
+              </a:lnSpc>
+              <a:buNone/>
+            </a:pPr>
+            <a:r>
+              <a:rPr lang="en-US" sz="1150" b="1" dirty="0">
                 <a:solidFill>
                   <a:srgbClr val="E2E8F0"/>
                 </a:solidFill>
@@ -2182,27 +2211,27 @@
             </a:r>
             <a:pPr indent="0" marL="0">
               <a:lnSpc>
-                <a:spcPct val="120000"/>
-              </a:lnSpc>
-              <a:buNone/>
-            </a:pPr>
-            <a:r>
-              <a:rPr lang="en-US" sz="1200" dirty="0">
+                <a:spcPct val="115000"/>
+              </a:lnSpc>
+              <a:buNone/>
+            </a:pPr>
+            <a:r>
+              <a:rPr lang="en-US" sz="1150" dirty="0">
                 <a:solidFill>
                   <a:srgbClr val="94A3B8"/>
                 </a:solidFill>
               </a:rPr>
-              <a:t>Cumulative points convert into a starting distance head-start on the River Styx in Round 3!
+              <a:t>Cumulative points convert directly into starting distance meters on the River Styx in Round 3!
 </a:t>
             </a:r>
             <a:pPr indent="0" marL="0">
               <a:lnSpc>
-                <a:spcPct val="120000"/>
-              </a:lnSpc>
-              <a:buNone/>
-            </a:pPr>
-            <a:r>
-              <a:rPr lang="en-US" sz="1200" b="1" dirty="0">
+                <a:spcPct val="115000"/>
+              </a:lnSpc>
+              <a:buNone/>
+            </a:pPr>
+            <a:r>
+              <a:rPr lang="en-US" sz="1150" b="1" dirty="0">
                 <a:solidFill>
                   <a:srgbClr val="E2E8F0"/>
                 </a:solidFill>
@@ -2211,19 +2240,48 @@
             </a:r>
             <a:pPr indent="0" marL="0">
               <a:lnSpc>
-                <a:spcPct val="120000"/>
-              </a:lnSpc>
-              <a:buNone/>
-            </a:pPr>
-            <a:r>
-              <a:rPr lang="en-US" sz="1200" dirty="0">
+                <a:spcPct val="115000"/>
+              </a:lnSpc>
+              <a:buNone/>
+            </a:pPr>
+            <a:r>
+              <a:rPr lang="en-US" sz="1150" dirty="0">
                 <a:solidFill>
                   <a:srgbClr val="F59E0B"/>
                 </a:solidFill>
               </a:rPr>
-              <a:t>First 3 crews to cross the 1,000-meter portal win Gold, Silver, and Bronze medals.</a:t>
-            </a:r>
-            <a:endParaRPr lang="en-US" sz="1200" dirty="0"/>
+              <a:t>First 3 crews to cross the 1,000-meter exit portal win Gold, Silver, and Bronze medals.
+</a:t>
+            </a:r>
+            <a:pPr indent="0" marL="0">
+              <a:lnSpc>
+                <a:spcPct val="115000"/>
+              </a:lnSpc>
+              <a:buNone/>
+            </a:pPr>
+            <a:r>
+              <a:rPr lang="en-US" sz="1150" b="1" dirty="0">
+                <a:solidFill>
+                  <a:srgbClr val="E2E8F0"/>
+                </a:solidFill>
+              </a:rPr>
+              <a:t>• Fast &amp; Social: </a:t>
+            </a:r>
+            <a:pPr indent="0" marL="0">
+              <a:lnSpc>
+                <a:spcPct val="115000"/>
+              </a:lnSpc>
+              <a:buNone/>
+            </a:pPr>
+            <a:r>
+              <a:rPr lang="en-US" sz="1150" dirty="0">
+                <a:solidFill>
+                  <a:srgbClr val="94A3B8"/>
+                </a:solidFill>
+              </a:rPr>
+              <a:t>The whole experience runs in ~25-30 minutes of high-energy pub interaction.</a:t>
+            </a:r>
+            <a:endParaRPr lang="en-US" sz="1150" dirty="0"/>
           </a:p>
         </p:txBody>
       </p:sp>
@@ -2267,8 +2325,8 @@
         </p:nvSpPr>
         <p:spPr>
           <a:xfrm>
-            <a:off x="731520" y="457200"/>
-            <a:ext cx="7315200" cy="365760"/>
+            <a:off x="731520" y="411480"/>
+            <a:ext cx="7315200" cy="274320"/>
           </a:xfrm>
           <a:prstGeom prst="rect">
             <a:avLst/>
@@ -2284,14 +2342,14 @@
               <a:buNone/>
             </a:pPr>
             <a:r>
-              <a:rPr lang="en-US" sz="1100" b="1" spc="200" kern="0" dirty="0">
+              <a:rPr lang="en-US" sz="1000" b="1" spc="200" kern="0" dirty="0">
                 <a:solidFill>
                   <a:srgbClr val="06B6D4"/>
                 </a:solidFill>
               </a:rPr>
               <a:t>ROUND 1 • PHYSICAL COOPERATION PUZZLE</a:t>
             </a:r>
-            <a:endParaRPr lang="en-US" sz="1100" dirty="0"/>
+            <a:endParaRPr lang="en-US" sz="1000" dirty="0"/>
           </a:p>
         </p:txBody>
       </p:sp>
@@ -2303,8 +2361,8 @@
         </p:nvSpPr>
         <p:spPr>
           <a:xfrm>
-            <a:off x="731520" y="731520"/>
-            <a:ext cx="10058400" cy="731520"/>
+            <a:off x="731520" y="685800"/>
+            <a:ext cx="10698480" cy="548640"/>
           </a:xfrm>
           <a:prstGeom prst="rect">
             <a:avLst/>
@@ -2320,14 +2378,14 @@
               <a:buNone/>
             </a:pPr>
             <a:r>
-              <a:rPr lang="en-US" sz="3200" b="1" dirty="0">
+              <a:rPr lang="en-US" sz="2600" b="1" dirty="0">
                 <a:solidFill>
                   <a:srgbClr val="FEF3C7"/>
                 </a:solidFill>
               </a:rPr>
               <a:t>THE SHATTERED TABLET</a:t>
             </a:r>
-            <a:endParaRPr lang="en-US" sz="3200" dirty="0"/>
+            <a:endParaRPr lang="en-US" sz="2600" dirty="0"/>
           </a:p>
         </p:txBody>
       </p:sp>
@@ -2339,8 +2397,8 @@
         </p:nvSpPr>
         <p:spPr>
           <a:xfrm>
-            <a:off x="731520" y="1371600"/>
-            <a:ext cx="9144000" cy="365760"/>
+            <a:off x="731520" y="1234440"/>
+            <a:ext cx="10698480" cy="320040"/>
           </a:xfrm>
           <a:prstGeom prst="rect">
             <a:avLst/>
@@ -2356,14 +2414,14 @@
               <a:buNone/>
             </a:pPr>
             <a:r>
-              <a:rPr lang="en-US" sz="1400" dirty="0">
+              <a:rPr lang="en-US" sz="1200" dirty="0">
                 <a:solidFill>
                   <a:srgbClr val="94A3B8"/>
                 </a:solidFill>
               </a:rPr>
               <a:t>Tomb Gate Alignment • Duration: ~5 Minutes</a:t>
             </a:r>
-            <a:endParaRPr lang="en-US" sz="1400" dirty="0"/>
+            <a:endParaRPr lang="en-US" sz="1200" dirty="0"/>
           </a:p>
         </p:txBody>
       </p:sp>
@@ -2375,16 +2433,16 @@
         </p:nvSpPr>
         <p:spPr>
           <a:xfrm>
-            <a:off x="731520" y="1920240"/>
-            <a:ext cx="5120640" cy="3474720"/>
+            <a:off x="731520" y="1691640"/>
+            <a:ext cx="5257800" cy="3886200"/>
           </a:xfrm>
           <a:prstGeom prst="roundRect">
             <a:avLst>
-              <a:gd name="adj" fmla="val 2632"/>
+              <a:gd name="adj" fmla="val 1882"/>
             </a:avLst>
           </a:prstGeom>
           <a:solidFill>
-            <a:srgbClr val="151B2E"/>
+            <a:srgbClr val="141A2A"/>
           </a:solidFill>
           <a:ln w="19050">
             <a:solidFill>
@@ -2402,8 +2460,8 @@
         </p:nvSpPr>
         <p:spPr>
           <a:xfrm>
-            <a:off x="914400" y="2103120"/>
-            <a:ext cx="4754880" cy="365760"/>
+            <a:off x="960120" y="1874520"/>
+            <a:ext cx="4800600" cy="365760"/>
           </a:xfrm>
           <a:prstGeom prst="rect">
             <a:avLst/>
@@ -2419,14 +2477,14 @@
               <a:buNone/>
             </a:pPr>
             <a:r>
-              <a:rPr lang="en-US" sz="1800" b="1" dirty="0">
+              <a:rPr lang="en-US" sz="1600" b="1" dirty="0">
                 <a:solidFill>
                   <a:srgbClr val="FEF3C7"/>
                 </a:solidFill>
               </a:rPr>
-              <a:t>🧩 The Mechanic</a:t>
-            </a:r>
-            <a:endParaRPr lang="en-US" sz="1800" dirty="0"/>
+              <a:t>🧩 The Story &amp; Mechanic</a:t>
+            </a:r>
+            <a:endParaRPr lang="en-US" sz="1600" dirty="0"/>
           </a:p>
         </p:txBody>
       </p:sp>
@@ -2438,8 +2496,8 @@
         </p:nvSpPr>
         <p:spPr>
           <a:xfrm>
-            <a:off x="914400" y="2560320"/>
-            <a:ext cx="4754880" cy="2651760"/>
+            <a:off x="960120" y="2331720"/>
+            <a:ext cx="4800600" cy="3017520"/>
           </a:xfrm>
           <a:prstGeom prst="rect">
             <a:avLst/>
@@ -2458,7 +2516,7 @@
               <a:buNone/>
             </a:pPr>
             <a:r>
-              <a:rPr lang="en-US" sz="1200" b="1" dirty="0">
+              <a:rPr lang="en-US" sz="1150" b="1" dirty="0">
                 <a:solidFill>
                   <a:srgbClr val="E2E8F0"/>
                 </a:solidFill>
@@ -2472,7 +2530,7 @@
               <a:buNone/>
             </a:pPr>
             <a:r>
-              <a:rPr lang="en-US" sz="1200" dirty="0">
+              <a:rPr lang="en-US" sz="1150" dirty="0">
                 <a:solidFill>
                   <a:srgbClr val="94A3B8"/>
                 </a:solidFill>
@@ -2487,26 +2545,26 @@
               <a:buNone/>
             </a:pPr>
             <a:r>
-              <a:rPr lang="en-US" sz="1200" b="1" dirty="0">
+              <a:rPr lang="en-US" sz="1150" b="1" dirty="0">
                 <a:solidFill>
                   <a:srgbClr val="E2E8F0"/>
                 </a:solidFill>
               </a:rPr>
-              <a:t>• 5 Slices across 5 Phones: </a:t>
-            </a:r>
-            <a:pPr indent="0" marL="0">
-              <a:lnSpc>
-                <a:spcPct val="115000"/>
-              </a:lnSpc>
-              <a:buNone/>
-            </a:pPr>
-            <a:r>
-              <a:rPr lang="en-US" sz="1200" dirty="0">
+              <a:t>• 5 Slices on 5 Phones: </a:t>
+            </a:r>
+            <a:pPr indent="0" marL="0">
+              <a:lnSpc>
+                <a:spcPct val="115000"/>
+              </a:lnSpc>
+              <a:buNone/>
+            </a:pPr>
+            <a:r>
+              <a:rPr lang="en-US" sz="1150" dirty="0">
                 <a:solidFill>
                   <a:srgbClr val="94A3B8"/>
                 </a:solidFill>
               </a:rPr>
-              <a:t>The tablet is split into 5 vertical slices distributed across the crew's phones (Slots #1 to #5).
+              <a:t>The tablet is split into 5 vertical slices distributed across the crew's phones (#1 to #5).
 </a:t>
             </a:r>
             <a:pPr indent="0" marL="0">
@@ -2516,7 +2574,7 @@
               <a:buNone/>
             </a:pPr>
             <a:r>
-              <a:rPr lang="en-US" sz="1200" b="1" dirty="0">
+              <a:rPr lang="en-US" sz="1150" b="1" dirty="0">
                 <a:solidFill>
                   <a:srgbClr val="E2E8F0"/>
                 </a:solidFill>
@@ -2530,7 +2588,7 @@
               <a:buNone/>
             </a:pPr>
             <a:r>
-              <a:rPr lang="en-US" sz="1200" dirty="0">
+              <a:rPr lang="en-US" sz="1150" dirty="0">
                 <a:solidFill>
                   <a:srgbClr val="94A3B8"/>
                 </a:solidFill>
@@ -2545,7 +2603,7 @@
               <a:buNone/>
             </a:pPr>
             <a:r>
-              <a:rPr lang="en-US" sz="1200" b="1" dirty="0">
+              <a:rPr lang="en-US" sz="1150" b="1" dirty="0">
                 <a:solidFill>
                   <a:srgbClr val="E2E8F0"/>
                 </a:solidFill>
@@ -2559,14 +2617,14 @@
               <a:buNone/>
             </a:pPr>
             <a:r>
-              <a:rPr lang="en-US" sz="1200" dirty="0">
+              <a:rPr lang="en-US" sz="1150" dirty="0">
                 <a:solidFill>
                   <a:srgbClr val="F59E0B"/>
                 </a:solidFill>
               </a:rPr>
-              <a:t>Carved fracture lines align across screen borders to reveal a 2-word ancient codeword (e.g. CRIMSON SHADOW).</a:t>
-            </a:r>
-            <a:endParaRPr lang="en-US" sz="1200" dirty="0"/>
+              <a:t>Golden fracture lines connect across phone borders to reveal a 2-word codeword (e.g. CRIMSON SHADOW).</a:t>
+            </a:r>
+            <a:endParaRPr lang="en-US" sz="1150" dirty="0"/>
           </a:p>
         </p:txBody>
       </p:sp>
@@ -2578,16 +2636,16 @@
         </p:nvSpPr>
         <p:spPr>
           <a:xfrm>
-            <a:off x="6126480" y="1920240"/>
-            <a:ext cx="5303520" cy="3474720"/>
+            <a:off x="6199632" y="1691640"/>
+            <a:ext cx="5257800" cy="3886200"/>
           </a:xfrm>
           <a:prstGeom prst="roundRect">
             <a:avLst>
-              <a:gd name="adj" fmla="val 2632"/>
+              <a:gd name="adj" fmla="val 1882"/>
             </a:avLst>
           </a:prstGeom>
           <a:solidFill>
-            <a:srgbClr val="151B2E"/>
+            <a:srgbClr val="141A2A"/>
           </a:solidFill>
           <a:ln w="12700">
             <a:solidFill>
@@ -2605,8 +2663,8 @@
         </p:nvSpPr>
         <p:spPr>
           <a:xfrm>
-            <a:off x="6309360" y="2103120"/>
-            <a:ext cx="4937760" cy="365760"/>
+            <a:off x="6428232" y="1874520"/>
+            <a:ext cx="4800600" cy="365760"/>
           </a:xfrm>
           <a:prstGeom prst="rect">
             <a:avLst/>
@@ -2622,14 +2680,14 @@
               <a:buNone/>
             </a:pPr>
             <a:r>
-              <a:rPr lang="en-US" sz="1800" b="1" dirty="0">
+              <a:rPr lang="en-US" sz="1600" b="1" dirty="0">
                 <a:solidFill>
                   <a:srgbClr val="FEF3C7"/>
                 </a:solidFill>
               </a:rPr>
               <a:t>⏱️ Points &amp; Progressive Hints</a:t>
             </a:r>
-            <a:endParaRPr lang="en-US" sz="1800" dirty="0"/>
+            <a:endParaRPr lang="en-US" sz="1600" dirty="0"/>
           </a:p>
         </p:txBody>
       </p:sp>
@@ -2641,8 +2699,8 @@
         </p:nvSpPr>
         <p:spPr>
           <a:xfrm>
-            <a:off x="6309360" y="2560320"/>
-            <a:ext cx="4937760" cy="2651760"/>
+            <a:off x="6428232" y="2331720"/>
+            <a:ext cx="4800600" cy="3017520"/>
           </a:xfrm>
           <a:prstGeom prst="rect">
             <a:avLst/>
@@ -2661,7 +2719,7 @@
               <a:buNone/>
             </a:pPr>
             <a:r>
-              <a:rPr lang="en-US" sz="1200" b="1" dirty="0">
+              <a:rPr lang="en-US" sz="1150" b="1" dirty="0">
                 <a:solidFill>
                   <a:srgbClr val="E2E8F0"/>
                 </a:solidFill>
@@ -2675,12 +2733,12 @@
               <a:buNone/>
             </a:pPr>
             <a:r>
-              <a:rPr lang="en-US" sz="1200" dirty="0">
+              <a:rPr lang="en-US" sz="1150" dirty="0">
                 <a:solidFill>
                   <a:srgbClr val="94A3B8"/>
                 </a:solidFill>
               </a:rPr>
-              <a:t>Fastest solves earn maximum points (Legendary: 300 PTS, Swift: 250 PTS, Steady: 200 PTS).
+              <a:t>Faster team solves earn higher base points (Legendary $\rightarrow$ Swift $\rightarrow$ Steady).
 </a:t>
             </a:r>
             <a:pPr indent="0" marL="0">
@@ -2690,26 +2748,26 @@
               <a:buNone/>
             </a:pPr>
             <a:r>
-              <a:rPr lang="en-US" sz="1200" b="1" dirty="0">
+              <a:rPr lang="en-US" sz="1150" b="1" dirty="0">
                 <a:solidFill>
                   <a:srgbClr val="E2E8F0"/>
                 </a:solidFill>
               </a:rPr>
-              <a:t>• Anyone Can Submit: </a:t>
-            </a:r>
-            <a:pPr indent="0" marL="0">
-              <a:lnSpc>
-                <a:spcPct val="115000"/>
-              </a:lnSpc>
-              <a:buNone/>
-            </a:pPr>
-            <a:r>
-              <a:rPr lang="en-US" sz="1200" dirty="0">
+              <a:t>• Any Player Can Submit: </a:t>
+            </a:r>
+            <a:pPr indent="0" marL="0">
+              <a:lnSpc>
+                <a:spcPct val="115000"/>
+              </a:lnSpc>
+              <a:buNone/>
+            </a:pPr>
+            <a:r>
+              <a:rPr lang="en-US" sz="1150" dirty="0">
                 <a:solidFill>
                   <a:srgbClr val="94A3B8"/>
                 </a:solidFill>
               </a:rPr>
-              <a:t>Any player in the crew can type and submit the codeword once solved.
+              <a:t>Once solved, any teammate can type and submit the codeword on their screen.
 </a:t>
             </a:r>
             <a:pPr indent="0" marL="0">
@@ -2719,21 +2777,21 @@
               <a:buNone/>
             </a:pPr>
             <a:r>
-              <a:rPr lang="en-US" sz="1200" b="1" dirty="0">
+              <a:rPr lang="en-US" sz="1150" b="1" dirty="0">
                 <a:solidFill>
                   <a:srgbClr val="E2E8F0"/>
                 </a:solidFill>
               </a:rPr>
-              <a:t>• Stuck? Timed Hints: </a:t>
-            </a:r>
-            <a:pPr indent="0" marL="0">
-              <a:lnSpc>
-                <a:spcPct val="115000"/>
-              </a:lnSpc>
-              <a:buNone/>
-            </a:pPr>
-            <a:r>
-              <a:rPr lang="en-US" sz="1200" dirty="0">
+              <a:t>• Progressive Hints: </a:t>
+            </a:r>
+            <a:pPr indent="0" marL="0">
+              <a:lnSpc>
+                <a:spcPct val="115000"/>
+              </a:lnSpc>
+              <a:buNone/>
+            </a:pPr>
+            <a:r>
+              <a:rPr lang="en-US" sz="1150" dirty="0">
                 <a:solidFill>
                   <a:srgbClr val="94A3B8"/>
                 </a:solidFill>
@@ -2748,28 +2806,28 @@
               <a:buNone/>
             </a:pPr>
             <a:r>
-              <a:rPr lang="en-US" sz="1200" b="1" dirty="0">
+              <a:rPr lang="en-US" sz="1150" b="1" dirty="0">
                 <a:solidFill>
                   <a:srgbClr val="E2E8F0"/>
                 </a:solidFill>
               </a:rPr>
-              <a:t>• Guaranteed Safety Floor: </a:t>
-            </a:r>
-            <a:pPr indent="0" marL="0">
-              <a:lnSpc>
-                <a:spcPct val="115000"/>
-              </a:lnSpc>
-              <a:buNone/>
-            </a:pPr>
-            <a:r>
-              <a:rPr lang="en-US" sz="1200" dirty="0">
+              <a:t>• Safety Net: </a:t>
+            </a:r>
+            <a:pPr indent="0" marL="0">
+              <a:lnSpc>
+                <a:spcPct val="115000"/>
+              </a:lnSpc>
+              <a:buNone/>
+            </a:pPr>
+            <a:r>
+              <a:rPr lang="en-US" sz="1150" dirty="0">
                 <a:solidFill>
                   <a:srgbClr val="10B981"/>
                 </a:solidFill>
               </a:rPr>
-              <a:t>50 PTS minimum floor ensures every crew passes through the door.</a:t>
-            </a:r>
-            <a:endParaRPr lang="en-US" sz="1200" dirty="0"/>
+              <a:t>50 PTS guaranteed floor ensures every crew passes through the door.</a:t>
+            </a:r>
+            <a:endParaRPr lang="en-US" sz="1150" dirty="0"/>
           </a:p>
         </p:txBody>
       </p:sp>
@@ -2781,8 +2839,8 @@
         </p:nvSpPr>
         <p:spPr>
           <a:xfrm>
-            <a:off x="731520" y="5577840"/>
-            <a:ext cx="10698480" cy="640080"/>
+            <a:off x="731520" y="5760720"/>
+            <a:ext cx="10725912" cy="594360"/>
           </a:xfrm>
           <a:prstGeom prst="rect">
             <a:avLst/>
@@ -2806,8 +2864,8 @@
         </p:nvSpPr>
         <p:spPr>
           <a:xfrm>
-            <a:off x="914400" y="5715000"/>
-            <a:ext cx="10332720" cy="365760"/>
+            <a:off x="914400" y="5870448"/>
+            <a:ext cx="10360152" cy="365760"/>
           </a:xfrm>
           <a:prstGeom prst="rect">
             <a:avLst/>
@@ -2819,7 +2877,7 @@
           <a:bodyPr wrap="square" rtlCol="0" anchor="ctr"/>
           <a:lstStyle/>
           <a:p>
-            <a:pPr indent="0" marL="0">
+            <a:pPr algn="ctr" indent="0" marL="0">
               <a:buNone/>
             </a:pPr>
             <a:r>
@@ -2874,8 +2932,8 @@
         </p:nvSpPr>
         <p:spPr>
           <a:xfrm>
-            <a:off x="731520" y="457200"/>
-            <a:ext cx="7315200" cy="365760"/>
+            <a:off x="731520" y="411480"/>
+            <a:ext cx="7315200" cy="274320"/>
           </a:xfrm>
           <a:prstGeom prst="rect">
             <a:avLst/>
@@ -2891,14 +2949,14 @@
               <a:buNone/>
             </a:pPr>
             <a:r>
-              <a:rPr lang="en-US" sz="1100" b="1" spc="200" kern="0" dirty="0">
+              <a:rPr lang="en-US" sz="1000" b="1" spc="200" kern="0" dirty="0">
                 <a:solidFill>
                   <a:srgbClr val="F43F5E"/>
                 </a:solidFill>
               </a:rPr>
               <a:t>ROUND 2 • SOCIAL DILEMMA &amp; BLUFFING</a:t>
             </a:r>
-            <a:endParaRPr lang="en-US" sz="1100" dirty="0"/>
+            <a:endParaRPr lang="en-US" sz="1000" dirty="0"/>
           </a:p>
         </p:txBody>
       </p:sp>
@@ -2910,8 +2968,8 @@
         </p:nvSpPr>
         <p:spPr>
           <a:xfrm>
-            <a:off x="731520" y="731520"/>
-            <a:ext cx="10058400" cy="731520"/>
+            <a:off x="731520" y="685800"/>
+            <a:ext cx="10698480" cy="548640"/>
           </a:xfrm>
           <a:prstGeom prst="rect">
             <a:avLst/>
@@ -2927,14 +2985,14 @@
               <a:buNone/>
             </a:pPr>
             <a:r>
-              <a:rPr lang="en-US" sz="3200" b="1" dirty="0">
+              <a:rPr lang="en-US" sz="2600" b="1" dirty="0">
                 <a:solidFill>
                   <a:srgbClr val="FEF3C7"/>
                 </a:solidFill>
               </a:rPr>
               <a:t>SHADES IN THE MIST</a:t>
             </a:r>
-            <a:endParaRPr lang="en-US" sz="3200" dirty="0"/>
+            <a:endParaRPr lang="en-US" sz="2600" dirty="0"/>
           </a:p>
         </p:txBody>
       </p:sp>
@@ -2946,8 +3004,8 @@
         </p:nvSpPr>
         <p:spPr>
           <a:xfrm>
-            <a:off x="731520" y="1371600"/>
-            <a:ext cx="9144000" cy="365760"/>
+            <a:off x="731520" y="1234440"/>
+            <a:ext cx="10698480" cy="320040"/>
           </a:xfrm>
           <a:prstGeom prst="rect">
             <a:avLst/>
@@ -2963,14 +3021,14 @@
               <a:buNone/>
             </a:pPr>
             <a:r>
-              <a:rPr lang="en-US" sz="1400" dirty="0">
+              <a:rPr lang="en-US" sz="1200" dirty="0">
                 <a:solidFill>
                   <a:srgbClr val="94A3B8"/>
                 </a:solidFill>
               </a:rPr>
-              <a:t>3 Clashes vs Rival Table • Face-to-Face Negotiation</a:t>
-            </a:r>
-            <a:endParaRPr lang="en-US" sz="1400" dirty="0"/>
+              <a:t>3 Clashes vs Rival Table • Face-to-Face Negotiation • Bluffing Allowed</a:t>
+            </a:r>
+            <a:endParaRPr lang="en-US" sz="1200" dirty="0"/>
           </a:p>
         </p:txBody>
       </p:sp>
@@ -2982,16 +3040,16 @@
         </p:nvSpPr>
         <p:spPr>
           <a:xfrm>
-            <a:off x="731520" y="1920240"/>
-            <a:ext cx="5120640" cy="4206240"/>
+            <a:off x="731520" y="1691640"/>
+            <a:ext cx="5257800" cy="3886200"/>
           </a:xfrm>
           <a:prstGeom prst="roundRect">
             <a:avLst>
-              <a:gd name="adj" fmla="val 2174"/>
+              <a:gd name="adj" fmla="val 1882"/>
             </a:avLst>
           </a:prstGeom>
           <a:solidFill>
-            <a:srgbClr val="151B2E"/>
+            <a:srgbClr val="141A2A"/>
           </a:solidFill>
           <a:ln w="19050">
             <a:solidFill>
@@ -3009,8 +3067,8 @@
         </p:nvSpPr>
         <p:spPr>
           <a:xfrm>
-            <a:off x="914400" y="2103120"/>
-            <a:ext cx="4754880" cy="365760"/>
+            <a:off x="960120" y="1874520"/>
+            <a:ext cx="4800600" cy="365760"/>
           </a:xfrm>
           <a:prstGeom prst="rect">
             <a:avLst/>
@@ -3026,14 +3084,14 @@
               <a:buNone/>
             </a:pPr>
             <a:r>
-              <a:rPr lang="en-US" sz="1800" b="1" dirty="0">
+              <a:rPr lang="en-US" sz="1600" b="1" dirty="0">
                 <a:solidFill>
                   <a:srgbClr val="FEF3C7"/>
                 </a:solidFill>
               </a:rPr>
               <a:t>⚔️ How Each Clash Runs</a:t>
             </a:r>
-            <a:endParaRPr lang="en-US" sz="1800" dirty="0"/>
+            <a:endParaRPr lang="en-US" sz="1600" dirty="0"/>
           </a:p>
         </p:txBody>
       </p:sp>
@@ -3045,8 +3103,8 @@
         </p:nvSpPr>
         <p:spPr>
           <a:xfrm>
-            <a:off x="914400" y="2560320"/>
-            <a:ext cx="4754880" cy="3383280"/>
+            <a:off x="960120" y="2331720"/>
+            <a:ext cx="4800600" cy="3017520"/>
           </a:xfrm>
           <a:prstGeom prst="rect">
             <a:avLst/>
@@ -3070,7 +3128,7 @@
                   <a:srgbClr val="94A3B8"/>
                 </a:solidFill>
               </a:rPr>
-              <a:t>Your crew faces an opposing table across 3 escalating clashes:
+              <a:t>Your crew faces a rival table across 3 escalating clashes:
 </a:t>
             </a:r>
             <a:pPr indent="0" marL="0">
@@ -3128,7 +3186,7 @@
                   <a:srgbClr val="94A3B8"/>
                 </a:solidFill>
               </a:rPr>
-              <a:t>Turn to the rival table. Look them in the eyes and negotiate your pact across the room. (Bluffing is 100% permitted!).
+              <a:t>Turn to rival table. Look them in the eyes and negotiate across the room. (Bluffing is 100% permitted!).
 </a:t>
             </a:r>
             <a:pPr indent="0" marL="0">
@@ -3157,7 +3215,7 @@
                   <a:srgbClr val="94A3B8"/>
                 </a:solidFill>
               </a:rPr>
-              <a:t>Every player secretly votes on their phone. Majority rules (Negotiator breaks 2-2 ties).
+              <a:t>Every player secretly votes on phone. Majority rules (Negotiator breaks ties).
 </a:t>
             </a:r>
             <a:pPr indent="0" marL="0">
@@ -3186,7 +3244,7 @@
                   <a:srgbClr val="F59E0B"/>
                 </a:solidFill>
               </a:rPr>
-              <a:t>Both tables' decisions are unmasked simultaneously on screen!</a:t>
+              <a:t>Both tables' choices unmask simultaneously on screen!</a:t>
             </a:r>
             <a:endParaRPr lang="en-US" sz="1100" dirty="0"/>
           </a:p>
@@ -3200,16 +3258,16 @@
         </p:nvSpPr>
         <p:spPr>
           <a:xfrm>
-            <a:off x="6126480" y="1920240"/>
-            <a:ext cx="5303520" cy="4206240"/>
+            <a:off x="6199632" y="1691640"/>
+            <a:ext cx="5257800" cy="3886200"/>
           </a:xfrm>
           <a:prstGeom prst="roundRect">
             <a:avLst>
-              <a:gd name="adj" fmla="val 2174"/>
+              <a:gd name="adj" fmla="val 1882"/>
             </a:avLst>
           </a:prstGeom>
           <a:solidFill>
-            <a:srgbClr val="151B2E"/>
+            <a:srgbClr val="141A2A"/>
           </a:solidFill>
           <a:ln w="12700">
             <a:solidFill>
@@ -3227,8 +3285,8 @@
         </p:nvSpPr>
         <p:spPr>
           <a:xfrm>
-            <a:off x="6309360" y="2103120"/>
-            <a:ext cx="4937760" cy="365760"/>
+            <a:off x="6428232" y="1874520"/>
+            <a:ext cx="4800600" cy="365760"/>
           </a:xfrm>
           <a:prstGeom prst="rect">
             <a:avLst/>
@@ -3244,14 +3302,14 @@
               <a:buNone/>
             </a:pPr>
             <a:r>
-              <a:rPr lang="en-US" sz="1800" b="1" dirty="0">
+              <a:rPr lang="en-US" sz="1600" b="1" dirty="0">
                 <a:solidFill>
                   <a:srgbClr val="FEF3C7"/>
                 </a:solidFill>
               </a:rPr>
               <a:t>⚖️ The Stances &amp; Moral Legacy</a:t>
             </a:r>
-            <a:endParaRPr lang="en-US" sz="1800" dirty="0"/>
+            <a:endParaRPr lang="en-US" sz="1600" dirty="0"/>
           </a:p>
         </p:txBody>
       </p:sp>
@@ -3263,8 +3321,8 @@
         </p:nvSpPr>
         <p:spPr>
           <a:xfrm>
-            <a:off x="6309360" y="2560320"/>
-            <a:ext cx="4937760" cy="3383280"/>
+            <a:off x="6428232" y="2331720"/>
+            <a:ext cx="4800600" cy="3017520"/>
           </a:xfrm>
           <a:prstGeom prst="rect">
             <a:avLst/>
@@ -3303,7 +3361,21 @@
                   <a:srgbClr val="10B981"/>
                 </a:solidFill>
               </a:rPr>
-              <a:t>🤝 Mutual Truce (Truce vs Truce):
+              <a:t>🤝 Mutual Truce: </a:t>
+            </a:r>
+            <a:pPr indent="0" marL="0">
+              <a:lnSpc>
+                <a:spcPct val="115000"/>
+              </a:lnSpc>
+              <a:buNone/>
+            </a:pPr>
+            <a:r>
+              <a:rPr lang="en-US" sz="1100" dirty="0">
+                <a:solidFill>
+                  <a:srgbClr val="94A3B8"/>
+                </a:solidFill>
+              </a:rPr>
+              <a:t>Both crews play peaceful $\rightarrow$ Both win solid, steady points.
 </a:t>
             </a:r>
             <a:pPr indent="0" marL="0">
@@ -3313,12 +3385,26 @@
               <a:buNone/>
             </a:pPr>
             <a:r>
+              <a:rPr lang="en-US" sz="1100" b="1" dirty="0">
+                <a:solidFill>
+                  <a:srgbClr val="F43F5E"/>
+                </a:solidFill>
+              </a:rPr>
+              <a:t>🗡️ The Backstab: </a:t>
+            </a:r>
+            <a:pPr indent="0" marL="0">
+              <a:lnSpc>
+                <a:spcPct val="115000"/>
+              </a:lnSpc>
+              <a:buNone/>
+            </a:pPr>
+            <a:r>
               <a:rPr lang="en-US" sz="1100" dirty="0">
                 <a:solidFill>
                   <a:srgbClr val="94A3B8"/>
                 </a:solidFill>
               </a:rPr>
-              <a:t>Both teams play honorably $\rightarrow$ Both win solid, safe points.
+              <a:t>Ambush beats Truce $\rightarrow$ Betrayer steals massive points; victim gets 0!
 </a:t>
             </a:r>
             <a:pPr indent="0" marL="0">
@@ -3330,11 +3416,10 @@
             <a:r>
               <a:rPr lang="en-US" sz="1100" b="1" dirty="0">
                 <a:solidFill>
-                  <a:srgbClr val="F43F5E"/>
-                </a:solidFill>
-              </a:rPr>
-              <a:t>🗡️ The Backstab (Ambush vs Truce):
-</a:t>
+                  <a:srgbClr val="F59E0B"/>
+                </a:solidFill>
+              </a:rPr>
+              <a:t>💥 Mutual Brawl: </a:t>
             </a:r>
             <a:pPr indent="0" marL="0">
               <a:lnSpc>
@@ -3348,37 +3433,7 @@
                   <a:srgbClr val="94A3B8"/>
                 </a:solidFill>
               </a:rPr>
-              <a:t>The betrayer steals massive points; the peaceful victim gets 0!
-</a:t>
-            </a:r>
-            <a:pPr indent="0" marL="0">
-              <a:lnSpc>
-                <a:spcPct val="115000"/>
-              </a:lnSpc>
-              <a:buNone/>
-            </a:pPr>
-            <a:r>
-              <a:rPr lang="en-US" sz="1100" b="1" dirty="0">
-                <a:solidFill>
-                  <a:srgbClr val="000000"/>
-                </a:solidFill>
-              </a:rPr>
-              <a:t>💥 Mutual Brawl (Ambush vs Ambush):
-</a:t>
-            </a:r>
-            <a:pPr indent="0" marL="0">
-              <a:lnSpc>
-                <a:spcPct val="115000"/>
-              </a:lnSpc>
-              <a:buNone/>
-            </a:pPr>
-            <a:r>
-              <a:rPr lang="en-US" sz="1100" dirty="0">
-                <a:solidFill>
-                  <a:srgbClr val="94A3B8"/>
-                </a:solidFill>
-              </a:rPr>
-              <a:t>Both tables try to backstab $\rightarrow$ Both walk away with crumbs.
+              <a:t>Both crews attack $\rightarrow$ Both walk away with scraps.
 </a:t>
             </a:r>
             <a:pPr indent="0" marL="0">
@@ -3426,6 +3481,67 @@
                 </a:solidFill>
               </a:rPr>
               <a:t>• Betrayed: Crew gets a Cerberus revenge token to strike their nemesis!</a:t>
+            </a:r>
+            <a:endParaRPr lang="en-US" sz="1100" dirty="0"/>
+          </a:p>
+        </p:txBody>
+      </p:sp>
+      <p:sp>
+        <p:nvSpPr>
+          <p:cNvPr id="11" name="Shape 9"/>
+          <p:cNvSpPr/>
+          <p:nvPr/>
+        </p:nvSpPr>
+        <p:spPr>
+          <a:xfrm>
+            <a:off x="731520" y="5760720"/>
+            <a:ext cx="10725912" cy="594360"/>
+          </a:xfrm>
+          <a:prstGeom prst="rect">
+            <a:avLst/>
+          </a:prstGeom>
+          <a:solidFill>
+            <a:srgbClr val="1E293B"/>
+          </a:solidFill>
+          <a:ln w="12700">
+            <a:solidFill>
+              <a:srgbClr val="F43F5E"/>
+            </a:solidFill>
+            <a:prstDash val="solid"/>
+          </a:ln>
+        </p:spPr>
+      </p:sp>
+      <p:sp>
+        <p:nvSpPr>
+          <p:cNvPr id="12" name="Text 10"/>
+          <p:cNvSpPr/>
+          <p:nvPr/>
+        </p:nvSpPr>
+        <p:spPr>
+          <a:xfrm>
+            <a:off x="914400" y="5870448"/>
+            <a:ext cx="10360152" cy="365760"/>
+          </a:xfrm>
+          <a:prstGeom prst="rect">
+            <a:avLst/>
+          </a:prstGeom>
+          <a:noFill/>
+          <a:ln/>
+        </p:spPr>
+        <p:txBody>
+          <a:bodyPr wrap="square" rtlCol="0" anchor="ctr"/>
+          <a:lstStyle/>
+          <a:p>
+            <a:pPr algn="ctr" indent="0" marL="0">
+              <a:buNone/>
+            </a:pPr>
+            <a:r>
+              <a:rPr lang="en-US" sz="1100" b="1" dirty="0">
+                <a:solidFill>
+                  <a:srgbClr val="FEF3C7"/>
+                </a:solidFill>
+              </a:rPr>
+              <a:t>💡 Facilitator Cue: "Promises made across the room are not binding. Will you build trust, or cash in on a brutal backstab?"</a:t>
             </a:r>
             <a:endParaRPr lang="en-US" sz="1100" dirty="0"/>
           </a:p>
@@ -3471,8 +3587,8 @@
         </p:nvSpPr>
         <p:spPr>
           <a:xfrm>
-            <a:off x="731520" y="457200"/>
-            <a:ext cx="7315200" cy="365760"/>
+            <a:off x="731520" y="411480"/>
+            <a:ext cx="7315200" cy="274320"/>
           </a:xfrm>
           <a:prstGeom prst="rect">
             <a:avLst/>
@@ -3488,14 +3604,14 @@
               <a:buNone/>
             </a:pPr>
             <a:r>
-              <a:rPr lang="en-US" sz="1100" b="1" spc="200" kern="0" dirty="0">
-                <a:solidFill>
-                  <a:srgbClr val="F59E0B"/>
+              <a:rPr lang="en-US" sz="1000" b="1" spc="200" kern="0" dirty="0">
+                <a:solidFill>
+                  <a:srgbClr val="A855F7"/>
                 </a:solidFill>
               </a:rPr>
               <a:t>ROUND 3 • THE CLIMAX &amp; ESCAPE ROYALE</a:t>
             </a:r>
-            <a:endParaRPr lang="en-US" sz="1100" dirty="0"/>
+            <a:endParaRPr lang="en-US" sz="1000" dirty="0"/>
           </a:p>
         </p:txBody>
       </p:sp>
@@ -3507,8 +3623,8 @@
         </p:nvSpPr>
         <p:spPr>
           <a:xfrm>
-            <a:off x="731520" y="731520"/>
-            <a:ext cx="10058400" cy="731520"/>
+            <a:off x="731520" y="685800"/>
+            <a:ext cx="10698480" cy="548640"/>
           </a:xfrm>
           <a:prstGeom prst="rect">
             <a:avLst/>
@@ -3524,14 +3640,14 @@
               <a:buNone/>
             </a:pPr>
             <a:r>
-              <a:rPr lang="en-US" sz="3200" b="1" dirty="0">
+              <a:rPr lang="en-US" sz="2600" b="1" dirty="0">
                 <a:solidFill>
                   <a:srgbClr val="FEF3C7"/>
                 </a:solidFill>
               </a:rPr>
               <a:t>ESCAPE FROM TARTARUS</a:t>
             </a:r>
-            <a:endParaRPr lang="en-US" sz="3200" dirty="0"/>
+            <a:endParaRPr lang="en-US" sz="2600" dirty="0"/>
           </a:p>
         </p:txBody>
       </p:sp>
@@ -3543,8 +3659,8 @@
         </p:nvSpPr>
         <p:spPr>
           <a:xfrm>
-            <a:off x="731520" y="1371600"/>
-            <a:ext cx="9144000" cy="365760"/>
+            <a:off x="731520" y="1234440"/>
+            <a:ext cx="10698480" cy="320040"/>
           </a:xfrm>
           <a:prstGeom prst="rect">
             <a:avLst/>
@@ -3560,14 +3676,14 @@
               <a:buNone/>
             </a:pPr>
             <a:r>
-              <a:rPr lang="en-US" sz="1400" dirty="0">
+              <a:rPr lang="en-US" sz="1200" dirty="0">
                 <a:solidFill>
                   <a:srgbClr val="94A3B8"/>
                 </a:solidFill>
               </a:rPr>
-              <a:t>River Styx Congestion Race • 1,000m to the Portal</a:t>
-            </a:r>
-            <a:endParaRPr lang="en-US" sz="1400" dirty="0"/>
+              <a:t>River Styx Congestion Race • 1,000m to the Exit Portal</a:t>
+            </a:r>
+            <a:endParaRPr lang="en-US" sz="1200" dirty="0"/>
           </a:p>
         </p:txBody>
       </p:sp>
@@ -3579,16 +3695,16 @@
         </p:nvSpPr>
         <p:spPr>
           <a:xfrm>
-            <a:off x="731520" y="1920240"/>
-            <a:ext cx="3337560" cy="2377440"/>
+            <a:off x="731520" y="1691640"/>
+            <a:ext cx="3374136" cy="2148840"/>
           </a:xfrm>
           <a:prstGeom prst="roundRect">
             <a:avLst>
-              <a:gd name="adj" fmla="val 3846"/>
+              <a:gd name="adj" fmla="val 3404"/>
             </a:avLst>
           </a:prstGeom>
           <a:solidFill>
-            <a:srgbClr val="151B2E"/>
+            <a:srgbClr val="141A2A"/>
           </a:solidFill>
           <a:ln w="19050">
             <a:solidFill>
@@ -3606,8 +3722,8 @@
         </p:nvSpPr>
         <p:spPr>
           <a:xfrm>
-            <a:off x="868680" y="2057400"/>
-            <a:ext cx="3063240" cy="320040"/>
+            <a:off x="868680" y="1783080"/>
+            <a:ext cx="3099816" cy="320040"/>
           </a:xfrm>
           <a:prstGeom prst="rect">
             <a:avLst/>
@@ -3623,14 +3739,14 @@
               <a:buNone/>
             </a:pPr>
             <a:r>
-              <a:rPr lang="en-US" sz="1600" b="1" dirty="0">
+              <a:rPr lang="en-US" sz="1500" b="1" dirty="0">
                 <a:solidFill>
                   <a:srgbClr val="10B981"/>
                 </a:solidFill>
               </a:rPr>
               <a:t>🚣 The Rowboat</a:t>
             </a:r>
-            <a:endParaRPr lang="en-US" sz="1600" dirty="0"/>
+            <a:endParaRPr lang="en-US" sz="1500" dirty="0"/>
           </a:p>
         </p:txBody>
       </p:sp>
@@ -3642,8 +3758,8 @@
         </p:nvSpPr>
         <p:spPr>
           <a:xfrm>
-            <a:off x="868680" y="2377440"/>
-            <a:ext cx="3063240" cy="228600"/>
+            <a:off x="868680" y="2103120"/>
+            <a:ext cx="3099816" cy="182880"/>
           </a:xfrm>
           <a:prstGeom prst="rect">
             <a:avLst/>
@@ -3659,14 +3775,14 @@
               <a:buNone/>
             </a:pPr>
             <a:r>
-              <a:rPr lang="en-US" sz="900" b="1" dirty="0">
+              <a:rPr lang="en-US" sz="850" b="1" dirty="0">
                 <a:solidFill>
                   <a:srgbClr val="94A3B8"/>
                 </a:solidFill>
               </a:rPr>
               <a:t>SAFE &amp; STEADY</a:t>
             </a:r>
-            <a:endParaRPr lang="en-US" sz="900" dirty="0"/>
+            <a:endParaRPr lang="en-US" sz="850" dirty="0"/>
           </a:p>
         </p:txBody>
       </p:sp>
@@ -3678,8 +3794,8 @@
         </p:nvSpPr>
         <p:spPr>
           <a:xfrm>
-            <a:off x="868680" y="2651760"/>
-            <a:ext cx="3063240" cy="1463040"/>
+            <a:off x="868680" y="2331720"/>
+            <a:ext cx="3099816" cy="1371600"/>
           </a:xfrm>
           <a:prstGeom prst="rect">
             <a:avLst/>
@@ -3698,7 +3814,7 @@
               <a:buNone/>
             </a:pPr>
             <a:r>
-              <a:rPr lang="en-US" sz="1000" b="1" dirty="0">
+              <a:rPr lang="en-US" sz="950" b="1" dirty="0">
                 <a:solidFill>
                   <a:srgbClr val="E2E8F0"/>
                 </a:solidFill>
@@ -3713,21 +3829,21 @@
               <a:buNone/>
             </a:pPr>
             <a:r>
-              <a:rPr lang="en-US" sz="1000" b="1" dirty="0">
+              <a:rPr lang="en-US" sz="950" b="1" dirty="0">
                 <a:solidFill>
                   <a:srgbClr val="E2E8F0"/>
                 </a:solidFill>
               </a:rPr>
-              <a:t>• Outcome: </a:t>
-            </a:r>
-            <a:pPr indent="0" marL="0">
-              <a:lnSpc>
-                <a:spcPct val="115000"/>
-              </a:lnSpc>
-              <a:buNone/>
-            </a:pPr>
-            <a:r>
-              <a:rPr lang="en-US" sz="1000" b="1" dirty="0">
+              <a:t>• Advance: </a:t>
+            </a:r>
+            <a:pPr indent="0" marL="0">
+              <a:lnSpc>
+                <a:spcPct val="115000"/>
+              </a:lnSpc>
+              <a:buNone/>
+            </a:pPr>
+            <a:r>
+              <a:rPr lang="en-US" sz="950" b="1" dirty="0">
                 <a:solidFill>
                   <a:srgbClr val="10B981"/>
                 </a:solidFill>
@@ -3742,14 +3858,14 @@
               <a:buNone/>
             </a:pPr>
             <a:r>
-              <a:rPr lang="en-US" sz="1000" dirty="0">
+              <a:rPr lang="en-US" sz="950" dirty="0">
                 <a:solidFill>
                   <a:srgbClr val="94A3B8"/>
                 </a:solidFill>
               </a:rPr>
-              <a:t>Never capsizes. Reliable progress while rival crews greedily crash.</a:t>
-            </a:r>
-            <a:endParaRPr lang="en-US" sz="1000" dirty="0"/>
+              <a:t>Never capsizes. Reliable steady progress while rivals greedily crash.</a:t>
+            </a:r>
+            <a:endParaRPr lang="en-US" sz="950" dirty="0"/>
           </a:p>
         </p:txBody>
       </p:sp>
@@ -3761,16 +3877,16 @@
         </p:nvSpPr>
         <p:spPr>
           <a:xfrm>
-            <a:off x="4251960" y="1920240"/>
-            <a:ext cx="3337560" cy="2377440"/>
+            <a:off x="4407408" y="1691640"/>
+            <a:ext cx="3374136" cy="2148840"/>
           </a:xfrm>
           <a:prstGeom prst="roundRect">
             <a:avLst>
-              <a:gd name="adj" fmla="val 3846"/>
+              <a:gd name="adj" fmla="val 3404"/>
             </a:avLst>
           </a:prstGeom>
           <a:solidFill>
-            <a:srgbClr val="151B2E"/>
+            <a:srgbClr val="141A2A"/>
           </a:solidFill>
           <a:ln w="19050">
             <a:solidFill>
@@ -3788,8 +3904,8 @@
         </p:nvSpPr>
         <p:spPr>
           <a:xfrm>
-            <a:off x="4389120" y="2057400"/>
-            <a:ext cx="3063240" cy="320040"/>
+            <a:off x="4544568" y="1783080"/>
+            <a:ext cx="3099816" cy="320040"/>
           </a:xfrm>
           <a:prstGeom prst="rect">
             <a:avLst/>
@@ -3805,14 +3921,14 @@
               <a:buNone/>
             </a:pPr>
             <a:r>
-              <a:rPr lang="en-US" sz="1600" b="1" dirty="0">
+              <a:rPr lang="en-US" sz="1500" b="1" dirty="0">
                 <a:solidFill>
                   <a:srgbClr val="F59E0B"/>
                 </a:solidFill>
               </a:rPr>
               <a:t>⛵ The Sailboat</a:t>
             </a:r>
-            <a:endParaRPr lang="en-US" sz="1600" dirty="0"/>
+            <a:endParaRPr lang="en-US" sz="1500" dirty="0"/>
           </a:p>
         </p:txBody>
       </p:sp>
@@ -3824,8 +3940,8 @@
         </p:nvSpPr>
         <p:spPr>
           <a:xfrm>
-            <a:off x="4389120" y="2377440"/>
-            <a:ext cx="3063240" cy="228600"/>
+            <a:off x="4544568" y="2103120"/>
+            <a:ext cx="3099816" cy="182880"/>
           </a:xfrm>
           <a:prstGeom prst="rect">
             <a:avLst/>
@@ -3841,14 +3957,14 @@
               <a:buNone/>
             </a:pPr>
             <a:r>
-              <a:rPr lang="en-US" sz="900" b="1" dirty="0">
+              <a:rPr lang="en-US" sz="850" b="1" dirty="0">
                 <a:solidFill>
                   <a:srgbClr val="94A3B8"/>
                 </a:solidFill>
               </a:rPr>
               <a:t>SPEED VS CROWDS</a:t>
             </a:r>
-            <a:endParaRPr lang="en-US" sz="900" dirty="0"/>
+            <a:endParaRPr lang="en-US" sz="850" dirty="0"/>
           </a:p>
         </p:txBody>
       </p:sp>
@@ -3860,8 +3976,8 @@
         </p:nvSpPr>
         <p:spPr>
           <a:xfrm>
-            <a:off x="4389120" y="2651760"/>
-            <a:ext cx="3063240" cy="1463040"/>
+            <a:off x="4544568" y="2331720"/>
+            <a:ext cx="3099816" cy="1371600"/>
           </a:xfrm>
           <a:prstGeom prst="rect">
             <a:avLst/>
@@ -3880,7 +3996,7 @@
               <a:buNone/>
             </a:pPr>
             <a:r>
-              <a:rPr lang="en-US" sz="1000" b="1" dirty="0">
+              <a:rPr lang="en-US" sz="950" b="1" dirty="0">
                 <a:solidFill>
                   <a:srgbClr val="E2E8F0"/>
                 </a:solidFill>
@@ -3895,21 +4011,21 @@
               <a:buNone/>
             </a:pPr>
             <a:r>
-              <a:rPr lang="en-US" sz="1000" b="1" dirty="0">
+              <a:rPr lang="en-US" sz="950" b="1" dirty="0">
                 <a:solidFill>
                   <a:srgbClr val="E2E8F0"/>
                 </a:solidFill>
               </a:rPr>
-              <a:t>• Outcome: </a:t>
-            </a:r>
-            <a:pPr indent="0" marL="0">
-              <a:lnSpc>
-                <a:spcPct val="115000"/>
-              </a:lnSpc>
-              <a:buNone/>
-            </a:pPr>
-            <a:r>
-              <a:rPr lang="en-US" sz="1000" b="1" dirty="0">
+              <a:t>• Advance: </a:t>
+            </a:r>
+            <a:pPr indent="0" marL="0">
+              <a:lnSpc>
+                <a:spcPct val="115000"/>
+              </a:lnSpc>
+              <a:buNone/>
+            </a:pPr>
+            <a:r>
+              <a:rPr lang="en-US" sz="950" b="1" dirty="0">
                 <a:solidFill>
                   <a:srgbClr val="F59E0B"/>
                 </a:solidFill>
@@ -3924,14 +4040,14 @@
               <a:buNone/>
             </a:pPr>
             <a:r>
-              <a:rPr lang="en-US" sz="1000" dirty="0">
+              <a:rPr lang="en-US" sz="950" dirty="0">
                 <a:solidFill>
                   <a:srgbClr val="94A3B8"/>
                 </a:solidFill>
               </a:rPr>
-              <a:t>Fast surge! But if too many crews board, the vessel capsizes.</a:t>
-            </a:r>
-            <a:endParaRPr lang="en-US" sz="1000" dirty="0"/>
+              <a:t>Fast surge! But if too many crews board, the vessel capsizes into the river.</a:t>
+            </a:r>
+            <a:endParaRPr lang="en-US" sz="950" dirty="0"/>
           </a:p>
         </p:txBody>
       </p:sp>
@@ -3943,16 +4059,16 @@
         </p:nvSpPr>
         <p:spPr>
           <a:xfrm>
-            <a:off x="7772400" y="1920240"/>
-            <a:ext cx="3337560" cy="2377440"/>
+            <a:off x="8083296" y="1691640"/>
+            <a:ext cx="3374136" cy="2148840"/>
           </a:xfrm>
           <a:prstGeom prst="roundRect">
             <a:avLst>
-              <a:gd name="adj" fmla="val 3846"/>
+              <a:gd name="adj" fmla="val 3404"/>
             </a:avLst>
           </a:prstGeom>
           <a:solidFill>
-            <a:srgbClr val="151B2E"/>
+            <a:srgbClr val="141A2A"/>
           </a:solidFill>
           <a:ln w="19050">
             <a:solidFill>
@@ -3970,8 +4086,8 @@
         </p:nvSpPr>
         <p:spPr>
           <a:xfrm>
-            <a:off x="7909560" y="2057400"/>
-            <a:ext cx="3063240" cy="320040"/>
+            <a:off x="8220456" y="1783080"/>
+            <a:ext cx="3099816" cy="320040"/>
           </a:xfrm>
           <a:prstGeom prst="rect">
             <a:avLst/>
@@ -3987,14 +4103,14 @@
               <a:buNone/>
             </a:pPr>
             <a:r>
-              <a:rPr lang="en-US" sz="1600" b="1" dirty="0">
+              <a:rPr lang="en-US" sz="1500" b="1" dirty="0">
                 <a:solidFill>
                   <a:srgbClr val="A855F7"/>
                 </a:solidFill>
               </a:rPr>
               <a:t>⚡ The Ghost Ship</a:t>
             </a:r>
-            <a:endParaRPr lang="en-US" sz="1600" dirty="0"/>
+            <a:endParaRPr lang="en-US" sz="1500" dirty="0"/>
           </a:p>
         </p:txBody>
       </p:sp>
@@ -4006,8 +4122,8 @@
         </p:nvSpPr>
         <p:spPr>
           <a:xfrm>
-            <a:off x="7909560" y="2377440"/>
-            <a:ext cx="3063240" cy="228600"/>
+            <a:off x="8220456" y="2103120"/>
+            <a:ext cx="3099816" cy="182880"/>
           </a:xfrm>
           <a:prstGeom prst="rect">
             <a:avLst/>
@@ -4023,14 +4139,14 @@
               <a:buNone/>
             </a:pPr>
             <a:r>
-              <a:rPr lang="en-US" sz="900" b="1" dirty="0">
+              <a:rPr lang="en-US" sz="850" b="1" dirty="0">
                 <a:solidFill>
                   <a:srgbClr val="94A3B8"/>
                 </a:solidFill>
               </a:rPr>
               <a:t>SOLO GAMBLE</a:t>
             </a:r>
-            <a:endParaRPr lang="en-US" sz="900" dirty="0"/>
+            <a:endParaRPr lang="en-US" sz="850" dirty="0"/>
           </a:p>
         </p:txBody>
       </p:sp>
@@ -4042,8 +4158,8 @@
         </p:nvSpPr>
         <p:spPr>
           <a:xfrm>
-            <a:off x="7909560" y="2651760"/>
-            <a:ext cx="3063240" cy="1463040"/>
+            <a:off x="8220456" y="2331720"/>
+            <a:ext cx="3099816" cy="1371600"/>
           </a:xfrm>
           <a:prstGeom prst="rect">
             <a:avLst/>
@@ -4062,7 +4178,7 @@
               <a:buNone/>
             </a:pPr>
             <a:r>
-              <a:rPr lang="en-US" sz="1000" b="1" dirty="0">
+              <a:rPr lang="en-US" sz="950" b="1" dirty="0">
                 <a:solidFill>
                   <a:srgbClr val="E2E8F0"/>
                 </a:solidFill>
@@ -4077,21 +4193,21 @@
               <a:buNone/>
             </a:pPr>
             <a:r>
-              <a:rPr lang="en-US" sz="1000" b="1" dirty="0">
+              <a:rPr lang="en-US" sz="950" b="1" dirty="0">
                 <a:solidFill>
                   <a:srgbClr val="E2E8F0"/>
                 </a:solidFill>
               </a:rPr>
-              <a:t>• Outcome: </a:t>
-            </a:r>
-            <a:pPr indent="0" marL="0">
-              <a:lnSpc>
-                <a:spcPct val="115000"/>
-              </a:lnSpc>
-              <a:buNone/>
-            </a:pPr>
-            <a:r>
-              <a:rPr lang="en-US" sz="1000" b="1" dirty="0">
+              <a:t>• Advance: </a:t>
+            </a:r>
+            <a:pPr indent="0" marL="0">
+              <a:lnSpc>
+                <a:spcPct val="115000"/>
+              </a:lnSpc>
+              <a:buNone/>
+            </a:pPr>
+            <a:r>
+              <a:rPr lang="en-US" sz="950" b="1" dirty="0">
                 <a:solidFill>
                   <a:srgbClr val="A855F7"/>
                 </a:solidFill>
@@ -4106,14 +4222,14 @@
               <a:buNone/>
             </a:pPr>
             <a:r>
-              <a:rPr lang="en-US" sz="1000" dirty="0">
+              <a:rPr lang="en-US" sz="950" dirty="0">
                 <a:solidFill>
                   <a:srgbClr val="94A3B8"/>
                 </a:solidFill>
               </a:rPr>
-              <a:t>Mythic leap! But if 2 or more crews choose it, they collide (-50m).</a:t>
-            </a:r>
-            <a:endParaRPr lang="en-US" sz="1000" dirty="0"/>
+              <a:t>Mythic leap! But if 2 or more crews choose it, they collide (-50m penalty).</a:t>
+            </a:r>
+            <a:endParaRPr lang="en-US" sz="950" dirty="0"/>
           </a:p>
         </p:txBody>
       </p:sp>
@@ -4125,16 +4241,16 @@
         </p:nvSpPr>
         <p:spPr>
           <a:xfrm>
-            <a:off x="731520" y="4480560"/>
-            <a:ext cx="5120640" cy="1737360"/>
+            <a:off x="731520" y="4023360"/>
+            <a:ext cx="5257800" cy="2286000"/>
           </a:xfrm>
           <a:prstGeom prst="roundRect">
             <a:avLst>
-              <a:gd name="adj" fmla="val 5263"/>
+              <a:gd name="adj" fmla="val 3200"/>
             </a:avLst>
           </a:prstGeom>
           <a:solidFill>
-            <a:srgbClr val="151B2E"/>
+            <a:srgbClr val="141A2A"/>
           </a:solidFill>
           <a:ln w="12700">
             <a:solidFill>
@@ -4152,8 +4268,8 @@
         </p:nvSpPr>
         <p:spPr>
           <a:xfrm>
-            <a:off x="914400" y="4617720"/>
-            <a:ext cx="4754880" cy="320040"/>
+            <a:off x="960120" y="4160520"/>
+            <a:ext cx="4800600" cy="320040"/>
           </a:xfrm>
           <a:prstGeom prst="rect">
             <a:avLst/>
@@ -4188,8 +4304,8 @@
         </p:nvSpPr>
         <p:spPr>
           <a:xfrm>
-            <a:off x="914400" y="4937760"/>
-            <a:ext cx="4754880" cy="1188720"/>
+            <a:off x="960120" y="4526280"/>
+            <a:ext cx="4800600" cy="1645920"/>
           </a:xfrm>
           <a:prstGeom prst="rect">
             <a:avLst/>
@@ -4208,26 +4324,26 @@
               <a:buNone/>
             </a:pPr>
             <a:r>
-              <a:rPr lang="en-US" sz="1000" b="1" dirty="0">
+              <a:rPr lang="en-US" sz="1050" b="1" dirty="0">
                 <a:solidFill>
                   <a:srgbClr val="E2E8F0"/>
                 </a:solidFill>
               </a:rPr>
-              <a:t>• Starting Line: </a:t>
-            </a:r>
-            <a:pPr indent="0" marL="0">
-              <a:lnSpc>
-                <a:spcPct val="115000"/>
-              </a:lnSpc>
-              <a:buNone/>
-            </a:pPr>
-            <a:r>
-              <a:rPr lang="en-US" sz="1000" dirty="0">
+              <a:t>• Starting Head-Start: </a:t>
+            </a:r>
+            <a:pPr indent="0" marL="0">
+              <a:lnSpc>
+                <a:spcPct val="115000"/>
+              </a:lnSpc>
+              <a:buNone/>
+            </a:pPr>
+            <a:r>
+              <a:rPr lang="en-US" sz="1050" dirty="0">
                 <a:solidFill>
                   <a:srgbClr val="94A3B8"/>
                 </a:solidFill>
               </a:rPr>
-              <a:t>Total points from R1 &amp; R2 convert into starting meters (+75m if honorable).
+              <a:t>Points from R1 &amp; R2 convert into starting meters (+75m honor bonus).
 </a:t>
             </a:r>
             <a:pPr indent="0" marL="0">
@@ -4237,26 +4353,26 @@
               <a:buNone/>
             </a:pPr>
             <a:r>
-              <a:rPr lang="en-US" sz="1000" b="1" dirty="0">
+              <a:rPr lang="en-US" sz="1050" b="1" dirty="0">
                 <a:solidFill>
                   <a:srgbClr val="E2E8F0"/>
                 </a:solidFill>
               </a:rPr>
-              <a:t>• The Victory Gate: </a:t>
-            </a:r>
-            <a:pPr indent="0" marL="0">
-              <a:lnSpc>
-                <a:spcPct val="115000"/>
-              </a:lnSpc>
-              <a:buNone/>
-            </a:pPr>
-            <a:r>
-              <a:rPr lang="en-US" sz="1000" dirty="0">
+              <a:t>• Podium Victory: </a:t>
+            </a:r>
+            <a:pPr indent="0" marL="0">
+              <a:lnSpc>
+                <a:spcPct val="115000"/>
+              </a:lnSpc>
+              <a:buNone/>
+            </a:pPr>
+            <a:r>
+              <a:rPr lang="en-US" sz="1050" dirty="0">
                 <a:solidFill>
                   <a:srgbClr val="F59E0B"/>
                 </a:solidFill>
               </a:rPr>
-              <a:t>First 3 crews to reach 1,000m win Gold, Silver &amp; Bronze medals!
+              <a:t>First 3 crews across the 1,000m line win Gold, Silver &amp; Bronze medals!
 </a:t>
             </a:r>
             <a:pPr indent="0" marL="0">
@@ -4266,7 +4382,7 @@
               <a:buNone/>
             </a:pPr>
             <a:r>
-              <a:rPr lang="en-US" sz="1000" b="1" dirty="0">
+              <a:rPr lang="en-US" sz="1050" b="1" dirty="0">
                 <a:solidFill>
                   <a:srgbClr val="E2E8F0"/>
                 </a:solidFill>
@@ -4280,14 +4396,14 @@
               <a:buNone/>
             </a:pPr>
             <a:r>
-              <a:rPr lang="en-US" sz="1000" dirty="0">
+              <a:rPr lang="en-US" sz="1050" dirty="0">
                 <a:solidFill>
                   <a:srgbClr val="94A3B8"/>
                 </a:solidFill>
               </a:rPr>
-              <a:t>Tie-breaker standoff (Shields vs Ram vs Sails) if crews cross together.</a:t>
-            </a:r>
-            <a:endParaRPr lang="en-US" sz="1000" dirty="0"/>
+              <a:t>Tie-breaker duel (Shields vs Ram vs Sails) if crews cross together.</a:t>
+            </a:r>
+            <a:endParaRPr lang="en-US" sz="1050" dirty="0"/>
           </a:p>
         </p:txBody>
       </p:sp>
@@ -4299,16 +4415,16 @@
         </p:nvSpPr>
         <p:spPr>
           <a:xfrm>
-            <a:off x="6126480" y="4480560"/>
-            <a:ext cx="5303520" cy="1737360"/>
+            <a:off x="6199632" y="4023360"/>
+            <a:ext cx="5257800" cy="2286000"/>
           </a:xfrm>
           <a:prstGeom prst="roundRect">
             <a:avLst>
-              <a:gd name="adj" fmla="val 5263"/>
+              <a:gd name="adj" fmla="val 3200"/>
             </a:avLst>
           </a:prstGeom>
           <a:solidFill>
-            <a:srgbClr val="151B2E"/>
+            <a:srgbClr val="141A2A"/>
           </a:solidFill>
           <a:ln w="12700">
             <a:solidFill>
@@ -4326,8 +4442,8 @@
         </p:nvSpPr>
         <p:spPr>
           <a:xfrm>
-            <a:off x="6309360" y="4617720"/>
-            <a:ext cx="4937760" cy="320040"/>
+            <a:off x="6428232" y="4160520"/>
+            <a:ext cx="4800600" cy="320040"/>
           </a:xfrm>
           <a:prstGeom prst="rect">
             <a:avLst/>
@@ -4362,8 +4478,8 @@
         </p:nvSpPr>
         <p:spPr>
           <a:xfrm>
-            <a:off x="6309360" y="4937760"/>
-            <a:ext cx="4937760" cy="1188720"/>
+            <a:off x="6428232" y="4526280"/>
+            <a:ext cx="4800600" cy="1645920"/>
           </a:xfrm>
           <a:prstGeom prst="rect">
             <a:avLst/>
@@ -4382,21 +4498,21 @@
               <a:buNone/>
             </a:pPr>
             <a:r>
-              <a:rPr lang="en-US" sz="1000" b="1" dirty="0">
+              <a:rPr lang="en-US" sz="1050" b="1" dirty="0">
                 <a:solidFill>
                   <a:srgbClr val="E2E8F0"/>
                 </a:solidFill>
               </a:rPr>
-              <a:t>• Revenge for Betrayal: </a:t>
-            </a:r>
-            <a:pPr indent="0" marL="0">
-              <a:lnSpc>
-                <a:spcPct val="115000"/>
-              </a:lnSpc>
-              <a:buNone/>
-            </a:pPr>
-            <a:r>
-              <a:rPr lang="en-US" sz="1000" dirty="0">
+              <a:t>• Retaliation for Betrayal: </a:t>
+            </a:r>
+            <a:pPr indent="0" marL="0">
+              <a:lnSpc>
+                <a:spcPct val="115000"/>
+              </a:lnSpc>
+              <a:buNone/>
+            </a:pPr>
+            <a:r>
+              <a:rPr lang="en-US" sz="1050" dirty="0">
                 <a:solidFill>
                   <a:srgbClr val="94A3B8"/>
                 </a:solidFill>
@@ -4411,7 +4527,7 @@
               <a:buNone/>
             </a:pPr>
             <a:r>
-              <a:rPr lang="en-US" sz="1000" b="1" dirty="0">
+              <a:rPr lang="en-US" sz="1050" b="1" dirty="0">
                 <a:solidFill>
                   <a:srgbClr val="E2E8F0"/>
                 </a:solidFill>
@@ -4425,12 +4541,12 @@
               <a:buNone/>
             </a:pPr>
             <a:r>
-              <a:rPr lang="en-US" sz="1000" dirty="0">
+              <a:rPr lang="en-US" sz="1050" dirty="0">
                 <a:solidFill>
                   <a:srgbClr val="94A3B8"/>
                 </a:solidFill>
               </a:rPr>
-              <a:t>Guess which boat your nemesis will take. If you predict correctly:
+              <a:t>Guess which boat your nemesis will pick this wave. If correct:
 </a:t>
             </a:r>
             <a:pPr indent="0" marL="0">
@@ -4440,31 +4556,31 @@
               <a:buNone/>
             </a:pPr>
             <a:r>
-              <a:rPr lang="en-US" sz="1000" b="1" dirty="0">
+              <a:rPr lang="en-US" sz="1050" b="1" dirty="0">
                 <a:solidFill>
                   <a:srgbClr val="F43F5E"/>
                 </a:solidFill>
               </a:rPr>
               <a:t>  ➔ Nemesis dragged back -150m!</a:t>
             </a:r>
-            <a:endParaRPr lang="en-US" sz="1000" dirty="0"/>
-          </a:p>
-          <a:p>
-            <a:pPr indent="0" marL="0">
-              <a:lnSpc>
-                <a:spcPct val="115000"/>
-              </a:lnSpc>
-              <a:buNone/>
-            </a:pPr>
-            <a:r>
-              <a:rPr lang="en-US" sz="1000" b="1" dirty="0">
+            <a:endParaRPr lang="en-US" sz="1050" dirty="0"/>
+          </a:p>
+          <a:p>
+            <a:pPr indent="0" marL="0">
+              <a:lnSpc>
+                <a:spcPct val="115000"/>
+              </a:lnSpc>
+              <a:buNone/>
+            </a:pPr>
+            <a:r>
+              <a:rPr lang="en-US" sz="1050" b="1" dirty="0">
                 <a:solidFill>
                   <a:srgbClr val="F43F5E"/>
                 </a:solidFill>
               </a:rPr>
               <a:t>  ➔ Your crew surges forward +150m!</a:t>
             </a:r>
-            <a:endParaRPr lang="en-US" sz="1000" dirty="0"/>
+            <a:endParaRPr lang="en-US" sz="1050" dirty="0"/>
           </a:p>
         </p:txBody>
       </p:sp>
@@ -4508,8 +4624,8 @@
         </p:nvSpPr>
         <p:spPr>
           <a:xfrm>
-            <a:off x="731520" y="457200"/>
-            <a:ext cx="7315200" cy="365760"/>
+            <a:off x="731520" y="411480"/>
+            <a:ext cx="7315200" cy="274320"/>
           </a:xfrm>
           <a:prstGeom prst="rect">
             <a:avLst/>
@@ -4525,14 +4641,14 @@
               <a:buNone/>
             </a:pPr>
             <a:r>
-              <a:rPr lang="en-US" sz="1100" b="1" spc="200" kern="0" dirty="0">
+              <a:rPr lang="en-US" sz="1000" b="1" spc="200" kern="0" dirty="0">
                 <a:solidFill>
                   <a:srgbClr val="F59E0B"/>
                 </a:solidFill>
               </a:rPr>
               <a:t>FACILITATOR CHEATSHEET • AT A GLANCE</a:t>
             </a:r>
-            <a:endParaRPr lang="en-US" sz="1100" dirty="0"/>
+            <a:endParaRPr lang="en-US" sz="1000" dirty="0"/>
           </a:p>
         </p:txBody>
       </p:sp>
@@ -4544,8 +4660,8 @@
         </p:nvSpPr>
         <p:spPr>
           <a:xfrm>
-            <a:off x="731520" y="731520"/>
-            <a:ext cx="10058400" cy="731520"/>
+            <a:off x="731520" y="685800"/>
+            <a:ext cx="10698480" cy="548640"/>
           </a:xfrm>
           <a:prstGeom prst="rect">
             <a:avLst/>
@@ -4561,14 +4677,14 @@
               <a:buNone/>
             </a:pPr>
             <a:r>
-              <a:rPr lang="en-US" sz="3200" b="1" dirty="0">
+              <a:rPr lang="en-US" sz="2600" b="1" dirty="0">
                 <a:solidFill>
                   <a:srgbClr val="FEF3C7"/>
                 </a:solidFill>
               </a:rPr>
               <a:t>SESSION RUNNING GUIDE</a:t>
             </a:r>
-            <a:endParaRPr lang="en-US" sz="3200" dirty="0"/>
+            <a:endParaRPr lang="en-US" sz="2600" dirty="0"/>
           </a:p>
         </p:txBody>
       </p:sp>
@@ -4580,8 +4696,8 @@
         </p:nvSpPr>
         <p:spPr>
           <a:xfrm>
-            <a:off x="731520" y="1371600"/>
-            <a:ext cx="9144000" cy="365760"/>
+            <a:off x="731520" y="1234440"/>
+            <a:ext cx="10698480" cy="320040"/>
           </a:xfrm>
           <a:prstGeom prst="rect">
             <a:avLst/>
@@ -4597,14 +4713,14 @@
               <a:buNone/>
             </a:pPr>
             <a:r>
-              <a:rPr lang="en-US" sz="1400" dirty="0">
+              <a:rPr lang="en-US" sz="1200" dirty="0">
                 <a:solidFill>
                   <a:srgbClr val="94A3B8"/>
                 </a:solidFill>
               </a:rPr>
               <a:t>Total Event Runtime: ~25 - 30 Minutes</a:t>
             </a:r>
-            <a:endParaRPr lang="en-US" sz="1400" dirty="0"/>
+            <a:endParaRPr lang="en-US" sz="1200" dirty="0"/>
           </a:p>
         </p:txBody>
       </p:sp>
@@ -4623,20 +4739,20 @@
           </p:nvPr>
         </p:nvGraphicFramePr>
         <p:xfrm>
-          <a:off x="731520" y="1920240"/>
-          <a:ext cx="10698480" cy="3474720"/>
+          <a:off x="731520" y="1691640"/>
+          <a:ext cx="10725912" cy="3749040"/>
         </p:xfrm>
         <a:graphic>
           <a:graphicData uri="http://schemas.openxmlformats.org/drawingml/2006/table">
             <a:tbl>
               <a:tblPr/>
               <a:tblGrid>
-                <a:gridCol w="2674620"/>
-                <a:gridCol w="2674620"/>
-                <a:gridCol w="2674620"/>
-                <a:gridCol w="2674620"/>
+                <a:gridCol w="2681478"/>
+                <a:gridCol w="2681478"/>
+                <a:gridCol w="2681478"/>
+                <a:gridCol w="2681478"/>
               </a:tblGrid>
-              <a:tr h="868680">
+              <a:tr h="937260">
                 <a:tc>
                   <a:txBody>
                     <a:bodyPr/>
@@ -4646,14 +4762,14 @@
                         <a:buNone/>
                       </a:pPr>
                       <a:r>
-                        <a:rPr lang="en-US" sz="1000" b="1" dirty="0">
+                        <a:rPr lang="en-US" sz="1050" b="1" dirty="0">
                           <a:solidFill>
                             <a:srgbClr val="F59E0B"/>
                           </a:solidFill>
                         </a:rPr>
                         <a:t>ROUND</a:t>
                       </a:r>
-                      <a:endParaRPr lang="en-US" sz="1000" dirty="0"/>
+                      <a:endParaRPr lang="en-US" sz="1050" dirty="0"/>
                     </a:p>
                   </a:txBody>
                   <a:tcPr marL="91440" marR="91440" marT="45720" marB="45720" anchor="ctr">
@@ -4707,14 +4823,14 @@
                         <a:buNone/>
                       </a:pPr>
                       <a:r>
-                        <a:rPr lang="en-US" sz="1000" b="1" dirty="0">
+                        <a:rPr lang="en-US" sz="1050" b="1" dirty="0">
                           <a:solidFill>
                             <a:srgbClr val="F59E0B"/>
                           </a:solidFill>
                         </a:rPr>
                         <a:t>CORE ACTIVITY</a:t>
                       </a:r>
-                      <a:endParaRPr lang="en-US" sz="1000" dirty="0"/>
+                      <a:endParaRPr lang="en-US" sz="1050" dirty="0"/>
                     </a:p>
                   </a:txBody>
                   <a:tcPr marL="91440" marR="91440" marT="45720" marB="45720" anchor="ctr">
@@ -4768,14 +4884,14 @@
                         <a:buNone/>
                       </a:pPr>
                       <a:r>
-                        <a:rPr lang="en-US" sz="1000" b="1" dirty="0">
+                        <a:rPr lang="en-US" sz="1050" b="1" dirty="0">
                           <a:solidFill>
                             <a:srgbClr val="F59E0B"/>
                           </a:solidFill>
                         </a:rPr>
                         <a:t>HOW POINTS / PROGRESS WORK</a:t>
                       </a:r>
-                      <a:endParaRPr lang="en-US" sz="1000" dirty="0"/>
+                      <a:endParaRPr lang="en-US" sz="1050" dirty="0"/>
                     </a:p>
                   </a:txBody>
                   <a:tcPr marL="91440" marR="91440" marT="45720" marB="45720" anchor="ctr">
@@ -4829,14 +4945,14 @@
                         <a:buNone/>
                       </a:pPr>
                       <a:r>
-                        <a:rPr lang="en-US" sz="1000" b="1" dirty="0">
+                        <a:rPr lang="en-US" sz="1050" b="1" dirty="0">
                           <a:solidFill>
                             <a:srgbClr val="F59E0B"/>
                           </a:solidFill>
                         </a:rPr>
-                        <a:t>ROUND COMPLETION</a:t>
+                        <a:t>COMPLETION</a:t>
                       </a:r>
-                      <a:endParaRPr lang="en-US" sz="1000" dirty="0"/>
+                      <a:endParaRPr lang="en-US" sz="1050" dirty="0"/>
                     </a:p>
                   </a:txBody>
                   <a:tcPr marL="91440" marR="91440" marT="45720" marB="45720" anchor="ctr">
@@ -4882,7 +4998,7 @@
                   </a:tcPr>
                 </a:tc>
               </a:tr>
-              <a:tr h="868680">
+              <a:tr h="937260">
                 <a:tc>
                   <a:txBody>
                     <a:bodyPr/>
@@ -4892,28 +5008,28 @@
                         <a:buNone/>
                       </a:pPr>
                       <a:r>
-                        <a:rPr lang="en-US" sz="1000" b="1" dirty="0">
+                        <a:rPr lang="en-US" sz="1050" b="1" dirty="0">
                           <a:solidFill>
                             <a:srgbClr val="E2E8F0"/>
                           </a:solidFill>
                         </a:rPr>
                         <a:t>1. Shattered Tablet</a:t>
                       </a:r>
-                      <a:endParaRPr lang="en-US" sz="1000" dirty="0"/>
+                      <a:endParaRPr lang="en-US" sz="1050" dirty="0"/>
                     </a:p>
                     <a:p>
                       <a:pPr algn="l" indent="0" marL="0">
                         <a:buNone/>
                       </a:pPr>
                       <a:r>
-                        <a:rPr lang="en-US" sz="1000" b="1" dirty="0">
+                        <a:rPr lang="en-US" sz="1050" b="1" dirty="0">
                           <a:solidFill>
                             <a:srgbClr val="E2E8F0"/>
                           </a:solidFill>
                         </a:rPr>
                         <a:t>(~5 min)</a:t>
                       </a:r>
-                      <a:endParaRPr lang="en-US" sz="1000" dirty="0"/>
+                      <a:endParaRPr lang="en-US" sz="1050" dirty="0"/>
                     </a:p>
                   </a:txBody>
                   <a:tcPr marL="91440" marR="91440" marT="45720" marB="45720" anchor="ctr">
@@ -4954,7 +5070,7 @@
                       <a:tailEnd type="none" w="med" len="med"/>
                     </a:lnB>
                     <a:solidFill>
-                      <a:srgbClr val="151B2E"/>
+                      <a:srgbClr val="141A2A"/>
                     </a:solidFill>
                   </a:tcPr>
                 </a:tc>
@@ -4967,14 +5083,14 @@
                         <a:buNone/>
                       </a:pPr>
                       <a:r>
-                        <a:rPr lang="en-US" sz="1000" dirty="0">
+                        <a:rPr lang="en-US" sz="1050" dirty="0">
                           <a:solidFill>
                             <a:srgbClr val="94A3B8"/>
                           </a:solidFill>
                         </a:rPr>
-                        <a:t>Physically place 5 phones side-by-side in order (#1 to #5) to read codeword.</a:t>
+                        <a:t>Place 5 phones side-by-side in order (#1 to #5) across the table to connect carved lines.</a:t>
                       </a:r>
-                      <a:endParaRPr lang="en-US" sz="1000" dirty="0"/>
+                      <a:endParaRPr lang="en-US" sz="1050" dirty="0"/>
                     </a:p>
                   </a:txBody>
                   <a:tcPr marL="91440" marR="91440" marT="45720" marB="45720" anchor="ctr">
@@ -5015,7 +5131,7 @@
                       <a:tailEnd type="none" w="med" len="med"/>
                     </a:lnB>
                     <a:solidFill>
-                      <a:srgbClr val="151B2E"/>
+                      <a:srgbClr val="141A2A"/>
                     </a:solidFill>
                   </a:tcPr>
                 </a:tc>
@@ -5028,14 +5144,14 @@
                         <a:buNone/>
                       </a:pPr>
                       <a:r>
-                        <a:rPr lang="en-US" sz="1000" dirty="0">
+                        <a:rPr lang="en-US" sz="1050" dirty="0">
                           <a:solidFill>
                             <a:srgbClr val="94A3B8"/>
                           </a:solidFill>
                         </a:rPr>
-                        <a:t>Fast solve = top points (300). Hints cost -30 PTS each. 50 PTS floor.</a:t>
+                        <a:t>Fast solve = top points (up to 300). Progressive hints cost -30 PTS each. 50 PTS floor.</a:t>
                       </a:r>
-                      <a:endParaRPr lang="en-US" sz="1000" dirty="0"/>
+                      <a:endParaRPr lang="en-US" sz="1050" dirty="0"/>
                     </a:p>
                   </a:txBody>
                   <a:tcPr marL="91440" marR="91440" marT="45720" marB="45720" anchor="ctr">
@@ -5076,7 +5192,7 @@
                       <a:tailEnd type="none" w="med" len="med"/>
                     </a:lnB>
                     <a:solidFill>
-                      <a:srgbClr val="151B2E"/>
+                      <a:srgbClr val="141A2A"/>
                     </a:solidFill>
                   </a:tcPr>
                 </a:tc>
@@ -5089,14 +5205,14 @@
                         <a:buNone/>
                       </a:pPr>
                       <a:r>
-                        <a:rPr lang="en-US" sz="1000" dirty="0">
+                        <a:rPr lang="en-US" sz="1050" dirty="0">
                           <a:solidFill>
                             <a:srgbClr val="10B981"/>
                           </a:solidFill>
                         </a:rPr>
-                        <a:t>Correct 2-word codeword entered or timer expires.</a:t>
+                        <a:t>2-word codeword entered or timer expires.</a:t>
                       </a:r>
-                      <a:endParaRPr lang="en-US" sz="1000" dirty="0"/>
+                      <a:endParaRPr lang="en-US" sz="1050" dirty="0"/>
                     </a:p>
                   </a:txBody>
                   <a:tcPr marL="91440" marR="91440" marT="45720" marB="45720" anchor="ctr">
@@ -5137,12 +5253,12 @@
                       <a:tailEnd type="none" w="med" len="med"/>
                     </a:lnB>
                     <a:solidFill>
-                      <a:srgbClr val="151B2E"/>
+                      <a:srgbClr val="141A2A"/>
                     </a:solidFill>
                   </a:tcPr>
                 </a:tc>
               </a:tr>
-              <a:tr h="868680">
+              <a:tr h="937260">
                 <a:tc>
                   <a:txBody>
                     <a:bodyPr/>
@@ -5152,28 +5268,28 @@
                         <a:buNone/>
                       </a:pPr>
                       <a:r>
-                        <a:rPr lang="en-US" sz="1000" b="1" dirty="0">
+                        <a:rPr lang="en-US" sz="1050" b="1" dirty="0">
                           <a:solidFill>
                             <a:srgbClr val="E2E8F0"/>
                           </a:solidFill>
                         </a:rPr>
                         <a:t>2. Shades in Mist</a:t>
                       </a:r>
-                      <a:endParaRPr lang="en-US" sz="1000" dirty="0"/>
+                      <a:endParaRPr lang="en-US" sz="1050" dirty="0"/>
                     </a:p>
                     <a:p>
                       <a:pPr algn="l" indent="0" marL="0">
                         <a:buNone/>
                       </a:pPr>
                       <a:r>
-                        <a:rPr lang="en-US" sz="1000" b="1" dirty="0">
+                        <a:rPr lang="en-US" sz="1050" b="1" dirty="0">
                           <a:solidFill>
                             <a:srgbClr val="E2E8F0"/>
                           </a:solidFill>
                         </a:rPr>
                         <a:t>(~8 min)</a:t>
                       </a:r>
-                      <a:endParaRPr lang="en-US" sz="1000" dirty="0"/>
+                      <a:endParaRPr lang="en-US" sz="1050" dirty="0"/>
                     </a:p>
                   </a:txBody>
                   <a:tcPr marL="91440" marR="91440" marT="45720" marB="45720" anchor="ctr">
@@ -5214,7 +5330,7 @@
                       <a:tailEnd type="none" w="med" len="med"/>
                     </a:lnB>
                     <a:solidFill>
-                      <a:srgbClr val="151B2E"/>
+                      <a:srgbClr val="141A2A"/>
                     </a:solidFill>
                   </a:tcPr>
                 </a:tc>
@@ -5227,14 +5343,14 @@
                         <a:buNone/>
                       </a:pPr>
                       <a:r>
-                        <a:rPr lang="en-US" sz="1000" dirty="0">
+                        <a:rPr lang="en-US" sz="1050" dirty="0">
                           <a:solidFill>
                             <a:srgbClr val="94A3B8"/>
                           </a:solidFill>
                         </a:rPr>
-                        <a:t>Face rival table across 3 clashes. Negotiate in person, vote secretly.</a:t>
+                        <a:t>Face rival table across 3 clashes. Whisper in huddle, negotiate across room, vote secretly.</a:t>
                       </a:r>
-                      <a:endParaRPr lang="en-US" sz="1000" dirty="0"/>
+                      <a:endParaRPr lang="en-US" sz="1050" dirty="0"/>
                     </a:p>
                   </a:txBody>
                   <a:tcPr marL="91440" marR="91440" marT="45720" marB="45720" anchor="ctr">
@@ -5275,7 +5391,7 @@
                       <a:tailEnd type="none" w="med" len="med"/>
                     </a:lnB>
                     <a:solidFill>
-                      <a:srgbClr val="151B2E"/>
+                      <a:srgbClr val="141A2A"/>
                     </a:solidFill>
                   </a:tcPr>
                 </a:tc>
@@ -5288,14 +5404,14 @@
                         <a:buNone/>
                       </a:pPr>
                       <a:r>
-                        <a:rPr lang="en-US" sz="1000" dirty="0">
+                        <a:rPr lang="en-US" sz="1050" dirty="0">
                           <a:solidFill>
                             <a:srgbClr val="94A3B8"/>
                           </a:solidFill>
                         </a:rPr>
-                        <a:t>Truce = safe points. Backstab = huge points or 0. Stakes triple in Clash 3.</a:t>
+                        <a:t>Truce = steady points. Backstab = massive points or 0. Stakes triple in Clash 3.</a:t>
                       </a:r>
-                      <a:endParaRPr lang="en-US" sz="1000" dirty="0"/>
+                      <a:endParaRPr lang="en-US" sz="1050" dirty="0"/>
                     </a:p>
                   </a:txBody>
                   <a:tcPr marL="91440" marR="91440" marT="45720" marB="45720" anchor="ctr">
@@ -5336,7 +5452,7 @@
                       <a:tailEnd type="none" w="med" len="med"/>
                     </a:lnB>
                     <a:solidFill>
-                      <a:srgbClr val="151B2E"/>
+                      <a:srgbClr val="141A2A"/>
                     </a:solidFill>
                   </a:tcPr>
                 </a:tc>
@@ -5349,14 +5465,14 @@
                         <a:buNone/>
                       </a:pPr>
                       <a:r>
-                        <a:rPr lang="en-US" sz="1000" dirty="0">
+                        <a:rPr lang="en-US" sz="1050" dirty="0">
                           <a:solidFill>
                             <a:srgbClr val="10B981"/>
                           </a:solidFill>
                         </a:rPr>
-                        <a:t>All 3 clashes resolved. Determines R3 headstart &amp; revenge tokens.</a:t>
+                        <a:t>All 3 clashes resolved. Sets R3 headstart &amp; revenge tokens.</a:t>
                       </a:r>
-                      <a:endParaRPr lang="en-US" sz="1000" dirty="0"/>
+                      <a:endParaRPr lang="en-US" sz="1050" dirty="0"/>
                     </a:p>
                   </a:txBody>
                   <a:tcPr marL="91440" marR="91440" marT="45720" marB="45720" anchor="ctr">
@@ -5397,12 +5513,12 @@
                       <a:tailEnd type="none" w="med" len="med"/>
                     </a:lnB>
                     <a:solidFill>
-                      <a:srgbClr val="151B2E"/>
+                      <a:srgbClr val="141A2A"/>
                     </a:solidFill>
                   </a:tcPr>
                 </a:tc>
               </a:tr>
-              <a:tr h="868680">
+              <a:tr h="937260">
                 <a:tc>
                   <a:txBody>
                     <a:bodyPr/>
@@ -5412,28 +5528,28 @@
                         <a:buNone/>
                       </a:pPr>
                       <a:r>
-                        <a:rPr lang="en-US" sz="1000" b="1" dirty="0">
+                        <a:rPr lang="en-US" sz="1050" b="1" dirty="0">
                           <a:solidFill>
                             <a:srgbClr val="E2E8F0"/>
                           </a:solidFill>
                         </a:rPr>
                         <a:t>3. Styx Escape</a:t>
                       </a:r>
-                      <a:endParaRPr lang="en-US" sz="1000" dirty="0"/>
+                      <a:endParaRPr lang="en-US" sz="1050" dirty="0"/>
                     </a:p>
                     <a:p>
                       <a:pPr algn="l" indent="0" marL="0">
                         <a:buNone/>
                       </a:pPr>
                       <a:r>
-                        <a:rPr lang="en-US" sz="1000" b="1" dirty="0">
+                        <a:rPr lang="en-US" sz="1050" b="1" dirty="0">
                           <a:solidFill>
                             <a:srgbClr val="E2E8F0"/>
                           </a:solidFill>
                         </a:rPr>
                         <a:t>(~8 min)</a:t>
                       </a:r>
-                      <a:endParaRPr lang="en-US" sz="1000" dirty="0"/>
+                      <a:endParaRPr lang="en-US" sz="1050" dirty="0"/>
                     </a:p>
                   </a:txBody>
                   <a:tcPr marL="91440" marR="91440" marT="45720" marB="45720" anchor="ctr">
@@ -5474,7 +5590,7 @@
                       <a:tailEnd type="none" w="med" len="med"/>
                     </a:lnB>
                     <a:solidFill>
-                      <a:srgbClr val="151B2E"/>
+                      <a:srgbClr val="141A2A"/>
                     </a:solidFill>
                   </a:tcPr>
                 </a:tc>
@@ -5487,14 +5603,14 @@
                         <a:buNone/>
                       </a:pPr>
                       <a:r>
-                        <a:rPr lang="en-US" sz="1000" dirty="0">
+                        <a:rPr lang="en-US" sz="1050" dirty="0">
                           <a:solidFill>
                             <a:srgbClr val="94A3B8"/>
                           </a:solidFill>
                         </a:rPr>
                         <a:t>Pick vessels secretly (Rowboat: safe, Sailboat: 30% cap, Ghost Ship: solo).</a:t>
                       </a:r>
-                      <a:endParaRPr lang="en-US" sz="1000" dirty="0"/>
+                      <a:endParaRPr lang="en-US" sz="1050" dirty="0"/>
                     </a:p>
                   </a:txBody>
                   <a:tcPr marL="91440" marR="91440" marT="45720" marB="45720" anchor="ctr">
@@ -5535,7 +5651,7 @@
                       <a:tailEnd type="none" w="med" len="med"/>
                     </a:lnB>
                     <a:solidFill>
-                      <a:srgbClr val="151B2E"/>
+                      <a:srgbClr val="141A2A"/>
                     </a:solidFill>
                   </a:tcPr>
                 </a:tc>
@@ -5548,14 +5664,14 @@
                         <a:buNone/>
                       </a:pPr>
                       <a:r>
-                        <a:rPr lang="en-US" sz="1000" dirty="0">
+                        <a:rPr lang="en-US" sz="1050" dirty="0">
                           <a:solidFill>
                             <a:srgbClr val="94A3B8"/>
                           </a:solidFill>
                         </a:rPr>
-                        <a:t>Points become river meters. Avoid capsizing and unleash Cerberus revenge.</a:t>
+                        <a:t>Points become river meters. Avoid congestion and unleash Cerberus revenge.</a:t>
                       </a:r>
-                      <a:endParaRPr lang="en-US" sz="1000" dirty="0"/>
+                      <a:endParaRPr lang="en-US" sz="1050" dirty="0"/>
                     </a:p>
                   </a:txBody>
                   <a:tcPr marL="91440" marR="91440" marT="45720" marB="45720" anchor="ctr">
@@ -5596,7 +5712,7 @@
                       <a:tailEnd type="none" w="med" len="med"/>
                     </a:lnB>
                     <a:solidFill>
-                      <a:srgbClr val="151B2E"/>
+                      <a:srgbClr val="141A2A"/>
                     </a:solidFill>
                   </a:tcPr>
                 </a:tc>
@@ -5609,14 +5725,14 @@
                         <a:buNone/>
                       </a:pPr>
                       <a:r>
-                        <a:rPr lang="en-US" sz="1000" dirty="0">
+                        <a:rPr lang="en-US" sz="1050" dirty="0">
                           <a:solidFill>
                             <a:srgbClr val="F59E0B"/>
                           </a:solidFill>
                         </a:rPr>
-                        <a:t>Top 3 crews cross 1,000m to take Gold, Silver &amp; Bronze medals!</a:t>
+                        <a:t>Top 3 crews cross 1,000m to win Gold, Silver &amp; Bronze medals!</a:t>
                       </a:r>
-                      <a:endParaRPr lang="en-US" sz="1000" dirty="0"/>
+                      <a:endParaRPr lang="en-US" sz="1050" dirty="0"/>
                     </a:p>
                   </a:txBody>
                   <a:tcPr marL="91440" marR="91440" marT="45720" marB="45720" anchor="ctr">
@@ -5657,7 +5773,7 @@
                       <a:tailEnd type="none" w="med" len="med"/>
                     </a:lnB>
                     <a:solidFill>
-                      <a:srgbClr val="151B2E"/>
+                      <a:srgbClr val="141A2A"/>
                     </a:solidFill>
                   </a:tcPr>
                 </a:tc>
@@ -5675,7 +5791,7 @@
         <p:spPr>
           <a:xfrm>
             <a:off x="731520" y="5669280"/>
-            <a:ext cx="10698480" cy="548640"/>
+            <a:ext cx="10725912" cy="594360"/>
           </a:xfrm>
           <a:prstGeom prst="rect">
             <a:avLst/>
@@ -5699,8 +5815,8 @@
         </p:nvSpPr>
         <p:spPr>
           <a:xfrm>
-            <a:off x="914400" y="5779008"/>
-            <a:ext cx="10332720" cy="320040"/>
+            <a:off x="914400" y="5806440"/>
+            <a:ext cx="10360152" cy="320040"/>
           </a:xfrm>
           <a:prstGeom prst="rect">
             <a:avLst/>

</xml_diff>

<commit_message>
feat(round3): implement Stygian Leash high-risk leech mechanic replacing guess-the-boat
</commit_message>
<xml_diff>
--- a/presentation.pptx
+++ b/presentation.pptx
@@ -1240,7 +1240,7 @@
         <p:spPr>
           <a:xfrm>
             <a:off x="731520" y="411480"/>
-            <a:ext cx="7315200" cy="274320"/>
+            <a:ext cx="7315200" cy="256032"/>
           </a:xfrm>
           <a:prstGeom prst="rect">
             <a:avLst/>
@@ -1275,8 +1275,8 @@
         </p:nvSpPr>
         <p:spPr>
           <a:xfrm>
-            <a:off x="731520" y="685800"/>
-            <a:ext cx="10698480" cy="548640"/>
+            <a:off x="731520" y="658368"/>
+            <a:ext cx="10725912" cy="502920"/>
           </a:xfrm>
           <a:prstGeom prst="rect">
             <a:avLst/>
@@ -1311,8 +1311,8 @@
         </p:nvSpPr>
         <p:spPr>
           <a:xfrm>
-            <a:off x="731520" y="1234440"/>
-            <a:ext cx="10698480" cy="320040"/>
+            <a:off x="731520" y="1170432"/>
+            <a:ext cx="10725912" cy="292608"/>
           </a:xfrm>
           <a:prstGeom prst="rect">
             <a:avLst/>
@@ -1347,12 +1347,418 @@
         </p:nvSpPr>
         <p:spPr>
           <a:xfrm>
-            <a:off x="731520" y="1691640"/>
-            <a:ext cx="2514600" cy="1005840"/>
+            <a:off x="731520" y="1645920"/>
+            <a:ext cx="5257800" cy="3474720"/>
           </a:xfrm>
           <a:prstGeom prst="roundRect">
             <a:avLst>
-              <a:gd name="adj" fmla="val 7273"/>
+              <a:gd name="adj" fmla="val 2105"/>
+            </a:avLst>
+          </a:prstGeom>
+          <a:solidFill>
+            <a:srgbClr val="141A2A"/>
+          </a:solidFill>
+          <a:ln w="12700">
+            <a:solidFill>
+              <a:srgbClr val="334155"/>
+            </a:solidFill>
+            <a:prstDash val="solid"/>
+          </a:ln>
+        </p:spPr>
+      </p:sp>
+      <p:sp>
+        <p:nvSpPr>
+          <p:cNvPr id="6" name="Text 4"/>
+          <p:cNvSpPr/>
+          <p:nvPr/>
+        </p:nvSpPr>
+        <p:spPr>
+          <a:xfrm>
+            <a:off x="960120" y="1828800"/>
+            <a:ext cx="4800600" cy="365760"/>
+          </a:xfrm>
+          <a:prstGeom prst="rect">
+            <a:avLst/>
+          </a:prstGeom>
+          <a:noFill/>
+          <a:ln/>
+        </p:spPr>
+        <p:txBody>
+          <a:bodyPr wrap="square" rtlCol="0" anchor="ctr"/>
+          <a:lstStyle/>
+          <a:p>
+            <a:pPr indent="0" marL="0">
+              <a:buNone/>
+            </a:pPr>
+            <a:r>
+              <a:rPr lang="en-US" sz="1600" b="1" dirty="0">
+                <a:solidFill>
+                  <a:srgbClr val="FEF3C7"/>
+                </a:solidFill>
+              </a:rPr>
+              <a:t>👥 The 5-Player Crews</a:t>
+            </a:r>
+            <a:endParaRPr lang="en-US" sz="1600" dirty="0"/>
+          </a:p>
+        </p:txBody>
+      </p:sp>
+      <p:sp>
+        <p:nvSpPr>
+          <p:cNvPr id="7" name="Text 5"/>
+          <p:cNvSpPr/>
+          <p:nvPr/>
+        </p:nvSpPr>
+        <p:spPr>
+          <a:xfrm>
+            <a:off x="960120" y="2286000"/>
+            <a:ext cx="4800600" cy="2651760"/>
+          </a:xfrm>
+          <a:prstGeom prst="rect">
+            <a:avLst/>
+          </a:prstGeom>
+          <a:noFill/>
+          <a:ln/>
+        </p:spPr>
+        <p:txBody>
+          <a:bodyPr wrap="square" rtlCol="0" anchor="ctr"/>
+          <a:lstStyle/>
+          <a:p>
+            <a:pPr indent="0" marL="0">
+              <a:lnSpc>
+                <a:spcPct val="115000"/>
+              </a:lnSpc>
+              <a:buNone/>
+            </a:pPr>
+            <a:r>
+              <a:rPr lang="en-US" sz="1150" b="1" dirty="0">
+                <a:solidFill>
+                  <a:srgbClr val="E2E8F0"/>
+                </a:solidFill>
+              </a:rPr>
+              <a:t>• 5 Distinct Roles: </a:t>
+            </a:r>
+            <a:pPr indent="0" marL="0">
+              <a:lnSpc>
+                <a:spcPct val="115000"/>
+              </a:lnSpc>
+              <a:buNone/>
+            </a:pPr>
+            <a:r>
+              <a:rPr lang="en-US" sz="1150" dirty="0">
+                <a:solidFill>
+                  <a:srgbClr val="94A3B8"/>
+                </a:solidFill>
+              </a:rPr>
+              <a:t>Navigator, Oracle, Scholar, Torchbearer, Negotiator.
+</a:t>
+            </a:r>
+            <a:pPr indent="0" marL="0">
+              <a:lnSpc>
+                <a:spcPct val="115000"/>
+              </a:lnSpc>
+              <a:buNone/>
+            </a:pPr>
+            <a:r>
+              <a:rPr lang="en-US" sz="1150" b="1" dirty="0">
+                <a:solidFill>
+                  <a:srgbClr val="E2E8F0"/>
+                </a:solidFill>
+              </a:rPr>
+              <a:t>• Simple Identity (No Complex Powers): </a:t>
+            </a:r>
+            <a:pPr indent="0" marL="0">
+              <a:lnSpc>
+                <a:spcPct val="115000"/>
+              </a:lnSpc>
+              <a:buNone/>
+            </a:pPr>
+            <a:r>
+              <a:rPr lang="en-US" sz="1150" dirty="0">
+                <a:solidFill>
+                  <a:srgbClr val="94A3B8"/>
+                </a:solidFill>
+              </a:rPr>
+              <a:t>Roles serve as crew member identities and tablet puzzle slots. Players don't need to manage complicated abilities.
+</a:t>
+            </a:r>
+            <a:pPr indent="0" marL="0">
+              <a:lnSpc>
+                <a:spcPct val="115000"/>
+              </a:lnSpc>
+              <a:buNone/>
+            </a:pPr>
+            <a:r>
+              <a:rPr lang="en-US" sz="1150" b="1" dirty="0">
+                <a:solidFill>
+                  <a:srgbClr val="E2E8F0"/>
+                </a:solidFill>
+              </a:rPr>
+              <a:t>• 1-Tap Emoji Joining: </a:t>
+            </a:r>
+            <a:pPr indent="0" marL="0">
+              <a:lnSpc>
+                <a:spcPct val="115000"/>
+              </a:lnSpc>
+              <a:buNone/>
+            </a:pPr>
+            <a:r>
+              <a:rPr lang="en-US" sz="1150" dirty="0">
+                <a:solidFill>
+                  <a:srgbClr val="94A3B8"/>
+                </a:solidFill>
+              </a:rPr>
+              <a:t>One player creates the crew; teammates join by tapping 3 emojis on screen (e.g. Skull • Bolt • Shield).
+</a:t>
+            </a:r>
+            <a:pPr indent="0" marL="0">
+              <a:lnSpc>
+                <a:spcPct val="115000"/>
+              </a:lnSpc>
+              <a:buNone/>
+            </a:pPr>
+            <a:r>
+              <a:rPr lang="en-US" sz="1150" b="1" dirty="0">
+                <a:solidFill>
+                  <a:srgbClr val="E2E8F0"/>
+                </a:solidFill>
+              </a:rPr>
+              <a:t>• Zero Friction: </a:t>
+            </a:r>
+            <a:pPr indent="0" marL="0">
+              <a:lnSpc>
+                <a:spcPct val="115000"/>
+              </a:lnSpc>
+              <a:buNone/>
+            </a:pPr>
+            <a:r>
+              <a:rPr lang="en-US" sz="1150" dirty="0">
+                <a:solidFill>
+                  <a:srgbClr val="10B981"/>
+                </a:solidFill>
+              </a:rPr>
+              <a:t>No apps to download, no typing, no camera permissions required.</a:t>
+            </a:r>
+            <a:endParaRPr lang="en-US" sz="1150" dirty="0"/>
+          </a:p>
+        </p:txBody>
+      </p:sp>
+      <p:sp>
+        <p:nvSpPr>
+          <p:cNvPr id="8" name="Shape 6"/>
+          <p:cNvSpPr/>
+          <p:nvPr/>
+        </p:nvSpPr>
+        <p:spPr>
+          <a:xfrm>
+            <a:off x="6199632" y="1645920"/>
+            <a:ext cx="5257800" cy="3474720"/>
+          </a:xfrm>
+          <a:prstGeom prst="roundRect">
+            <a:avLst>
+              <a:gd name="adj" fmla="val 2105"/>
+            </a:avLst>
+          </a:prstGeom>
+          <a:solidFill>
+            <a:srgbClr val="141A2A"/>
+          </a:solidFill>
+          <a:ln w="12700">
+            <a:solidFill>
+              <a:srgbClr val="334155"/>
+            </a:solidFill>
+            <a:prstDash val="solid"/>
+          </a:ln>
+        </p:spPr>
+      </p:sp>
+      <p:sp>
+        <p:nvSpPr>
+          <p:cNvPr id="9" name="Text 7"/>
+          <p:cNvSpPr/>
+          <p:nvPr/>
+        </p:nvSpPr>
+        <p:spPr>
+          <a:xfrm>
+            <a:off x="6428232" y="1828800"/>
+            <a:ext cx="4800600" cy="365760"/>
+          </a:xfrm>
+          <a:prstGeom prst="rect">
+            <a:avLst/>
+          </a:prstGeom>
+          <a:noFill/>
+          <a:ln/>
+        </p:spPr>
+        <p:txBody>
+          <a:bodyPr wrap="square" rtlCol="0" anchor="ctr"/>
+          <a:lstStyle/>
+          <a:p>
+            <a:pPr indent="0" marL="0">
+              <a:buNone/>
+            </a:pPr>
+            <a:r>
+              <a:rPr lang="en-US" sz="1600" b="1" dirty="0">
+                <a:solidFill>
+                  <a:srgbClr val="FEF3C7"/>
+                </a:solidFill>
+              </a:rPr>
+              <a:t>🏆 The Ultimate Objective</a:t>
+            </a:r>
+            <a:endParaRPr lang="en-US" sz="1600" dirty="0"/>
+          </a:p>
+        </p:txBody>
+      </p:sp>
+      <p:sp>
+        <p:nvSpPr>
+          <p:cNvPr id="10" name="Text 8"/>
+          <p:cNvSpPr/>
+          <p:nvPr/>
+        </p:nvSpPr>
+        <p:spPr>
+          <a:xfrm>
+            <a:off x="6428232" y="2286000"/>
+            <a:ext cx="4800600" cy="2651760"/>
+          </a:xfrm>
+          <a:prstGeom prst="rect">
+            <a:avLst/>
+          </a:prstGeom>
+          <a:noFill/>
+          <a:ln/>
+        </p:spPr>
+        <p:txBody>
+          <a:bodyPr wrap="square" rtlCol="0" anchor="ctr"/>
+          <a:lstStyle/>
+          <a:p>
+            <a:pPr indent="0" marL="0">
+              <a:lnSpc>
+                <a:spcPct val="115000"/>
+              </a:lnSpc>
+              <a:buNone/>
+            </a:pPr>
+            <a:r>
+              <a:rPr lang="en-US" sz="1150" b="1" dirty="0">
+                <a:solidFill>
+                  <a:srgbClr val="E2E8F0"/>
+                </a:solidFill>
+              </a:rPr>
+              <a:t>• Rounds 1 &amp; 2 (Points Pool): </a:t>
+            </a:r>
+            <a:pPr indent="0" marL="0">
+              <a:lnSpc>
+                <a:spcPct val="115000"/>
+              </a:lnSpc>
+              <a:buNone/>
+            </a:pPr>
+            <a:r>
+              <a:rPr lang="en-US" sz="1150" dirty="0">
+                <a:solidFill>
+                  <a:srgbClr val="94A3B8"/>
+                </a:solidFill>
+              </a:rPr>
+              <a:t>Earn points through team physical coordination and tactical room psychology.
+</a:t>
+            </a:r>
+            <a:pPr indent="0" marL="0">
+              <a:lnSpc>
+                <a:spcPct val="115000"/>
+              </a:lnSpc>
+              <a:buNone/>
+            </a:pPr>
+            <a:r>
+              <a:rPr lang="en-US" sz="1150" b="1" dirty="0">
+                <a:solidFill>
+                  <a:srgbClr val="E2E8F0"/>
+                </a:solidFill>
+              </a:rPr>
+              <a:t>• Starting Head-Start: </a:t>
+            </a:r>
+            <a:pPr indent="0" marL="0">
+              <a:lnSpc>
+                <a:spcPct val="115000"/>
+              </a:lnSpc>
+              <a:buNone/>
+            </a:pPr>
+            <a:r>
+              <a:rPr lang="en-US" sz="1150" dirty="0">
+                <a:solidFill>
+                  <a:srgbClr val="94A3B8"/>
+                </a:solidFill>
+              </a:rPr>
+              <a:t>Cumulative points convert directly into starting distance meters on the River Styx in Round 3!
+</a:t>
+            </a:r>
+            <a:pPr indent="0" marL="0">
+              <a:lnSpc>
+                <a:spcPct val="115000"/>
+              </a:lnSpc>
+              <a:buNone/>
+            </a:pPr>
+            <a:r>
+              <a:rPr lang="en-US" sz="1150" b="1" dirty="0">
+                <a:solidFill>
+                  <a:srgbClr val="E2E8F0"/>
+                </a:solidFill>
+              </a:rPr>
+              <a:t>• Podium Victory: </a:t>
+            </a:r>
+            <a:pPr indent="0" marL="0">
+              <a:lnSpc>
+                <a:spcPct val="115000"/>
+              </a:lnSpc>
+              <a:buNone/>
+            </a:pPr>
+            <a:r>
+              <a:rPr lang="en-US" sz="1150" dirty="0">
+                <a:solidFill>
+                  <a:srgbClr val="F59E0B"/>
+                </a:solidFill>
+              </a:rPr>
+              <a:t>First 3 crews to cross the 1,000-meter exit portal win Gold, Silver, and Bronze medals.
+</a:t>
+            </a:r>
+            <a:pPr indent="0" marL="0">
+              <a:lnSpc>
+                <a:spcPct val="115000"/>
+              </a:lnSpc>
+              <a:buNone/>
+            </a:pPr>
+            <a:r>
+              <a:rPr lang="en-US" sz="1150" b="1" dirty="0">
+                <a:solidFill>
+                  <a:srgbClr val="E2E8F0"/>
+                </a:solidFill>
+              </a:rPr>
+              <a:t>• High Energy: </a:t>
+            </a:r>
+            <a:pPr indent="0" marL="0">
+              <a:lnSpc>
+                <a:spcPct val="115000"/>
+              </a:lnSpc>
+              <a:buNone/>
+            </a:pPr>
+            <a:r>
+              <a:rPr lang="en-US" sz="1150" dirty="0">
+                <a:solidFill>
+                  <a:srgbClr val="94A3B8"/>
+                </a:solidFill>
+              </a:rPr>
+              <a:t>The whole experience runs in ~25-30 minutes of fast, social interaction.</a:t>
+            </a:r>
+            <a:endParaRPr lang="en-US" sz="1150" dirty="0"/>
+          </a:p>
+        </p:txBody>
+      </p:sp>
+      <p:sp>
+        <p:nvSpPr>
+          <p:cNvPr id="11" name="Shape 9"/>
+          <p:cNvSpPr/>
+          <p:nvPr/>
+        </p:nvSpPr>
+        <p:spPr>
+          <a:xfrm>
+            <a:off x="731520" y="5349240"/>
+            <a:ext cx="2514600" cy="731520"/>
+          </a:xfrm>
+          <a:prstGeom prst="roundRect">
+            <a:avLst>
+              <a:gd name="adj" fmla="val 10000"/>
             </a:avLst>
           </a:prstGeom>
           <a:solidFill>
@@ -1368,14 +1774,14 @@
       </p:sp>
       <p:sp>
         <p:nvSpPr>
-          <p:cNvPr id="6" name="Text 4"/>
-          <p:cNvSpPr/>
-          <p:nvPr/>
-        </p:nvSpPr>
-        <p:spPr>
-          <a:xfrm>
-            <a:off x="822960" y="1783080"/>
-            <a:ext cx="2331720" cy="228600"/>
+          <p:cNvPr id="12" name="Text 10"/>
+          <p:cNvSpPr/>
+          <p:nvPr/>
+        </p:nvSpPr>
+        <p:spPr>
+          <a:xfrm>
+            <a:off x="822960" y="5486400"/>
+            <a:ext cx="2331720" cy="457200"/>
           </a:xfrm>
           <a:prstGeom prst="rect">
             <a:avLst/>
@@ -1391,103 +1797,31 @@
               <a:buNone/>
             </a:pPr>
             <a:r>
-              <a:rPr lang="en-US" sz="900" b="1" dirty="0">
-                <a:solidFill>
-                  <a:srgbClr val="F59E0B"/>
-                </a:solidFill>
-              </a:rPr>
-              <a:t>0. LOBBY</a:t>
-            </a:r>
-            <a:endParaRPr lang="en-US" sz="900" dirty="0"/>
-          </a:p>
-        </p:txBody>
-      </p:sp>
-      <p:sp>
-        <p:nvSpPr>
-          <p:cNvPr id="7" name="Text 5"/>
-          <p:cNvSpPr/>
-          <p:nvPr/>
-        </p:nvSpPr>
-        <p:spPr>
-          <a:xfrm>
-            <a:off x="822960" y="2011680"/>
-            <a:ext cx="2331720" cy="320040"/>
-          </a:xfrm>
-          <a:prstGeom prst="rect">
-            <a:avLst/>
-          </a:prstGeom>
-          <a:noFill/>
-          <a:ln/>
-        </p:spPr>
-        <p:txBody>
-          <a:bodyPr wrap="square" rtlCol="0" anchor="ctr"/>
-          <a:lstStyle/>
-          <a:p>
-            <a:pPr algn="ctr" indent="0" marL="0">
-              <a:buNone/>
-            </a:pPr>
-            <a:r>
-              <a:rPr lang="en-US" sz="1300" b="1" dirty="0">
-                <a:solidFill>
-                  <a:srgbClr val="E2E8F0"/>
-                </a:solidFill>
-              </a:rPr>
-              <a:t>Crew Assembly</a:t>
-            </a:r>
-            <a:endParaRPr lang="en-US" sz="1300" dirty="0"/>
-          </a:p>
-        </p:txBody>
-      </p:sp>
-      <p:sp>
-        <p:nvSpPr>
-          <p:cNvPr id="8" name="Text 6"/>
-          <p:cNvSpPr/>
-          <p:nvPr/>
-        </p:nvSpPr>
-        <p:spPr>
-          <a:xfrm>
-            <a:off x="822960" y="2331720"/>
-            <a:ext cx="2331720" cy="274320"/>
-          </a:xfrm>
-          <a:prstGeom prst="rect">
-            <a:avLst/>
-          </a:prstGeom>
-          <a:noFill/>
-          <a:ln/>
-        </p:spPr>
-        <p:txBody>
-          <a:bodyPr wrap="square" rtlCol="0" anchor="ctr"/>
-          <a:lstStyle/>
-          <a:p>
-            <a:pPr algn="ctr" indent="0" marL="0">
-              <a:buNone/>
-            </a:pPr>
-            <a:r>
-              <a:rPr lang="en-US" sz="950" dirty="0">
-                <a:solidFill>
-                  <a:srgbClr val="94A3B8"/>
-                </a:solidFill>
-              </a:rPr>
-              <a:t>3-Emoji Keypad &amp; Roles</a:t>
-            </a:r>
-            <a:endParaRPr lang="en-US" sz="950" dirty="0"/>
-          </a:p>
-        </p:txBody>
-      </p:sp>
-      <p:sp>
-        <p:nvSpPr>
-          <p:cNvPr id="9" name="Shape 7"/>
-          <p:cNvSpPr/>
-          <p:nvPr/>
-        </p:nvSpPr>
-        <p:spPr>
-          <a:xfrm>
-            <a:off x="3465576" y="1691640"/>
-            <a:ext cx="2514600" cy="1005840"/>
+              <a:rPr lang="en-US" sz="1200" b="1" dirty="0">
+                <a:solidFill>
+                  <a:srgbClr val="FEF3C7"/>
+                </a:solidFill>
+              </a:rPr>
+              <a:t>0. Lobby Assembly</a:t>
+            </a:r>
+            <a:endParaRPr lang="en-US" sz="1200" dirty="0"/>
+          </a:p>
+        </p:txBody>
+      </p:sp>
+      <p:sp>
+        <p:nvSpPr>
+          <p:cNvPr id="13" name="Shape 11"/>
+          <p:cNvSpPr/>
+          <p:nvPr/>
+        </p:nvSpPr>
+        <p:spPr>
+          <a:xfrm>
+            <a:off x="3465576" y="5349240"/>
+            <a:ext cx="2514600" cy="731520"/>
           </a:xfrm>
           <a:prstGeom prst="roundRect">
             <a:avLst>
-              <a:gd name="adj" fmla="val 7273"/>
+              <a:gd name="adj" fmla="val 10000"/>
             </a:avLst>
           </a:prstGeom>
           <a:solidFill>
@@ -1503,14 +1837,14 @@
       </p:sp>
       <p:sp>
         <p:nvSpPr>
-          <p:cNvPr id="10" name="Text 8"/>
-          <p:cNvSpPr/>
-          <p:nvPr/>
-        </p:nvSpPr>
-        <p:spPr>
-          <a:xfrm>
-            <a:off x="3557016" y="1783080"/>
-            <a:ext cx="2331720" cy="228600"/>
+          <p:cNvPr id="14" name="Text 12"/>
+          <p:cNvSpPr/>
+          <p:nvPr/>
+        </p:nvSpPr>
+        <p:spPr>
+          <a:xfrm>
+            <a:off x="3557016" y="5486400"/>
+            <a:ext cx="2331720" cy="457200"/>
           </a:xfrm>
           <a:prstGeom prst="rect">
             <a:avLst/>
@@ -1526,103 +1860,31 @@
               <a:buNone/>
             </a:pPr>
             <a:r>
-              <a:rPr lang="en-US" sz="900" b="1" dirty="0">
-                <a:solidFill>
-                  <a:srgbClr val="F59E0B"/>
-                </a:solidFill>
-              </a:rPr>
-              <a:t>1. ROUND 1</a:t>
-            </a:r>
-            <a:endParaRPr lang="en-US" sz="900" dirty="0"/>
-          </a:p>
-        </p:txBody>
-      </p:sp>
-      <p:sp>
-        <p:nvSpPr>
-          <p:cNvPr id="11" name="Text 9"/>
-          <p:cNvSpPr/>
-          <p:nvPr/>
-        </p:nvSpPr>
-        <p:spPr>
-          <a:xfrm>
-            <a:off x="3557016" y="2011680"/>
-            <a:ext cx="2331720" cy="320040"/>
-          </a:xfrm>
-          <a:prstGeom prst="rect">
-            <a:avLst/>
-          </a:prstGeom>
-          <a:noFill/>
-          <a:ln/>
-        </p:spPr>
-        <p:txBody>
-          <a:bodyPr wrap="square" rtlCol="0" anchor="ctr"/>
-          <a:lstStyle/>
-          <a:p>
-            <a:pPr algn="ctr" indent="0" marL="0">
-              <a:buNone/>
-            </a:pPr>
-            <a:r>
-              <a:rPr lang="en-US" sz="1300" b="1" dirty="0">
-                <a:solidFill>
-                  <a:srgbClr val="E2E8F0"/>
-                </a:solidFill>
-              </a:rPr>
-              <a:t>Shattered Tablet</a:t>
-            </a:r>
-            <a:endParaRPr lang="en-US" sz="1300" dirty="0"/>
-          </a:p>
-        </p:txBody>
-      </p:sp>
-      <p:sp>
-        <p:nvSpPr>
-          <p:cNvPr id="12" name="Text 10"/>
-          <p:cNvSpPr/>
-          <p:nvPr/>
-        </p:nvSpPr>
-        <p:spPr>
-          <a:xfrm>
-            <a:off x="3557016" y="2331720"/>
-            <a:ext cx="2331720" cy="274320"/>
-          </a:xfrm>
-          <a:prstGeom prst="rect">
-            <a:avLst/>
-          </a:prstGeom>
-          <a:noFill/>
-          <a:ln/>
-        </p:spPr>
-        <p:txBody>
-          <a:bodyPr wrap="square" rtlCol="0" anchor="ctr"/>
-          <a:lstStyle/>
-          <a:p>
-            <a:pPr algn="ctr" indent="0" marL="0">
-              <a:buNone/>
-            </a:pPr>
-            <a:r>
-              <a:rPr lang="en-US" sz="950" dirty="0">
-                <a:solidFill>
-                  <a:srgbClr val="94A3B8"/>
-                </a:solidFill>
-              </a:rPr>
-              <a:t>Physical Phone Puzzle</a:t>
-            </a:r>
-            <a:endParaRPr lang="en-US" sz="950" dirty="0"/>
-          </a:p>
-        </p:txBody>
-      </p:sp>
-      <p:sp>
-        <p:nvSpPr>
-          <p:cNvPr id="13" name="Shape 11"/>
-          <p:cNvSpPr/>
-          <p:nvPr/>
-        </p:nvSpPr>
-        <p:spPr>
-          <a:xfrm>
-            <a:off x="6199632" y="1691640"/>
-            <a:ext cx="2514600" cy="1005840"/>
+              <a:rPr lang="en-US" sz="1200" b="1" dirty="0">
+                <a:solidFill>
+                  <a:srgbClr val="FEF3C7"/>
+                </a:solidFill>
+              </a:rPr>
+              <a:t>1. Shattered Tablet</a:t>
+            </a:r>
+            <a:endParaRPr lang="en-US" sz="1200" dirty="0"/>
+          </a:p>
+        </p:txBody>
+      </p:sp>
+      <p:sp>
+        <p:nvSpPr>
+          <p:cNvPr id="15" name="Shape 13"/>
+          <p:cNvSpPr/>
+          <p:nvPr/>
+        </p:nvSpPr>
+        <p:spPr>
+          <a:xfrm>
+            <a:off x="6199632" y="5349240"/>
+            <a:ext cx="2514600" cy="731520"/>
           </a:xfrm>
           <a:prstGeom prst="roundRect">
             <a:avLst>
-              <a:gd name="adj" fmla="val 7273"/>
+              <a:gd name="adj" fmla="val 10000"/>
             </a:avLst>
           </a:prstGeom>
           <a:solidFill>
@@ -1638,14 +1900,14 @@
       </p:sp>
       <p:sp>
         <p:nvSpPr>
-          <p:cNvPr id="14" name="Text 12"/>
-          <p:cNvSpPr/>
-          <p:nvPr/>
-        </p:nvSpPr>
-        <p:spPr>
-          <a:xfrm>
-            <a:off x="6291072" y="1783080"/>
-            <a:ext cx="2331720" cy="228600"/>
+          <p:cNvPr id="16" name="Text 14"/>
+          <p:cNvSpPr/>
+          <p:nvPr/>
+        </p:nvSpPr>
+        <p:spPr>
+          <a:xfrm>
+            <a:off x="6291072" y="5486400"/>
+            <a:ext cx="2331720" cy="457200"/>
           </a:xfrm>
           <a:prstGeom prst="rect">
             <a:avLst/>
@@ -1661,86 +1923,14 @@
               <a:buNone/>
             </a:pPr>
             <a:r>
-              <a:rPr lang="en-US" sz="900" b="1" dirty="0">
-                <a:solidFill>
-                  <a:srgbClr val="F59E0B"/>
-                </a:solidFill>
-              </a:rPr>
-              <a:t>2. ROUND 2</a:t>
-            </a:r>
-            <a:endParaRPr lang="en-US" sz="900" dirty="0"/>
-          </a:p>
-        </p:txBody>
-      </p:sp>
-      <p:sp>
-        <p:nvSpPr>
-          <p:cNvPr id="15" name="Text 13"/>
-          <p:cNvSpPr/>
-          <p:nvPr/>
-        </p:nvSpPr>
-        <p:spPr>
-          <a:xfrm>
-            <a:off x="6291072" y="2011680"/>
-            <a:ext cx="2331720" cy="320040"/>
-          </a:xfrm>
-          <a:prstGeom prst="rect">
-            <a:avLst/>
-          </a:prstGeom>
-          <a:noFill/>
-          <a:ln/>
-        </p:spPr>
-        <p:txBody>
-          <a:bodyPr wrap="square" rtlCol="0" anchor="ctr"/>
-          <a:lstStyle/>
-          <a:p>
-            <a:pPr algn="ctr" indent="0" marL="0">
-              <a:buNone/>
-            </a:pPr>
-            <a:r>
-              <a:rPr lang="en-US" sz="1300" b="1" dirty="0">
-                <a:solidFill>
-                  <a:srgbClr val="E2E8F0"/>
-                </a:solidFill>
-              </a:rPr>
-              <a:t>Shades in Mist</a:t>
-            </a:r>
-            <a:endParaRPr lang="en-US" sz="1300" dirty="0"/>
-          </a:p>
-        </p:txBody>
-      </p:sp>
-      <p:sp>
-        <p:nvSpPr>
-          <p:cNvPr id="16" name="Text 14"/>
-          <p:cNvSpPr/>
-          <p:nvPr/>
-        </p:nvSpPr>
-        <p:spPr>
-          <a:xfrm>
-            <a:off x="6291072" y="2331720"/>
-            <a:ext cx="2331720" cy="274320"/>
-          </a:xfrm>
-          <a:prstGeom prst="rect">
-            <a:avLst/>
-          </a:prstGeom>
-          <a:noFill/>
-          <a:ln/>
-        </p:spPr>
-        <p:txBody>
-          <a:bodyPr wrap="square" rtlCol="0" anchor="ctr"/>
-          <a:lstStyle/>
-          <a:p>
-            <a:pPr algn="ctr" indent="0" marL="0">
-              <a:buNone/>
-            </a:pPr>
-            <a:r>
-              <a:rPr lang="en-US" sz="950" dirty="0">
-                <a:solidFill>
-                  <a:srgbClr val="94A3B8"/>
-                </a:solidFill>
-              </a:rPr>
-              <a:t>Social Dilemma &amp; Bluffing</a:t>
-            </a:r>
-            <a:endParaRPr lang="en-US" sz="950" dirty="0"/>
+              <a:rPr lang="en-US" sz="1200" b="1" dirty="0">
+                <a:solidFill>
+                  <a:srgbClr val="FEF3C7"/>
+                </a:solidFill>
+              </a:rPr>
+              <a:t>2. Shades in Mist</a:t>
+            </a:r>
+            <a:endParaRPr lang="en-US" sz="1200" dirty="0"/>
           </a:p>
         </p:txBody>
       </p:sp>
@@ -1752,12 +1942,12 @@
         </p:nvSpPr>
         <p:spPr>
           <a:xfrm>
-            <a:off x="8933688" y="1691640"/>
-            <a:ext cx="2514600" cy="1005840"/>
+            <a:off x="8933688" y="5349240"/>
+            <a:ext cx="2514600" cy="731520"/>
           </a:xfrm>
           <a:prstGeom prst="roundRect">
             <a:avLst>
-              <a:gd name="adj" fmla="val 7273"/>
+              <a:gd name="adj" fmla="val 10000"/>
             </a:avLst>
           </a:prstGeom>
           <a:solidFill>
@@ -1779,8 +1969,8 @@
         </p:nvSpPr>
         <p:spPr>
           <a:xfrm>
-            <a:off x="9025128" y="1783080"/>
-            <a:ext cx="2331720" cy="228600"/>
+            <a:off x="9025128" y="5486400"/>
+            <a:ext cx="2331720" cy="457200"/>
           </a:xfrm>
           <a:prstGeom prst="rect">
             <a:avLst/>
@@ -1796,492 +1986,14 @@
               <a:buNone/>
             </a:pPr>
             <a:r>
-              <a:rPr lang="en-US" sz="900" b="1" dirty="0">
-                <a:solidFill>
-                  <a:srgbClr val="F59E0B"/>
-                </a:solidFill>
-              </a:rPr>
-              <a:t>3. ROUND 3</a:t>
-            </a:r>
-            <a:endParaRPr lang="en-US" sz="900" dirty="0"/>
-          </a:p>
-        </p:txBody>
-      </p:sp>
-      <p:sp>
-        <p:nvSpPr>
-          <p:cNvPr id="19" name="Text 17"/>
-          <p:cNvSpPr/>
-          <p:nvPr/>
-        </p:nvSpPr>
-        <p:spPr>
-          <a:xfrm>
-            <a:off x="9025128" y="2011680"/>
-            <a:ext cx="2331720" cy="320040"/>
-          </a:xfrm>
-          <a:prstGeom prst="rect">
-            <a:avLst/>
-          </a:prstGeom>
-          <a:noFill/>
-          <a:ln/>
-        </p:spPr>
-        <p:txBody>
-          <a:bodyPr wrap="square" rtlCol="0" anchor="ctr"/>
-          <a:lstStyle/>
-          <a:p>
-            <a:pPr algn="ctr" indent="0" marL="0">
-              <a:buNone/>
-            </a:pPr>
-            <a:r>
-              <a:rPr lang="en-US" sz="1300" b="1" dirty="0">
-                <a:solidFill>
-                  <a:srgbClr val="E2E8F0"/>
-                </a:solidFill>
-              </a:rPr>
-              <a:t>Styx Escape</a:t>
-            </a:r>
-            <a:endParaRPr lang="en-US" sz="1300" dirty="0"/>
-          </a:p>
-        </p:txBody>
-      </p:sp>
-      <p:sp>
-        <p:nvSpPr>
-          <p:cNvPr id="20" name="Text 18"/>
-          <p:cNvSpPr/>
-          <p:nvPr/>
-        </p:nvSpPr>
-        <p:spPr>
-          <a:xfrm>
-            <a:off x="9025128" y="2331720"/>
-            <a:ext cx="2331720" cy="274320"/>
-          </a:xfrm>
-          <a:prstGeom prst="rect">
-            <a:avLst/>
-          </a:prstGeom>
-          <a:noFill/>
-          <a:ln/>
-        </p:spPr>
-        <p:txBody>
-          <a:bodyPr wrap="square" rtlCol="0" anchor="ctr"/>
-          <a:lstStyle/>
-          <a:p>
-            <a:pPr algn="ctr" indent="0" marL="0">
-              <a:buNone/>
-            </a:pPr>
-            <a:r>
-              <a:rPr lang="en-US" sz="950" dirty="0">
-                <a:solidFill>
-                  <a:srgbClr val="94A3B8"/>
-                </a:solidFill>
-              </a:rPr>
-              <a:t>1,000m Vessel Royale</a:t>
-            </a:r>
-            <a:endParaRPr lang="en-US" sz="950" dirty="0"/>
-          </a:p>
-        </p:txBody>
-      </p:sp>
-      <p:sp>
-        <p:nvSpPr>
-          <p:cNvPr id="21" name="Shape 19"/>
-          <p:cNvSpPr/>
-          <p:nvPr/>
-        </p:nvSpPr>
-        <p:spPr>
-          <a:xfrm>
-            <a:off x="731520" y="2926080"/>
-            <a:ext cx="5257800" cy="3337560"/>
-          </a:xfrm>
-          <a:prstGeom prst="roundRect">
-            <a:avLst>
-              <a:gd name="adj" fmla="val 2192"/>
-            </a:avLst>
-          </a:prstGeom>
-          <a:solidFill>
-            <a:srgbClr val="141A2A"/>
-          </a:solidFill>
-          <a:ln w="12700">
-            <a:solidFill>
-              <a:srgbClr val="334155"/>
-            </a:solidFill>
-            <a:prstDash val="solid"/>
-          </a:ln>
-        </p:spPr>
-      </p:sp>
-      <p:sp>
-        <p:nvSpPr>
-          <p:cNvPr id="22" name="Text 20"/>
-          <p:cNvSpPr/>
-          <p:nvPr/>
-        </p:nvSpPr>
-        <p:spPr>
-          <a:xfrm>
-            <a:off x="960120" y="3108960"/>
-            <a:ext cx="4800600" cy="365760"/>
-          </a:xfrm>
-          <a:prstGeom prst="rect">
-            <a:avLst/>
-          </a:prstGeom>
-          <a:noFill/>
-          <a:ln/>
-        </p:spPr>
-        <p:txBody>
-          <a:bodyPr wrap="square" rtlCol="0" anchor="ctr"/>
-          <a:lstStyle/>
-          <a:p>
-            <a:pPr indent="0" marL="0">
-              <a:buNone/>
-            </a:pPr>
-            <a:r>
-              <a:rPr lang="en-US" sz="1600" b="1" dirty="0">
+              <a:rPr lang="en-US" sz="1200" b="1" dirty="0">
                 <a:solidFill>
                   <a:srgbClr val="FEF3C7"/>
                 </a:solidFill>
               </a:rPr>
-              <a:t>👥 The 5-Player Crews</a:t>
-            </a:r>
-            <a:endParaRPr lang="en-US" sz="1600" dirty="0"/>
-          </a:p>
-        </p:txBody>
-      </p:sp>
-      <p:sp>
-        <p:nvSpPr>
-          <p:cNvPr id="23" name="Text 21"/>
-          <p:cNvSpPr/>
-          <p:nvPr/>
-        </p:nvSpPr>
-        <p:spPr>
-          <a:xfrm>
-            <a:off x="960120" y="3566160"/>
-            <a:ext cx="4800600" cy="2560320"/>
-          </a:xfrm>
-          <a:prstGeom prst="rect">
-            <a:avLst/>
-          </a:prstGeom>
-          <a:noFill/>
-          <a:ln/>
-        </p:spPr>
-        <p:txBody>
-          <a:bodyPr wrap="square" rtlCol="0" anchor="ctr"/>
-          <a:lstStyle/>
-          <a:p>
-            <a:pPr indent="0" marL="0">
-              <a:lnSpc>
-                <a:spcPct val="115000"/>
-              </a:lnSpc>
-              <a:buNone/>
-            </a:pPr>
-            <a:r>
-              <a:rPr lang="en-US" sz="1150" b="1" dirty="0">
-                <a:solidFill>
-                  <a:srgbClr val="E2E8F0"/>
-                </a:solidFill>
-              </a:rPr>
-              <a:t>• 5 Distinct Roles: </a:t>
-            </a:r>
-            <a:pPr indent="0" marL="0">
-              <a:lnSpc>
-                <a:spcPct val="115000"/>
-              </a:lnSpc>
-              <a:buNone/>
-            </a:pPr>
-            <a:r>
-              <a:rPr lang="en-US" sz="1150" dirty="0">
-                <a:solidFill>
-                  <a:srgbClr val="94A3B8"/>
-                </a:solidFill>
-              </a:rPr>
-              <a:t>Navigator, Oracle, Scholar, Torchbearer, Negotiator.
-</a:t>
-            </a:r>
-            <a:pPr indent="0" marL="0">
-              <a:lnSpc>
-                <a:spcPct val="115000"/>
-              </a:lnSpc>
-              <a:buNone/>
-            </a:pPr>
-            <a:r>
-              <a:rPr lang="en-US" sz="1150" b="1" dirty="0">
-                <a:solidFill>
-                  <a:srgbClr val="E2E8F0"/>
-                </a:solidFill>
-              </a:rPr>
-              <a:t>• Simple Identity (No Complex Powers): </a:t>
-            </a:r>
-            <a:pPr indent="0" marL="0">
-              <a:lnSpc>
-                <a:spcPct val="115000"/>
-              </a:lnSpc>
-              <a:buNone/>
-            </a:pPr>
-            <a:r>
-              <a:rPr lang="en-US" sz="1150" dirty="0">
-                <a:solidFill>
-                  <a:srgbClr val="94A3B8"/>
-                </a:solidFill>
-              </a:rPr>
-              <a:t>Roles serve as crew member identities and tablet puzzle slots. Players don't need to learn complicated abilities.
-</a:t>
-            </a:r>
-            <a:pPr indent="0" marL="0">
-              <a:lnSpc>
-                <a:spcPct val="115000"/>
-              </a:lnSpc>
-              <a:buNone/>
-            </a:pPr>
-            <a:r>
-              <a:rPr lang="en-US" sz="1150" b="1" dirty="0">
-                <a:solidFill>
-                  <a:srgbClr val="E2E8F0"/>
-                </a:solidFill>
-              </a:rPr>
-              <a:t>• 1-Tap Emoji Joining: </a:t>
-            </a:r>
-            <a:pPr indent="0" marL="0">
-              <a:lnSpc>
-                <a:spcPct val="115000"/>
-              </a:lnSpc>
-              <a:buNone/>
-            </a:pPr>
-            <a:r>
-              <a:rPr lang="en-US" sz="1150" dirty="0">
-                <a:solidFill>
-                  <a:srgbClr val="94A3B8"/>
-                </a:solidFill>
-              </a:rPr>
-              <a:t>One player creates the crew; teammates join by tapping 3 emojis on screen (e.g. Skull • Bolt • Shield).
-</a:t>
-            </a:r>
-            <a:pPr indent="0" marL="0">
-              <a:lnSpc>
-                <a:spcPct val="115000"/>
-              </a:lnSpc>
-              <a:buNone/>
-            </a:pPr>
-            <a:r>
-              <a:rPr lang="en-US" sz="1150" b="1" dirty="0">
-                <a:solidFill>
-                  <a:srgbClr val="E2E8F0"/>
-                </a:solidFill>
-              </a:rPr>
-              <a:t>• Zero Friction: </a:t>
-            </a:r>
-            <a:pPr indent="0" marL="0">
-              <a:lnSpc>
-                <a:spcPct val="115000"/>
-              </a:lnSpc>
-              <a:buNone/>
-            </a:pPr>
-            <a:r>
-              <a:rPr lang="en-US" sz="1150" dirty="0">
-                <a:solidFill>
-                  <a:srgbClr val="10B981"/>
-                </a:solidFill>
-              </a:rPr>
-              <a:t>No app to download, no typing, no camera permissions.</a:t>
-            </a:r>
-            <a:endParaRPr lang="en-US" sz="1150" dirty="0"/>
-          </a:p>
-        </p:txBody>
-      </p:sp>
-      <p:sp>
-        <p:nvSpPr>
-          <p:cNvPr id="24" name="Shape 22"/>
-          <p:cNvSpPr/>
-          <p:nvPr/>
-        </p:nvSpPr>
-        <p:spPr>
-          <a:xfrm>
-            <a:off x="6199632" y="2926080"/>
-            <a:ext cx="5257800" cy="3337560"/>
-          </a:xfrm>
-          <a:prstGeom prst="roundRect">
-            <a:avLst>
-              <a:gd name="adj" fmla="val 2192"/>
-            </a:avLst>
-          </a:prstGeom>
-          <a:solidFill>
-            <a:srgbClr val="141A2A"/>
-          </a:solidFill>
-          <a:ln w="12700">
-            <a:solidFill>
-              <a:srgbClr val="334155"/>
-            </a:solidFill>
-            <a:prstDash val="solid"/>
-          </a:ln>
-        </p:spPr>
-      </p:sp>
-      <p:sp>
-        <p:nvSpPr>
-          <p:cNvPr id="25" name="Text 23"/>
-          <p:cNvSpPr/>
-          <p:nvPr/>
-        </p:nvSpPr>
-        <p:spPr>
-          <a:xfrm>
-            <a:off x="6428232" y="3108960"/>
-            <a:ext cx="4800600" cy="365760"/>
-          </a:xfrm>
-          <a:prstGeom prst="rect">
-            <a:avLst/>
-          </a:prstGeom>
-          <a:noFill/>
-          <a:ln/>
-        </p:spPr>
-        <p:txBody>
-          <a:bodyPr wrap="square" rtlCol="0" anchor="ctr"/>
-          <a:lstStyle/>
-          <a:p>
-            <a:pPr indent="0" marL="0">
-              <a:buNone/>
-            </a:pPr>
-            <a:r>
-              <a:rPr lang="en-US" sz="1600" b="1" dirty="0">
-                <a:solidFill>
-                  <a:srgbClr val="FEF3C7"/>
-                </a:solidFill>
-              </a:rPr>
-              <a:t>🏆 The Ultimate Objective</a:t>
-            </a:r>
-            <a:endParaRPr lang="en-US" sz="1600" dirty="0"/>
-          </a:p>
-        </p:txBody>
-      </p:sp>
-      <p:sp>
-        <p:nvSpPr>
-          <p:cNvPr id="26" name="Text 24"/>
-          <p:cNvSpPr/>
-          <p:nvPr/>
-        </p:nvSpPr>
-        <p:spPr>
-          <a:xfrm>
-            <a:off x="6428232" y="3566160"/>
-            <a:ext cx="4800600" cy="2560320"/>
-          </a:xfrm>
-          <a:prstGeom prst="rect">
-            <a:avLst/>
-          </a:prstGeom>
-          <a:noFill/>
-          <a:ln/>
-        </p:spPr>
-        <p:txBody>
-          <a:bodyPr wrap="square" rtlCol="0" anchor="ctr"/>
-          <a:lstStyle/>
-          <a:p>
-            <a:pPr indent="0" marL="0">
-              <a:lnSpc>
-                <a:spcPct val="115000"/>
-              </a:lnSpc>
-              <a:buNone/>
-            </a:pPr>
-            <a:r>
-              <a:rPr lang="en-US" sz="1150" b="1" dirty="0">
-                <a:solidFill>
-                  <a:srgbClr val="E2E8F0"/>
-                </a:solidFill>
-              </a:rPr>
-              <a:t>• Rounds 1 &amp; 2 (Points Pool): </a:t>
-            </a:r>
-            <a:pPr indent="0" marL="0">
-              <a:lnSpc>
-                <a:spcPct val="115000"/>
-              </a:lnSpc>
-              <a:buNone/>
-            </a:pPr>
-            <a:r>
-              <a:rPr lang="en-US" sz="1150" dirty="0">
-                <a:solidFill>
-                  <a:srgbClr val="94A3B8"/>
-                </a:solidFill>
-              </a:rPr>
-              <a:t>Earn points through team physical coordination and tactical room psychology.
-</a:t>
-            </a:r>
-            <a:pPr indent="0" marL="0">
-              <a:lnSpc>
-                <a:spcPct val="115000"/>
-              </a:lnSpc>
-              <a:buNone/>
-            </a:pPr>
-            <a:r>
-              <a:rPr lang="en-US" sz="1150" b="1" dirty="0">
-                <a:solidFill>
-                  <a:srgbClr val="E2E8F0"/>
-                </a:solidFill>
-              </a:rPr>
-              <a:t>• Starting Head-Start: </a:t>
-            </a:r>
-            <a:pPr indent="0" marL="0">
-              <a:lnSpc>
-                <a:spcPct val="115000"/>
-              </a:lnSpc>
-              <a:buNone/>
-            </a:pPr>
-            <a:r>
-              <a:rPr lang="en-US" sz="1150" dirty="0">
-                <a:solidFill>
-                  <a:srgbClr val="94A3B8"/>
-                </a:solidFill>
-              </a:rPr>
-              <a:t>Cumulative points convert directly into starting distance meters on the River Styx in Round 3!
-</a:t>
-            </a:r>
-            <a:pPr indent="0" marL="0">
-              <a:lnSpc>
-                <a:spcPct val="115000"/>
-              </a:lnSpc>
-              <a:buNone/>
-            </a:pPr>
-            <a:r>
-              <a:rPr lang="en-US" sz="1150" b="1" dirty="0">
-                <a:solidFill>
-                  <a:srgbClr val="E2E8F0"/>
-                </a:solidFill>
-              </a:rPr>
-              <a:t>• Podium Victory: </a:t>
-            </a:r>
-            <a:pPr indent="0" marL="0">
-              <a:lnSpc>
-                <a:spcPct val="115000"/>
-              </a:lnSpc>
-              <a:buNone/>
-            </a:pPr>
-            <a:r>
-              <a:rPr lang="en-US" sz="1150" dirty="0">
-                <a:solidFill>
-                  <a:srgbClr val="F59E0B"/>
-                </a:solidFill>
-              </a:rPr>
-              <a:t>First 3 crews to cross the 1,000-meter exit portal win Gold, Silver, and Bronze medals.
-</a:t>
-            </a:r>
-            <a:pPr indent="0" marL="0">
-              <a:lnSpc>
-                <a:spcPct val="115000"/>
-              </a:lnSpc>
-              <a:buNone/>
-            </a:pPr>
-            <a:r>
-              <a:rPr lang="en-US" sz="1150" b="1" dirty="0">
-                <a:solidFill>
-                  <a:srgbClr val="E2E8F0"/>
-                </a:solidFill>
-              </a:rPr>
-              <a:t>• Fast &amp; Social: </a:t>
-            </a:r>
-            <a:pPr indent="0" marL="0">
-              <a:lnSpc>
-                <a:spcPct val="115000"/>
-              </a:lnSpc>
-              <a:buNone/>
-            </a:pPr>
-            <a:r>
-              <a:rPr lang="en-US" sz="1150" dirty="0">
-                <a:solidFill>
-                  <a:srgbClr val="94A3B8"/>
-                </a:solidFill>
-              </a:rPr>
-              <a:t>The whole experience runs in ~25-30 minutes of high-energy pub interaction.</a:t>
-            </a:r>
-            <a:endParaRPr lang="en-US" sz="1150" dirty="0"/>
+              <a:t>3. Styx Escape</a:t>
+            </a:r>
+            <a:endParaRPr lang="en-US" sz="1200" dirty="0"/>
           </a:p>
         </p:txBody>
       </p:sp>
@@ -2326,7 +2038,7 @@
         <p:spPr>
           <a:xfrm>
             <a:off x="731520" y="411480"/>
-            <a:ext cx="7315200" cy="274320"/>
+            <a:ext cx="7315200" cy="256032"/>
           </a:xfrm>
           <a:prstGeom prst="rect">
             <a:avLst/>
@@ -2361,8 +2073,8 @@
         </p:nvSpPr>
         <p:spPr>
           <a:xfrm>
-            <a:off x="731520" y="685800"/>
-            <a:ext cx="10698480" cy="548640"/>
+            <a:off x="731520" y="658368"/>
+            <a:ext cx="10725912" cy="502920"/>
           </a:xfrm>
           <a:prstGeom prst="rect">
             <a:avLst/>
@@ -2397,8 +2109,8 @@
         </p:nvSpPr>
         <p:spPr>
           <a:xfrm>
-            <a:off x="731520" y="1234440"/>
-            <a:ext cx="10698480" cy="320040"/>
+            <a:off x="731520" y="1170432"/>
+            <a:ext cx="10725912" cy="292608"/>
           </a:xfrm>
           <a:prstGeom prst="rect">
             <a:avLst/>
@@ -2433,12 +2145,73 @@
         </p:nvSpPr>
         <p:spPr>
           <a:xfrm>
-            <a:off x="731520" y="1691640"/>
-            <a:ext cx="5257800" cy="3886200"/>
+            <a:off x="731520" y="1572768"/>
+            <a:ext cx="10725912" cy="594360"/>
+          </a:xfrm>
+          <a:prstGeom prst="rect">
+            <a:avLst/>
+          </a:prstGeom>
+          <a:solidFill>
+            <a:srgbClr val="182033"/>
+          </a:solidFill>
+          <a:ln w="19050">
+            <a:solidFill>
+              <a:srgbClr val="06B6D4"/>
+            </a:solidFill>
+            <a:prstDash val="solid"/>
+          </a:ln>
+        </p:spPr>
+      </p:sp>
+      <p:sp>
+        <p:nvSpPr>
+          <p:cNvPr id="6" name="Text 4"/>
+          <p:cNvSpPr/>
+          <p:nvPr/>
+        </p:nvSpPr>
+        <p:spPr>
+          <a:xfrm>
+            <a:off x="914400" y="1618488"/>
+            <a:ext cx="10360152" cy="502920"/>
+          </a:xfrm>
+          <a:prstGeom prst="rect">
+            <a:avLst/>
+          </a:prstGeom>
+          <a:noFill/>
+          <a:ln/>
+        </p:spPr>
+        <p:txBody>
+          <a:bodyPr wrap="square" rtlCol="0" anchor="ctr"/>
+          <a:lstStyle/>
+          <a:p>
+            <a:pPr indent="0" marL="0">
+              <a:buNone/>
+            </a:pPr>
+            <a:r>
+              <a:rPr lang="en-US" sz="1100" i="1" dirty="0">
+                <a:solidFill>
+                  <a:srgbClr val="FEF3C7"/>
+                </a:solidFill>
+              </a:rPr>
+              <a:t>🏛️ The Story: Walking through the dark expanse of Tartarus, your crew reaches a sealed ancient stone door. You need a codeword to pass. Pieces of a shattered ancient tablet lie on the ground before you.</a:t>
+            </a:r>
+            <a:endParaRPr lang="en-US" sz="1100" dirty="0"/>
+          </a:p>
+        </p:txBody>
+      </p:sp>
+      <p:sp>
+        <p:nvSpPr>
+          <p:cNvPr id="7" name="Shape 5"/>
+          <p:cNvSpPr/>
+          <p:nvPr/>
+        </p:nvSpPr>
+        <p:spPr>
+          <a:xfrm>
+            <a:off x="731520" y="2331720"/>
+            <a:ext cx="5257800" cy="3794760"/>
           </a:xfrm>
           <a:prstGeom prst="roundRect">
             <a:avLst>
-              <a:gd name="adj" fmla="val 1882"/>
+              <a:gd name="adj" fmla="val 1928"/>
             </a:avLst>
           </a:prstGeom>
           <a:solidFill>
@@ -2454,13 +2227,13 @@
       </p:sp>
       <p:sp>
         <p:nvSpPr>
-          <p:cNvPr id="6" name="Text 4"/>
-          <p:cNvSpPr/>
-          <p:nvPr/>
-        </p:nvSpPr>
-        <p:spPr>
-          <a:xfrm>
-            <a:off x="960120" y="1874520"/>
+          <p:cNvPr id="8" name="Text 6"/>
+          <p:cNvSpPr/>
+          <p:nvPr/>
+        </p:nvSpPr>
+        <p:spPr>
+          <a:xfrm>
+            <a:off x="960120" y="2514600"/>
             <a:ext cx="4800600" cy="365760"/>
           </a:xfrm>
           <a:prstGeom prst="rect">
@@ -2482,7 +2255,7 @@
                   <a:srgbClr val="FEF3C7"/>
                 </a:solidFill>
               </a:rPr>
-              <a:t>🧩 The Story &amp; Mechanic</a:t>
+              <a:t>⚙️ Mechanics</a:t>
             </a:r>
             <a:endParaRPr lang="en-US" sz="1600" dirty="0"/>
           </a:p>
@@ -2490,14 +2263,14 @@
       </p:sp>
       <p:sp>
         <p:nvSpPr>
-          <p:cNvPr id="7" name="Text 5"/>
-          <p:cNvSpPr/>
-          <p:nvPr/>
-        </p:nvSpPr>
-        <p:spPr>
-          <a:xfrm>
-            <a:off x="960120" y="2331720"/>
-            <a:ext cx="4800600" cy="3017520"/>
+          <p:cNvPr id="9" name="Text 7"/>
+          <p:cNvSpPr/>
+          <p:nvPr/>
+        </p:nvSpPr>
+        <p:spPr>
+          <a:xfrm>
+            <a:off x="960120" y="2971800"/>
+            <a:ext cx="4800600" cy="2926080"/>
           </a:xfrm>
           <a:prstGeom prst="rect">
             <a:avLst/>
@@ -2521,35 +2294,6 @@
                   <a:srgbClr val="E2E8F0"/>
                 </a:solidFill>
               </a:rPr>
-              <a:t>• The Setup: </a:t>
-            </a:r>
-            <a:pPr indent="0" marL="0">
-              <a:lnSpc>
-                <a:spcPct val="115000"/>
-              </a:lnSpc>
-              <a:buNone/>
-            </a:pPr>
-            <a:r>
-              <a:rPr lang="en-US" sz="1150" dirty="0">
-                <a:solidFill>
-                  <a:srgbClr val="94A3B8"/>
-                </a:solidFill>
-              </a:rPr>
-              <a:t>A locked ancient tomb door blocks Tartarus. A shattered stone tablet lies in front of you.
-</a:t>
-            </a:r>
-            <a:pPr indent="0" marL="0">
-              <a:lnSpc>
-                <a:spcPct val="115000"/>
-              </a:lnSpc>
-              <a:buNone/>
-            </a:pPr>
-            <a:r>
-              <a:rPr lang="en-US" sz="1150" b="1" dirty="0">
-                <a:solidFill>
-                  <a:srgbClr val="E2E8F0"/>
-                </a:solidFill>
-              </a:rPr>
               <a:t>• 5 Slices on 5 Phones: </a:t>
             </a:r>
             <a:pPr indent="0" marL="0">
@@ -2579,7 +2323,7 @@
                   <a:srgbClr val="E2E8F0"/>
                 </a:solidFill>
               </a:rPr>
-              <a:t>• Physical Arrangement: </a:t>
+              <a:t>• Physical Phone Order: </a:t>
             </a:r>
             <a:pPr indent="0" marL="0">
               <a:lnSpc>
@@ -2593,7 +2337,7 @@
                   <a:srgbClr val="94A3B8"/>
                 </a:solidFill>
               </a:rPr>
-              <a:t>Players must physically place their 5 phones side-by-side in numerical order (#1 to #5) across the table.
+              <a:t>Players physically place their 5 phones side-by-side in numerical order (#1 to #5) across the table.
 </a:t>
             </a:r>
             <a:pPr indent="0" marL="0">
@@ -2608,7 +2352,7 @@
                   <a:srgbClr val="E2E8F0"/>
                 </a:solidFill>
               </a:rPr>
-              <a:t>• The Clue: </a:t>
+              <a:t>• The Codeword: </a:t>
             </a:r>
             <a:pPr indent="0" marL="0">
               <a:lnSpc>
@@ -2622,7 +2366,36 @@
                   <a:srgbClr val="F59E0B"/>
                 </a:solidFill>
               </a:rPr>
-              <a:t>Golden fracture lines connect across phone borders to reveal a 2-word codeword (e.g. CRIMSON SHADOW).</a:t>
+              <a:t>Golden carved fracture lines connect across phone borders to reveal a 2-word codeword (e.g. CRIMSON SHADOW).
+</a:t>
+            </a:r>
+            <a:pPr indent="0" marL="0">
+              <a:lnSpc>
+                <a:spcPct val="115000"/>
+              </a:lnSpc>
+              <a:buNone/>
+            </a:pPr>
+            <a:r>
+              <a:rPr lang="en-US" sz="1150" b="1" dirty="0">
+                <a:solidFill>
+                  <a:srgbClr val="E2E8F0"/>
+                </a:solidFill>
+              </a:rPr>
+              <a:t>• Team Submission: </a:t>
+            </a:r>
+            <a:pPr indent="0" marL="0">
+              <a:lnSpc>
+                <a:spcPct val="115000"/>
+              </a:lnSpc>
+              <a:buNone/>
+            </a:pPr>
+            <a:r>
+              <a:rPr lang="en-US" sz="1150" dirty="0">
+                <a:solidFill>
+                  <a:srgbClr val="E2E8F0"/>
+                </a:solidFill>
+              </a:rPr>
+              <a:t>Any player in the crew can type and submit the answer on their screen.</a:t>
             </a:r>
             <a:endParaRPr lang="en-US" sz="1150" dirty="0"/>
           </a:p>
@@ -2630,18 +2403,18 @@
       </p:sp>
       <p:sp>
         <p:nvSpPr>
-          <p:cNvPr id="8" name="Shape 6"/>
-          <p:cNvSpPr/>
-          <p:nvPr/>
-        </p:nvSpPr>
-        <p:spPr>
-          <a:xfrm>
-            <a:off x="6199632" y="1691640"/>
-            <a:ext cx="5257800" cy="3886200"/>
+          <p:cNvPr id="10" name="Shape 8"/>
+          <p:cNvSpPr/>
+          <p:nvPr/>
+        </p:nvSpPr>
+        <p:spPr>
+          <a:xfrm>
+            <a:off x="6199632" y="2331720"/>
+            <a:ext cx="5257800" cy="3794760"/>
           </a:xfrm>
           <a:prstGeom prst="roundRect">
             <a:avLst>
-              <a:gd name="adj" fmla="val 1882"/>
+              <a:gd name="adj" fmla="val 1928"/>
             </a:avLst>
           </a:prstGeom>
           <a:solidFill>
@@ -2657,13 +2430,13 @@
       </p:sp>
       <p:sp>
         <p:nvSpPr>
-          <p:cNvPr id="9" name="Text 7"/>
-          <p:cNvSpPr/>
-          <p:nvPr/>
-        </p:nvSpPr>
-        <p:spPr>
-          <a:xfrm>
-            <a:off x="6428232" y="1874520"/>
+          <p:cNvPr id="11" name="Text 9"/>
+          <p:cNvSpPr/>
+          <p:nvPr/>
+        </p:nvSpPr>
+        <p:spPr>
+          <a:xfrm>
+            <a:off x="6428232" y="2514600"/>
             <a:ext cx="4800600" cy="365760"/>
           </a:xfrm>
           <a:prstGeom prst="rect">
@@ -2685,7 +2458,7 @@
                   <a:srgbClr val="FEF3C7"/>
                 </a:solidFill>
               </a:rPr>
-              <a:t>⏱️ Points &amp; Progressive Hints</a:t>
+              <a:t>🏆 Points &amp; Winning Conditions</a:t>
             </a:r>
             <a:endParaRPr lang="en-US" sz="1600" dirty="0"/>
           </a:p>
@@ -2693,14 +2466,14 @@
       </p:sp>
       <p:sp>
         <p:nvSpPr>
-          <p:cNvPr id="10" name="Text 8"/>
-          <p:cNvSpPr/>
-          <p:nvPr/>
-        </p:nvSpPr>
-        <p:spPr>
-          <a:xfrm>
-            <a:off x="6428232" y="2331720"/>
-            <a:ext cx="4800600" cy="3017520"/>
+          <p:cNvPr id="12" name="Text 10"/>
+          <p:cNvSpPr/>
+          <p:nvPr/>
+        </p:nvSpPr>
+        <p:spPr>
+          <a:xfrm>
+            <a:off x="6428232" y="2971800"/>
+            <a:ext cx="4800600" cy="2926080"/>
           </a:xfrm>
           <a:prstGeom prst="rect">
             <a:avLst/>
@@ -2738,7 +2511,7 @@
                   <a:srgbClr val="94A3B8"/>
                 </a:solidFill>
               </a:rPr>
-              <a:t>Faster team solves earn higher base points (Legendary $\rightarrow$ Swift $\rightarrow$ Steady).
+              <a:t>Faster team solves earn higher base points (Legendary → Swift → Steady).
 </a:t>
             </a:r>
             <a:pPr indent="0" marL="0">
@@ -2753,7 +2526,7 @@
                   <a:srgbClr val="E2E8F0"/>
                 </a:solidFill>
               </a:rPr>
-              <a:t>• Any Player Can Submit: </a:t>
+              <a:t>• Guaranteed Safety Floor: </a:t>
             </a:r>
             <a:pPr indent="0" marL="0">
               <a:lnSpc>
@@ -2764,10 +2537,39 @@
             <a:r>
               <a:rPr lang="en-US" sz="1150" dirty="0">
                 <a:solidFill>
+                  <a:srgbClr val="10B981"/>
+                </a:solidFill>
+              </a:rPr>
+              <a:t>A 50 PTS minimum floor ensures every crew passes through the tomb gate.
+</a:t>
+            </a:r>
+            <a:pPr indent="0" marL="0">
+              <a:lnSpc>
+                <a:spcPct val="115000"/>
+              </a:lnSpc>
+              <a:buNone/>
+            </a:pPr>
+            <a:r>
+              <a:rPr lang="en-US" sz="1150" b="1" dirty="0">
+                <a:solidFill>
+                  <a:srgbClr val="E2E8F0"/>
+                </a:solidFill>
+              </a:rPr>
+              <a:t>• Round Completion: </a:t>
+            </a:r>
+            <a:pPr indent="0" marL="0">
+              <a:lnSpc>
+                <a:spcPct val="115000"/>
+              </a:lnSpc>
+              <a:buNone/>
+            </a:pPr>
+            <a:r>
+              <a:rPr lang="en-US" sz="1150" dirty="0">
+                <a:solidFill>
                   <a:srgbClr val="94A3B8"/>
                 </a:solidFill>
               </a:rPr>
-              <a:t>Once solved, any teammate can type and submit the codeword on their screen.
+              <a:t>The round ends when all crews submit the code or the timer concludes.
 </a:t>
             </a:r>
             <a:pPr indent="0" marL="0">
@@ -2779,10 +2581,10 @@
             <a:r>
               <a:rPr lang="en-US" sz="1150" b="1" dirty="0">
                 <a:solidFill>
-                  <a:srgbClr val="E2E8F0"/>
-                </a:solidFill>
-              </a:rPr>
-              <a:t>• Progressive Hints: </a:t>
+                  <a:srgbClr val="F59E0B"/>
+                </a:solidFill>
+              </a:rPr>
+              <a:t>💡 Facilitator Prompt: </a:t>
             </a:r>
             <a:pPr indent="0" marL="0">
               <a:lnSpc>
@@ -2793,102 +2595,12 @@
             <a:r>
               <a:rPr lang="en-US" sz="1150" dirty="0">
                 <a:solidFill>
-                  <a:srgbClr val="94A3B8"/>
-                </a:solidFill>
-              </a:rPr>
-              <a:t>Hints unlock at 2m, 3m, and 4m pinpointing who holds the left (#1), right (#5), and center (#3) pieces (-30 PTS penalty each).
-</a:t>
-            </a:r>
-            <a:pPr indent="0" marL="0">
-              <a:lnSpc>
-                <a:spcPct val="115000"/>
-              </a:lnSpc>
-              <a:buNone/>
-            </a:pPr>
-            <a:r>
-              <a:rPr lang="en-US" sz="1150" b="1" dirty="0">
-                <a:solidFill>
-                  <a:srgbClr val="E2E8F0"/>
-                </a:solidFill>
-              </a:rPr>
-              <a:t>• Safety Net: </a:t>
-            </a:r>
-            <a:pPr indent="0" marL="0">
-              <a:lnSpc>
-                <a:spcPct val="115000"/>
-              </a:lnSpc>
-              <a:buNone/>
-            </a:pPr>
-            <a:r>
-              <a:rPr lang="en-US" sz="1150" dirty="0">
-                <a:solidFill>
-                  <a:srgbClr val="10B981"/>
-                </a:solidFill>
-              </a:rPr>
-              <a:t>50 PTS guaranteed floor ensures every crew passes through the door.</a:t>
+                  <a:srgbClr val="FEF3C7"/>
+                </a:solidFill>
+              </a:rPr>
+              <a:t>"Don't stay seated staring at your own screen—stand up, place your 5 phones in order 1 to 5, and read the tablet together!"</a:t>
             </a:r>
             <a:endParaRPr lang="en-US" sz="1150" dirty="0"/>
-          </a:p>
-        </p:txBody>
-      </p:sp>
-      <p:sp>
-        <p:nvSpPr>
-          <p:cNvPr id="11" name="Shape 9"/>
-          <p:cNvSpPr/>
-          <p:nvPr/>
-        </p:nvSpPr>
-        <p:spPr>
-          <a:xfrm>
-            <a:off x="731520" y="5760720"/>
-            <a:ext cx="10725912" cy="594360"/>
-          </a:xfrm>
-          <a:prstGeom prst="rect">
-            <a:avLst/>
-          </a:prstGeom>
-          <a:solidFill>
-            <a:srgbClr val="1E293B"/>
-          </a:solidFill>
-          <a:ln w="12700">
-            <a:solidFill>
-              <a:srgbClr val="06B6D4"/>
-            </a:solidFill>
-            <a:prstDash val="solid"/>
-          </a:ln>
-        </p:spPr>
-      </p:sp>
-      <p:sp>
-        <p:nvSpPr>
-          <p:cNvPr id="12" name="Text 10"/>
-          <p:cNvSpPr/>
-          <p:nvPr/>
-        </p:nvSpPr>
-        <p:spPr>
-          <a:xfrm>
-            <a:off x="914400" y="5870448"/>
-            <a:ext cx="10360152" cy="365760"/>
-          </a:xfrm>
-          <a:prstGeom prst="rect">
-            <a:avLst/>
-          </a:prstGeom>
-          <a:noFill/>
-          <a:ln/>
-        </p:spPr>
-        <p:txBody>
-          <a:bodyPr wrap="square" rtlCol="0" anchor="ctr"/>
-          <a:lstStyle/>
-          <a:p>
-            <a:pPr algn="ctr" indent="0" marL="0">
-              <a:buNone/>
-            </a:pPr>
-            <a:r>
-              <a:rPr lang="en-US" sz="1100" b="1" dirty="0">
-                <a:solidFill>
-                  <a:srgbClr val="FEF3C7"/>
-                </a:solidFill>
-              </a:rPr>
-              <a:t>💡 Facilitator Cue: "Don't stay seated staring at your own screen—stand up, place your 5 phones in order 1 to 5, and read the tablet together!"</a:t>
-            </a:r>
-            <a:endParaRPr lang="en-US" sz="1100" dirty="0"/>
           </a:p>
         </p:txBody>
       </p:sp>
@@ -2933,7 +2645,7 @@
         <p:spPr>
           <a:xfrm>
             <a:off x="731520" y="411480"/>
-            <a:ext cx="7315200" cy="274320"/>
+            <a:ext cx="7315200" cy="256032"/>
           </a:xfrm>
           <a:prstGeom prst="rect">
             <a:avLst/>
@@ -2954,7 +2666,7 @@
                   <a:srgbClr val="F43F5E"/>
                 </a:solidFill>
               </a:rPr>
-              <a:t>ROUND 2 • SOCIAL DILEMMA &amp; BLUFFING</a:t>
+              <a:t>ROUND 2 • PRISONER'S DILEMMA</a:t>
             </a:r>
             <a:endParaRPr lang="en-US" sz="1000" dirty="0"/>
           </a:p>
@@ -2968,8 +2680,8 @@
         </p:nvSpPr>
         <p:spPr>
           <a:xfrm>
-            <a:off x="731520" y="685800"/>
-            <a:ext cx="10698480" cy="548640"/>
+            <a:off x="731520" y="658368"/>
+            <a:ext cx="10725912" cy="502920"/>
           </a:xfrm>
           <a:prstGeom prst="rect">
             <a:avLst/>
@@ -3004,8 +2716,8 @@
         </p:nvSpPr>
         <p:spPr>
           <a:xfrm>
-            <a:off x="731520" y="1234440"/>
-            <a:ext cx="10698480" cy="320040"/>
+            <a:off x="731520" y="1170432"/>
+            <a:ext cx="10725912" cy="292608"/>
           </a:xfrm>
           <a:prstGeom prst="rect">
             <a:avLst/>
@@ -3026,7 +2738,7 @@
                   <a:srgbClr val="94A3B8"/>
                 </a:solidFill>
               </a:rPr>
-              <a:t>3 Clashes vs Rival Table • Face-to-Face Negotiation • Bluffing Allowed</a:t>
+              <a:t>Prisoner's Dilemma • 3 Clashes • Face-to-Face Negotiation</a:t>
             </a:r>
             <a:endParaRPr lang="en-US" sz="1200" dirty="0"/>
           </a:p>
@@ -3040,12 +2752,73 @@
         </p:nvSpPr>
         <p:spPr>
           <a:xfrm>
-            <a:off x="731520" y="1691640"/>
-            <a:ext cx="5257800" cy="3886200"/>
+            <a:off x="731520" y="1572768"/>
+            <a:ext cx="10725912" cy="594360"/>
+          </a:xfrm>
+          <a:prstGeom prst="rect">
+            <a:avLst/>
+          </a:prstGeom>
+          <a:solidFill>
+            <a:srgbClr val="182033"/>
+          </a:solidFill>
+          <a:ln w="19050">
+            <a:solidFill>
+              <a:srgbClr val="F43F5E"/>
+            </a:solidFill>
+            <a:prstDash val="solid"/>
+          </a:ln>
+        </p:spPr>
+      </p:sp>
+      <p:sp>
+        <p:nvSpPr>
+          <p:cNvPr id="6" name="Text 4"/>
+          <p:cNvSpPr/>
+          <p:nvPr/>
+        </p:nvSpPr>
+        <p:spPr>
+          <a:xfrm>
+            <a:off x="914400" y="1618488"/>
+            <a:ext cx="10360152" cy="502920"/>
+          </a:xfrm>
+          <a:prstGeom prst="rect">
+            <a:avLst/>
+          </a:prstGeom>
+          <a:noFill/>
+          <a:ln/>
+        </p:spPr>
+        <p:txBody>
+          <a:bodyPr wrap="square" rtlCol="0" anchor="ctr"/>
+          <a:lstStyle/>
+          <a:p>
+            <a:pPr indent="0" marL="0">
+              <a:buNone/>
+            </a:pPr>
+            <a:r>
+              <a:rPr lang="en-US" sz="1100" i="1" dirty="0">
+                <a:solidFill>
+                  <a:srgbClr val="FEF3C7"/>
+                </a:solidFill>
+              </a:rPr>
+              <a:t>🏛️ The Story: You escape through the tomb door into a vast cavern hall as thick Stygian mist rolls in. Another crew of shades emerges from the shadows. Are they trustworthy friends or treacherous enemies?</a:t>
+            </a:r>
+            <a:endParaRPr lang="en-US" sz="1100" dirty="0"/>
+          </a:p>
+        </p:txBody>
+      </p:sp>
+      <p:sp>
+        <p:nvSpPr>
+          <p:cNvPr id="7" name="Shape 5"/>
+          <p:cNvSpPr/>
+          <p:nvPr/>
+        </p:nvSpPr>
+        <p:spPr>
+          <a:xfrm>
+            <a:off x="731520" y="2331720"/>
+            <a:ext cx="5257800" cy="3794760"/>
           </a:xfrm>
           <a:prstGeom prst="roundRect">
             <a:avLst>
-              <a:gd name="adj" fmla="val 1882"/>
+              <a:gd name="adj" fmla="val 1928"/>
             </a:avLst>
           </a:prstGeom>
           <a:solidFill>
@@ -3061,13 +2834,13 @@
       </p:sp>
       <p:sp>
         <p:nvSpPr>
-          <p:cNvPr id="6" name="Text 4"/>
-          <p:cNvSpPr/>
-          <p:nvPr/>
-        </p:nvSpPr>
-        <p:spPr>
-          <a:xfrm>
-            <a:off x="960120" y="1874520"/>
+          <p:cNvPr id="8" name="Text 6"/>
+          <p:cNvSpPr/>
+          <p:nvPr/>
+        </p:nvSpPr>
+        <p:spPr>
+          <a:xfrm>
+            <a:off x="960120" y="2514600"/>
             <a:ext cx="4800600" cy="365760"/>
           </a:xfrm>
           <a:prstGeom prst="rect">
@@ -3089,7 +2862,7 @@
                   <a:srgbClr val="FEF3C7"/>
                 </a:solidFill>
               </a:rPr>
-              <a:t>⚔️ How Each Clash Runs</a:t>
+              <a:t>⚙️ Mechanics (Each Clash)</a:t>
             </a:r>
             <a:endParaRPr lang="en-US" sz="1600" dirty="0"/>
           </a:p>
@@ -3097,14 +2870,14 @@
       </p:sp>
       <p:sp>
         <p:nvSpPr>
-          <p:cNvPr id="7" name="Text 5"/>
-          <p:cNvSpPr/>
-          <p:nvPr/>
-        </p:nvSpPr>
-        <p:spPr>
-          <a:xfrm>
-            <a:off x="960120" y="2331720"/>
-            <a:ext cx="4800600" cy="3017520"/>
+          <p:cNvPr id="9" name="Text 7"/>
+          <p:cNvSpPr/>
+          <p:nvPr/>
+        </p:nvSpPr>
+        <p:spPr>
+          <a:xfrm>
+            <a:off x="960120" y="2971800"/>
+            <a:ext cx="4800600" cy="2926080"/>
           </a:xfrm>
           <a:prstGeom prst="rect">
             <a:avLst/>
@@ -3186,7 +2959,7 @@
                   <a:srgbClr val="94A3B8"/>
                 </a:solidFill>
               </a:rPr>
-              <a:t>Turn to rival table. Look them in the eyes and negotiate across the room. (Bluffing is 100% permitted!).
+              <a:t>Talk with the other team across the room (bluffing is 100% permitted!).
 </a:t>
             </a:r>
             <a:pPr indent="0" marL="0">
@@ -3252,18 +3025,18 @@
       </p:sp>
       <p:sp>
         <p:nvSpPr>
-          <p:cNvPr id="8" name="Shape 6"/>
-          <p:cNvSpPr/>
-          <p:nvPr/>
-        </p:nvSpPr>
-        <p:spPr>
-          <a:xfrm>
-            <a:off x="6199632" y="1691640"/>
-            <a:ext cx="5257800" cy="3886200"/>
+          <p:cNvPr id="10" name="Shape 8"/>
+          <p:cNvSpPr/>
+          <p:nvPr/>
+        </p:nvSpPr>
+        <p:spPr>
+          <a:xfrm>
+            <a:off x="6199632" y="2331720"/>
+            <a:ext cx="5257800" cy="3794760"/>
           </a:xfrm>
           <a:prstGeom prst="roundRect">
             <a:avLst>
-              <a:gd name="adj" fmla="val 1882"/>
+              <a:gd name="adj" fmla="val 1928"/>
             </a:avLst>
           </a:prstGeom>
           <a:solidFill>
@@ -3279,13 +3052,13 @@
       </p:sp>
       <p:sp>
         <p:nvSpPr>
-          <p:cNvPr id="9" name="Text 7"/>
-          <p:cNvSpPr/>
-          <p:nvPr/>
-        </p:nvSpPr>
-        <p:spPr>
-          <a:xfrm>
-            <a:off x="6428232" y="1874520"/>
+          <p:cNvPr id="11" name="Text 9"/>
+          <p:cNvSpPr/>
+          <p:nvPr/>
+        </p:nvSpPr>
+        <p:spPr>
+          <a:xfrm>
+            <a:off x="6428232" y="2514600"/>
             <a:ext cx="4800600" cy="365760"/>
           </a:xfrm>
           <a:prstGeom prst="rect">
@@ -3307,7 +3080,7 @@
                   <a:srgbClr val="FEF3C7"/>
                 </a:solidFill>
               </a:rPr>
-              <a:t>⚖️ The Stances &amp; Moral Legacy</a:t>
+              <a:t>🏆 Points Difference</a:t>
             </a:r>
             <a:endParaRPr lang="en-US" sz="1600" dirty="0"/>
           </a:p>
@@ -3315,14 +3088,14 @@
       </p:sp>
       <p:sp>
         <p:nvSpPr>
-          <p:cNvPr id="10" name="Text 8"/>
-          <p:cNvSpPr/>
-          <p:nvPr/>
-        </p:nvSpPr>
-        <p:spPr>
-          <a:xfrm>
-            <a:off x="6428232" y="2331720"/>
-            <a:ext cx="4800600" cy="3017520"/>
+          <p:cNvPr id="12" name="Text 10"/>
+          <p:cNvSpPr/>
+          <p:nvPr/>
+        </p:nvSpPr>
+        <p:spPr>
+          <a:xfrm>
+            <a:off x="6428232" y="2971800"/>
+            <a:ext cx="4800600" cy="2926080"/>
           </a:xfrm>
           <a:prstGeom prst="rect">
             <a:avLst/>
@@ -3346,7 +3119,7 @@
                   <a:srgbClr val="F59E0B"/>
                 </a:solidFill>
               </a:rPr>
-              <a:t>Point Outcomes (Stakes DOUBLE in Clash 2, TRIPLE in Clash 3!):
+              <a:t>Points Outcomes (Stakes DOUBLE in Clash 2, TRIPLE in Clash 3!):
 </a:t>
             </a:r>
             <a:pPr indent="0" marL="0">
@@ -3361,7 +3134,8 @@
                   <a:srgbClr val="10B981"/>
                 </a:solidFill>
               </a:rPr>
-              <a:t>🤝 Mutual Truce: </a:t>
+              <a:t>🤝 Mutual Truce (Cooperation):
+</a:t>
             </a:r>
             <a:pPr indent="0" marL="0">
               <a:lnSpc>
@@ -3375,7 +3149,7 @@
                   <a:srgbClr val="94A3B8"/>
                 </a:solidFill>
               </a:rPr>
-              <a:t>Both crews play peaceful $\rightarrow$ Both win solid, steady points.
+              <a:t>Both teams play peaceful → Both win solid, steady points (+75 / +150 / +225 PTS).
 </a:t>
             </a:r>
             <a:pPr indent="0" marL="0">
@@ -3390,7 +3164,8 @@
                   <a:srgbClr val="F43F5E"/>
                 </a:solidFill>
               </a:rPr>
-              <a:t>🗡️ The Backstab: </a:t>
+              <a:t>🗡️ The Backstab (Betrayal):
+</a:t>
             </a:r>
             <a:pPr indent="0" marL="0">
               <a:lnSpc>
@@ -3404,7 +3179,7 @@
                   <a:srgbClr val="94A3B8"/>
                 </a:solidFill>
               </a:rPr>
-              <a:t>Ambush beats Truce $\rightarrow$ Betrayer steals massive points; victim gets 0!
+              <a:t>Ambush beats Truce → Betrayer steals maximum points (+150 / +300 / +450 PTS); peaceful victim gets 0 PTS!
 </a:t>
             </a:r>
             <a:pPr indent="0" marL="0">
@@ -3419,7 +3194,8 @@
                   <a:srgbClr val="F59E0B"/>
                 </a:solidFill>
               </a:rPr>
-              <a:t>💥 Mutual Brawl: </a:t>
+              <a:t>💥 Mutual Brawl (Conflict):
+</a:t>
             </a:r>
             <a:pPr indent="0" marL="0">
               <a:lnSpc>
@@ -3433,7 +3209,7 @@
                   <a:srgbClr val="94A3B8"/>
                 </a:solidFill>
               </a:rPr>
-              <a:t>Both crews attack $\rightarrow$ Both walk away with scraps.
+              <a:t>Both teams attack → Both walk away with scraps (+15 / +30 / +45 PTS).
 </a:t>
             </a:r>
             <a:pPr indent="0" marL="0">
@@ -3443,105 +3219,12 @@
               <a:buNone/>
             </a:pPr>
             <a:r>
-              <a:rPr lang="en-US" sz="1100" b="1" dirty="0">
+              <a:rPr lang="en-US" sz="1100" i="1" dirty="0">
                 <a:solidFill>
                   <a:srgbClr val="FEF3C7"/>
                 </a:solidFill>
               </a:rPr>
-              <a:t>🕊️ Moral Legacy in Round 3:
-</a:t>
-            </a:r>
-            <a:pPr indent="0" marL="0">
-              <a:lnSpc>
-                <a:spcPct val="115000"/>
-              </a:lnSpc>
-              <a:buNone/>
-            </a:pPr>
-            <a:r>
-              <a:rPr lang="en-US" sz="1100" dirty="0">
-                <a:solidFill>
-                  <a:srgbClr val="E2E8F0"/>
-                </a:solidFill>
-              </a:rPr>
-              <a:t>• Honourable (3 Truces): Athena grants +75m headstart in Round 3!</a:t>
-            </a:r>
-            <a:endParaRPr lang="en-US" sz="1100" dirty="0"/>
-          </a:p>
-          <a:p>
-            <a:pPr indent="0" marL="0">
-              <a:lnSpc>
-                <a:spcPct val="115000"/>
-              </a:lnSpc>
-              <a:buNone/>
-            </a:pPr>
-            <a:r>
-              <a:rPr lang="en-US" sz="1100" dirty="0">
-                <a:solidFill>
-                  <a:srgbClr val="E2E8F0"/>
-                </a:solidFill>
-              </a:rPr>
-              <a:t>• Betrayed: Crew gets a Cerberus revenge token to strike their nemesis!</a:t>
-            </a:r>
-            <a:endParaRPr lang="en-US" sz="1100" dirty="0"/>
-          </a:p>
-        </p:txBody>
-      </p:sp>
-      <p:sp>
-        <p:nvSpPr>
-          <p:cNvPr id="11" name="Shape 9"/>
-          <p:cNvSpPr/>
-          <p:nvPr/>
-        </p:nvSpPr>
-        <p:spPr>
-          <a:xfrm>
-            <a:off x="731520" y="5760720"/>
-            <a:ext cx="10725912" cy="594360"/>
-          </a:xfrm>
-          <a:prstGeom prst="rect">
-            <a:avLst/>
-          </a:prstGeom>
-          <a:solidFill>
-            <a:srgbClr val="1E293B"/>
-          </a:solidFill>
-          <a:ln w="12700">
-            <a:solidFill>
-              <a:srgbClr val="F43F5E"/>
-            </a:solidFill>
-            <a:prstDash val="solid"/>
-          </a:ln>
-        </p:spPr>
-      </p:sp>
-      <p:sp>
-        <p:nvSpPr>
-          <p:cNvPr id="12" name="Text 10"/>
-          <p:cNvSpPr/>
-          <p:nvPr/>
-        </p:nvSpPr>
-        <p:spPr>
-          <a:xfrm>
-            <a:off x="914400" y="5870448"/>
-            <a:ext cx="10360152" cy="365760"/>
-          </a:xfrm>
-          <a:prstGeom prst="rect">
-            <a:avLst/>
-          </a:prstGeom>
-          <a:noFill/>
-          <a:ln/>
-        </p:spPr>
-        <p:txBody>
-          <a:bodyPr wrap="square" rtlCol="0" anchor="ctr"/>
-          <a:lstStyle/>
-          <a:p>
-            <a:pPr algn="ctr" indent="0" marL="0">
-              <a:buNone/>
-            </a:pPr>
-            <a:r>
-              <a:rPr lang="en-US" sz="1100" b="1" dirty="0">
-                <a:solidFill>
-                  <a:srgbClr val="FEF3C7"/>
-                </a:solidFill>
-              </a:rPr>
-              <a:t>💡 Facilitator Cue: "Promises made across the room are not binding. Will you build trust, or cash in on a brutal backstab?"</a:t>
+              <a:t>⚠️ Key Tension: Promises across the room are non-binding. Will you build trust or cash in on a backstab?</a:t>
             </a:r>
             <a:endParaRPr lang="en-US" sz="1100" dirty="0"/>
           </a:p>
@@ -3588,7 +3271,7 @@
         <p:spPr>
           <a:xfrm>
             <a:off x="731520" y="411480"/>
-            <a:ext cx="7315200" cy="274320"/>
+            <a:ext cx="7315200" cy="256032"/>
           </a:xfrm>
           <a:prstGeom prst="rect">
             <a:avLst/>
@@ -3609,7 +3292,7 @@
                   <a:srgbClr val="A855F7"/>
                 </a:solidFill>
               </a:rPr>
-              <a:t>ROUND 3 • THE CLIMAX &amp; ESCAPE ROYALE</a:t>
+              <a:t>ROUND 3 • ESCAPE ROYALE</a:t>
             </a:r>
             <a:endParaRPr lang="en-US" sz="1000" dirty="0"/>
           </a:p>
@@ -3623,8 +3306,8 @@
         </p:nvSpPr>
         <p:spPr>
           <a:xfrm>
-            <a:off x="731520" y="685800"/>
-            <a:ext cx="10698480" cy="548640"/>
+            <a:off x="731520" y="658368"/>
+            <a:ext cx="10725912" cy="502920"/>
           </a:xfrm>
           <a:prstGeom prst="rect">
             <a:avLst/>
@@ -3659,8 +3342,8 @@
         </p:nvSpPr>
         <p:spPr>
           <a:xfrm>
-            <a:off x="731520" y="1234440"/>
-            <a:ext cx="10698480" cy="320040"/>
+            <a:off x="731520" y="1170432"/>
+            <a:ext cx="10725912" cy="292608"/>
           </a:xfrm>
           <a:prstGeom prst="rect">
             <a:avLst/>
@@ -3695,20 +3378,18 @@
         </p:nvSpPr>
         <p:spPr>
           <a:xfrm>
-            <a:off x="731520" y="1691640"/>
-            <a:ext cx="3374136" cy="2148840"/>
-          </a:xfrm>
-          <a:prstGeom prst="roundRect">
-            <a:avLst>
-              <a:gd name="adj" fmla="val 3404"/>
-            </a:avLst>
+            <a:off x="731520" y="1572768"/>
+            <a:ext cx="10725912" cy="594360"/>
+          </a:xfrm>
+          <a:prstGeom prst="rect">
+            <a:avLst/>
           </a:prstGeom>
           <a:solidFill>
-            <a:srgbClr val="141A2A"/>
+            <a:srgbClr val="182033"/>
           </a:solidFill>
           <a:ln w="19050">
             <a:solidFill>
-              <a:srgbClr val="10B981"/>
+              <a:srgbClr val="A855F7"/>
             </a:solidFill>
             <a:prstDash val="solid"/>
           </a:ln>
@@ -3722,8 +3403,8 @@
         </p:nvSpPr>
         <p:spPr>
           <a:xfrm>
-            <a:off x="868680" y="1783080"/>
-            <a:ext cx="3099816" cy="320040"/>
+            <a:off x="914400" y="1618488"/>
+            <a:ext cx="10360152" cy="502920"/>
           </a:xfrm>
           <a:prstGeom prst="rect">
             <a:avLst/>
@@ -3739,332 +3420,31 @@
               <a:buNone/>
             </a:pPr>
             <a:r>
-              <a:rPr lang="en-US" sz="1500" b="1" dirty="0">
-                <a:solidFill>
-                  <a:srgbClr val="10B981"/>
-                </a:solidFill>
-              </a:rPr>
-              <a:t>🚣 The Rowboat</a:t>
-            </a:r>
-            <a:endParaRPr lang="en-US" sz="1500" dirty="0"/>
-          </a:p>
-        </p:txBody>
-      </p:sp>
-      <p:sp>
-        <p:nvSpPr>
-          <p:cNvPr id="7" name="Text 5"/>
-          <p:cNvSpPr/>
-          <p:nvPr/>
-        </p:nvSpPr>
-        <p:spPr>
-          <a:xfrm>
-            <a:off x="868680" y="2103120"/>
-            <a:ext cx="3099816" cy="182880"/>
-          </a:xfrm>
-          <a:prstGeom prst="rect">
-            <a:avLst/>
-          </a:prstGeom>
-          <a:noFill/>
-          <a:ln/>
-        </p:spPr>
-        <p:txBody>
-          <a:bodyPr wrap="square" rtlCol="0" anchor="ctr"/>
-          <a:lstStyle/>
-          <a:p>
-            <a:pPr indent="0" marL="0">
-              <a:buNone/>
-            </a:pPr>
-            <a:r>
-              <a:rPr lang="en-US" sz="850" b="1" dirty="0">
-                <a:solidFill>
-                  <a:srgbClr val="94A3B8"/>
-                </a:solidFill>
-              </a:rPr>
-              <a:t>SAFE &amp; STEADY</a:t>
-            </a:r>
-            <a:endParaRPr lang="en-US" sz="850" dirty="0"/>
-          </a:p>
-        </p:txBody>
-      </p:sp>
-      <p:sp>
-        <p:nvSpPr>
-          <p:cNvPr id="8" name="Text 6"/>
-          <p:cNvSpPr/>
-          <p:nvPr/>
-        </p:nvSpPr>
-        <p:spPr>
-          <a:xfrm>
-            <a:off x="868680" y="2331720"/>
-            <a:ext cx="3099816" cy="1371600"/>
-          </a:xfrm>
-          <a:prstGeom prst="rect">
-            <a:avLst/>
-          </a:prstGeom>
-          <a:noFill/>
-          <a:ln/>
-        </p:spPr>
-        <p:txBody>
-          <a:bodyPr wrap="square" rtlCol="0" anchor="ctr"/>
-          <a:lstStyle/>
-          <a:p>
-            <a:pPr indent="0" marL="0">
-              <a:lnSpc>
-                <a:spcPct val="115000"/>
-              </a:lnSpc>
-              <a:buNone/>
-            </a:pPr>
-            <a:r>
-              <a:rPr lang="en-US" sz="950" b="1" dirty="0">
-                <a:solidFill>
-                  <a:srgbClr val="E2E8F0"/>
-                </a:solidFill>
-              </a:rPr>
-              <a:t>• Unlimited Capacity
-</a:t>
-            </a:r>
-            <a:pPr indent="0" marL="0">
-              <a:lnSpc>
-                <a:spcPct val="115000"/>
-              </a:lnSpc>
-              <a:buNone/>
-            </a:pPr>
-            <a:r>
-              <a:rPr lang="en-US" sz="950" b="1" dirty="0">
-                <a:solidFill>
-                  <a:srgbClr val="E2E8F0"/>
-                </a:solidFill>
-              </a:rPr>
-              <a:t>• Advance: </a:t>
-            </a:r>
-            <a:pPr indent="0" marL="0">
-              <a:lnSpc>
-                <a:spcPct val="115000"/>
-              </a:lnSpc>
-              <a:buNone/>
-            </a:pPr>
-            <a:r>
-              <a:rPr lang="en-US" sz="950" b="1" dirty="0">
-                <a:solidFill>
-                  <a:srgbClr val="10B981"/>
-                </a:solidFill>
-              </a:rPr>
-              <a:t>+150m ALWAYS
-</a:t>
-            </a:r>
-            <a:pPr indent="0" marL="0">
-              <a:lnSpc>
-                <a:spcPct val="115000"/>
-              </a:lnSpc>
-              <a:buNone/>
-            </a:pPr>
-            <a:r>
-              <a:rPr lang="en-US" sz="950" dirty="0">
-                <a:solidFill>
-                  <a:srgbClr val="94A3B8"/>
-                </a:solidFill>
-              </a:rPr>
-              <a:t>Never capsizes. Reliable steady progress while rivals greedily crash.</a:t>
-            </a:r>
-            <a:endParaRPr lang="en-US" sz="950" dirty="0"/>
-          </a:p>
-        </p:txBody>
-      </p:sp>
-      <p:sp>
-        <p:nvSpPr>
-          <p:cNvPr id="9" name="Shape 7"/>
-          <p:cNvSpPr/>
-          <p:nvPr/>
-        </p:nvSpPr>
-        <p:spPr>
-          <a:xfrm>
-            <a:off x="4407408" y="1691640"/>
-            <a:ext cx="3374136" cy="2148840"/>
+              <a:rPr lang="en-US" sz="1100" i="1" dirty="0">
+                <a:solidFill>
+                  <a:srgbClr val="FEF3C7"/>
+                </a:solidFill>
+              </a:rPr>
+              <a:t>🏛️ The Story: Cerberus is howling in the shadows behind you, and the exit portal across the wide River Styx is slowly starting to close. Can your crew reach the portal before it seals forever?</a:t>
+            </a:r>
+            <a:endParaRPr lang="en-US" sz="1100" dirty="0"/>
+          </a:p>
+        </p:txBody>
+      </p:sp>
+      <p:sp>
+        <p:nvSpPr>
+          <p:cNvPr id="7" name="Shape 5"/>
+          <p:cNvSpPr/>
+          <p:nvPr/>
+        </p:nvSpPr>
+        <p:spPr>
+          <a:xfrm>
+            <a:off x="731520" y="2331720"/>
+            <a:ext cx="5257800" cy="3794760"/>
           </a:xfrm>
           <a:prstGeom prst="roundRect">
             <a:avLst>
-              <a:gd name="adj" fmla="val 3404"/>
-            </a:avLst>
-          </a:prstGeom>
-          <a:solidFill>
-            <a:srgbClr val="141A2A"/>
-          </a:solidFill>
-          <a:ln w="19050">
-            <a:solidFill>
-              <a:srgbClr val="F59E0B"/>
-            </a:solidFill>
-            <a:prstDash val="solid"/>
-          </a:ln>
-        </p:spPr>
-      </p:sp>
-      <p:sp>
-        <p:nvSpPr>
-          <p:cNvPr id="10" name="Text 8"/>
-          <p:cNvSpPr/>
-          <p:nvPr/>
-        </p:nvSpPr>
-        <p:spPr>
-          <a:xfrm>
-            <a:off x="4544568" y="1783080"/>
-            <a:ext cx="3099816" cy="320040"/>
-          </a:xfrm>
-          <a:prstGeom prst="rect">
-            <a:avLst/>
-          </a:prstGeom>
-          <a:noFill/>
-          <a:ln/>
-        </p:spPr>
-        <p:txBody>
-          <a:bodyPr wrap="square" rtlCol="0" anchor="ctr"/>
-          <a:lstStyle/>
-          <a:p>
-            <a:pPr indent="0" marL="0">
-              <a:buNone/>
-            </a:pPr>
-            <a:r>
-              <a:rPr lang="en-US" sz="1500" b="1" dirty="0">
-                <a:solidFill>
-                  <a:srgbClr val="F59E0B"/>
-                </a:solidFill>
-              </a:rPr>
-              <a:t>⛵ The Sailboat</a:t>
-            </a:r>
-            <a:endParaRPr lang="en-US" sz="1500" dirty="0"/>
-          </a:p>
-        </p:txBody>
-      </p:sp>
-      <p:sp>
-        <p:nvSpPr>
-          <p:cNvPr id="11" name="Text 9"/>
-          <p:cNvSpPr/>
-          <p:nvPr/>
-        </p:nvSpPr>
-        <p:spPr>
-          <a:xfrm>
-            <a:off x="4544568" y="2103120"/>
-            <a:ext cx="3099816" cy="182880"/>
-          </a:xfrm>
-          <a:prstGeom prst="rect">
-            <a:avLst/>
-          </a:prstGeom>
-          <a:noFill/>
-          <a:ln/>
-        </p:spPr>
-        <p:txBody>
-          <a:bodyPr wrap="square" rtlCol="0" anchor="ctr"/>
-          <a:lstStyle/>
-          <a:p>
-            <a:pPr indent="0" marL="0">
-              <a:buNone/>
-            </a:pPr>
-            <a:r>
-              <a:rPr lang="en-US" sz="850" b="1" dirty="0">
-                <a:solidFill>
-                  <a:srgbClr val="94A3B8"/>
-                </a:solidFill>
-              </a:rPr>
-              <a:t>SPEED VS CROWDS</a:t>
-            </a:r>
-            <a:endParaRPr lang="en-US" sz="850" dirty="0"/>
-          </a:p>
-        </p:txBody>
-      </p:sp>
-      <p:sp>
-        <p:nvSpPr>
-          <p:cNvPr id="12" name="Text 10"/>
-          <p:cNvSpPr/>
-          <p:nvPr/>
-        </p:nvSpPr>
-        <p:spPr>
-          <a:xfrm>
-            <a:off x="4544568" y="2331720"/>
-            <a:ext cx="3099816" cy="1371600"/>
-          </a:xfrm>
-          <a:prstGeom prst="rect">
-            <a:avLst/>
-          </a:prstGeom>
-          <a:noFill/>
-          <a:ln/>
-        </p:spPr>
-        <p:txBody>
-          <a:bodyPr wrap="square" rtlCol="0" anchor="ctr"/>
-          <a:lstStyle/>
-          <a:p>
-            <a:pPr indent="0" marL="0">
-              <a:lnSpc>
-                <a:spcPct val="115000"/>
-              </a:lnSpc>
-              <a:buNone/>
-            </a:pPr>
-            <a:r>
-              <a:rPr lang="en-US" sz="950" b="1" dirty="0">
-                <a:solidFill>
-                  <a:srgbClr val="E2E8F0"/>
-                </a:solidFill>
-              </a:rPr>
-              <a:t>• Max 30% of Fleet
-</a:t>
-            </a:r>
-            <a:pPr indent="0" marL="0">
-              <a:lnSpc>
-                <a:spcPct val="115000"/>
-              </a:lnSpc>
-              <a:buNone/>
-            </a:pPr>
-            <a:r>
-              <a:rPr lang="en-US" sz="950" b="1" dirty="0">
-                <a:solidFill>
-                  <a:srgbClr val="E2E8F0"/>
-                </a:solidFill>
-              </a:rPr>
-              <a:t>• Advance: </a:t>
-            </a:r>
-            <a:pPr indent="0" marL="0">
-              <a:lnSpc>
-                <a:spcPct val="115000"/>
-              </a:lnSpc>
-              <a:buNone/>
-            </a:pPr>
-            <a:r>
-              <a:rPr lang="en-US" sz="950" b="1" dirty="0">
-                <a:solidFill>
-                  <a:srgbClr val="F59E0B"/>
-                </a:solidFill>
-              </a:rPr>
-              <a:t>+300m or CAPSIZE (0m)
-</a:t>
-            </a:r>
-            <a:pPr indent="0" marL="0">
-              <a:lnSpc>
-                <a:spcPct val="115000"/>
-              </a:lnSpc>
-              <a:buNone/>
-            </a:pPr>
-            <a:r>
-              <a:rPr lang="en-US" sz="950" dirty="0">
-                <a:solidFill>
-                  <a:srgbClr val="94A3B8"/>
-                </a:solidFill>
-              </a:rPr>
-              <a:t>Fast surge! But if too many crews board, the vessel capsizes into the river.</a:t>
-            </a:r>
-            <a:endParaRPr lang="en-US" sz="950" dirty="0"/>
-          </a:p>
-        </p:txBody>
-      </p:sp>
-      <p:sp>
-        <p:nvSpPr>
-          <p:cNvPr id="13" name="Shape 11"/>
-          <p:cNvSpPr/>
-          <p:nvPr/>
-        </p:nvSpPr>
-        <p:spPr>
-          <a:xfrm>
-            <a:off x="8083296" y="1691640"/>
-            <a:ext cx="3374136" cy="2148840"/>
-          </a:xfrm>
-          <a:prstGeom prst="roundRect">
-            <a:avLst>
-              <a:gd name="adj" fmla="val 3404"/>
+              <a:gd name="adj" fmla="val 1928"/>
             </a:avLst>
           </a:prstGeom>
           <a:solidFill>
@@ -4080,14 +3460,14 @@
       </p:sp>
       <p:sp>
         <p:nvSpPr>
-          <p:cNvPr id="14" name="Text 12"/>
-          <p:cNvSpPr/>
-          <p:nvPr/>
-        </p:nvSpPr>
-        <p:spPr>
-          <a:xfrm>
-            <a:off x="8220456" y="1783080"/>
-            <a:ext cx="3099816" cy="320040"/>
+          <p:cNvPr id="8" name="Text 6"/>
+          <p:cNvSpPr/>
+          <p:nvPr/>
+        </p:nvSpPr>
+        <p:spPr>
+          <a:xfrm>
+            <a:off x="960120" y="2514600"/>
+            <a:ext cx="4800600" cy="365760"/>
           </a:xfrm>
           <a:prstGeom prst="rect">
             <a:avLst/>
@@ -4103,27 +3483,27 @@
               <a:buNone/>
             </a:pPr>
             <a:r>
-              <a:rPr lang="en-US" sz="1500" b="1" dirty="0">
-                <a:solidFill>
-                  <a:srgbClr val="A855F7"/>
-                </a:solidFill>
-              </a:rPr>
-              <a:t>⚡ The Ghost Ship</a:t>
-            </a:r>
-            <a:endParaRPr lang="en-US" sz="1500" dirty="0"/>
-          </a:p>
-        </p:txBody>
-      </p:sp>
-      <p:sp>
-        <p:nvSpPr>
-          <p:cNvPr id="15" name="Text 13"/>
-          <p:cNvSpPr/>
-          <p:nvPr/>
-        </p:nvSpPr>
-        <p:spPr>
-          <a:xfrm>
-            <a:off x="8220456" y="2103120"/>
-            <a:ext cx="3099816" cy="182880"/>
+              <a:rPr lang="en-US" sz="1600" b="1" dirty="0">
+                <a:solidFill>
+                  <a:srgbClr val="FEF3C7"/>
+                </a:solidFill>
+              </a:rPr>
+              <a:t>⚙️ Mechanics: The 3 Vessels</a:t>
+            </a:r>
+            <a:endParaRPr lang="en-US" sz="1600" dirty="0"/>
+          </a:p>
+        </p:txBody>
+      </p:sp>
+      <p:sp>
+        <p:nvSpPr>
+          <p:cNvPr id="9" name="Text 7"/>
+          <p:cNvSpPr/>
+          <p:nvPr/>
+        </p:nvSpPr>
+        <p:spPr>
+          <a:xfrm>
+            <a:off x="960120" y="2971800"/>
+            <a:ext cx="4800600" cy="2926080"/>
           </a:xfrm>
           <a:prstGeom prst="rect">
             <a:avLst/>
@@ -4136,54 +3516,18 @@
           <a:lstStyle/>
           <a:p>
             <a:pPr indent="0" marL="0">
-              <a:buNone/>
-            </a:pPr>
-            <a:r>
-              <a:rPr lang="en-US" sz="850" b="1" dirty="0">
+              <a:lnSpc>
+                <a:spcPct val="115000"/>
+              </a:lnSpc>
+              <a:buNone/>
+            </a:pPr>
+            <a:r>
+              <a:rPr lang="en-US" sz="1100" dirty="0">
                 <a:solidFill>
                   <a:srgbClr val="94A3B8"/>
                 </a:solidFill>
               </a:rPr>
-              <a:t>SOLO GAMBLE</a:t>
-            </a:r>
-            <a:endParaRPr lang="en-US" sz="850" dirty="0"/>
-          </a:p>
-        </p:txBody>
-      </p:sp>
-      <p:sp>
-        <p:nvSpPr>
-          <p:cNvPr id="16" name="Text 14"/>
-          <p:cNvSpPr/>
-          <p:nvPr/>
-        </p:nvSpPr>
-        <p:spPr>
-          <a:xfrm>
-            <a:off x="8220456" y="2331720"/>
-            <a:ext cx="3099816" cy="1371600"/>
-          </a:xfrm>
-          <a:prstGeom prst="rect">
-            <a:avLst/>
-          </a:prstGeom>
-          <a:noFill/>
-          <a:ln/>
-        </p:spPr>
-        <p:txBody>
-          <a:bodyPr wrap="square" rtlCol="0" anchor="ctr"/>
-          <a:lstStyle/>
-          <a:p>
-            <a:pPr indent="0" marL="0">
-              <a:lnSpc>
-                <a:spcPct val="115000"/>
-              </a:lnSpc>
-              <a:buNone/>
-            </a:pPr>
-            <a:r>
-              <a:rPr lang="en-US" sz="950" b="1" dirty="0">
-                <a:solidFill>
-                  <a:srgbClr val="E2E8F0"/>
-                </a:solidFill>
-              </a:rPr>
-              <a:t>• EXACTLY 1 Crew Only
+              <a:t>Each wave, your crew secretly votes for one vessel:
 </a:t>
             </a:r>
             <a:pPr indent="0" marL="0">
@@ -4193,26 +3537,72 @@
               <a:buNone/>
             </a:pPr>
             <a:r>
-              <a:rPr lang="en-US" sz="950" b="1" dirty="0">
-                <a:solidFill>
-                  <a:srgbClr val="E2E8F0"/>
-                </a:solidFill>
-              </a:rPr>
-              <a:t>• Advance: </a:t>
-            </a:r>
-            <a:pPr indent="0" marL="0">
-              <a:lnSpc>
-                <a:spcPct val="115000"/>
-              </a:lnSpc>
-              <a:buNone/>
-            </a:pPr>
-            <a:r>
-              <a:rPr lang="en-US" sz="950" b="1" dirty="0">
+              <a:rPr lang="en-US" sz="1100" b="1" dirty="0">
+                <a:solidFill>
+                  <a:srgbClr val="10B981"/>
+                </a:solidFill>
+              </a:rPr>
+              <a:t>🚣 The Rowboat (Safe):
+</a:t>
+            </a:r>
+            <a:pPr indent="0" marL="0">
+              <a:lnSpc>
+                <a:spcPct val="115000"/>
+              </a:lnSpc>
+              <a:buNone/>
+            </a:pPr>
+            <a:r>
+              <a:rPr lang="en-US" sz="1100" dirty="0">
+                <a:solidFill>
+                  <a:srgbClr val="94A3B8"/>
+                </a:solidFill>
+              </a:rPr>
+              <a:t>• Unlimited capacity. Always advances +150m. Never capsizes.
+</a:t>
+            </a:r>
+            <a:pPr indent="0" marL="0">
+              <a:lnSpc>
+                <a:spcPct val="115000"/>
+              </a:lnSpc>
+              <a:buNone/>
+            </a:pPr>
+            <a:r>
+              <a:rPr lang="en-US" sz="1100" b="1" dirty="0">
+                <a:solidFill>
+                  <a:srgbClr val="F59E0B"/>
+                </a:solidFill>
+              </a:rPr>
+              <a:t>⛵ The Sailboat (Speed vs Crowds):
+</a:t>
+            </a:r>
+            <a:pPr indent="0" marL="0">
+              <a:lnSpc>
+                <a:spcPct val="115000"/>
+              </a:lnSpc>
+              <a:buNone/>
+            </a:pPr>
+            <a:r>
+              <a:rPr lang="en-US" sz="1100" dirty="0">
+                <a:solidFill>
+                  <a:srgbClr val="94A3B8"/>
+                </a:solidFill>
+              </a:rPr>
+              <a:t>• Max 30% fleet capacity. Advances +300m, but CAPSIZES (0m) if overcrowded!
+</a:t>
+            </a:r>
+            <a:pPr indent="0" marL="0">
+              <a:lnSpc>
+                <a:spcPct val="115000"/>
+              </a:lnSpc>
+              <a:buNone/>
+            </a:pPr>
+            <a:r>
+              <a:rPr lang="en-US" sz="1100" b="1" dirty="0">
                 <a:solidFill>
                   <a:srgbClr val="A855F7"/>
                 </a:solidFill>
               </a:rPr>
-              <a:t>+450m or CRASH (-50m)
+              <a:t>⚡ The Ghost Ship (Solo Gamble):
 </a:t>
             </a:r>
             <a:pPr indent="0" marL="0">
@@ -4222,31 +3612,31 @@
               <a:buNone/>
             </a:pPr>
             <a:r>
-              <a:rPr lang="en-US" sz="950" dirty="0">
+              <a:rPr lang="en-US" sz="1100" dirty="0">
                 <a:solidFill>
                   <a:srgbClr val="94A3B8"/>
                 </a:solidFill>
               </a:rPr>
-              <a:t>Mythic leap! But if 2 or more crews choose it, they collide (-50m penalty).</a:t>
-            </a:r>
-            <a:endParaRPr lang="en-US" sz="950" dirty="0"/>
-          </a:p>
-        </p:txBody>
-      </p:sp>
-      <p:sp>
-        <p:nvSpPr>
-          <p:cNvPr id="17" name="Shape 15"/>
-          <p:cNvSpPr/>
-          <p:nvPr/>
-        </p:nvSpPr>
-        <p:spPr>
-          <a:xfrm>
-            <a:off x="731520" y="4023360"/>
-            <a:ext cx="5257800" cy="2286000"/>
+              <a:t>• Exactly 1 crew. Mythic surge (+450m)! But COLLIDES (-50m) if 2+ crews board.</a:t>
+            </a:r>
+            <a:endParaRPr lang="en-US" sz="1100" dirty="0"/>
+          </a:p>
+        </p:txBody>
+      </p:sp>
+      <p:sp>
+        <p:nvSpPr>
+          <p:cNvPr id="10" name="Shape 8"/>
+          <p:cNvSpPr/>
+          <p:nvPr/>
+        </p:nvSpPr>
+        <p:spPr>
+          <a:xfrm>
+            <a:off x="6199632" y="2331720"/>
+            <a:ext cx="5257800" cy="3794760"/>
           </a:xfrm>
           <a:prstGeom prst="roundRect">
             <a:avLst>
-              <a:gd name="adj" fmla="val 3200"/>
+              <a:gd name="adj" fmla="val 1928"/>
             </a:avLst>
           </a:prstGeom>
           <a:solidFill>
@@ -4262,14 +3652,14 @@
       </p:sp>
       <p:sp>
         <p:nvSpPr>
-          <p:cNvPr id="18" name="Text 16"/>
-          <p:cNvSpPr/>
-          <p:nvPr/>
-        </p:nvSpPr>
-        <p:spPr>
-          <a:xfrm>
-            <a:off x="960120" y="4160520"/>
-            <a:ext cx="4800600" cy="320040"/>
+          <p:cNvPr id="11" name="Text 9"/>
+          <p:cNvSpPr/>
+          <p:nvPr/>
+        </p:nvSpPr>
+        <p:spPr>
+          <a:xfrm>
+            <a:off x="6428232" y="2514600"/>
+            <a:ext cx="4800600" cy="365760"/>
           </a:xfrm>
           <a:prstGeom prst="rect">
             <a:avLst/>
@@ -4285,27 +3675,27 @@
               <a:buNone/>
             </a:pPr>
             <a:r>
-              <a:rPr lang="en-US" sz="1400" b="1" dirty="0">
+              <a:rPr lang="en-US" sz="1600" b="1" dirty="0">
                 <a:solidFill>
                   <a:srgbClr val="FEF3C7"/>
                 </a:solidFill>
               </a:rPr>
-              <a:t>🏁 Deciding the Winners</a:t>
-            </a:r>
-            <a:endParaRPr lang="en-US" sz="1400" dirty="0"/>
-          </a:p>
-        </p:txBody>
-      </p:sp>
-      <p:sp>
-        <p:nvSpPr>
-          <p:cNvPr id="19" name="Text 17"/>
-          <p:cNvSpPr/>
-          <p:nvPr/>
-        </p:nvSpPr>
-        <p:spPr>
-          <a:xfrm>
-            <a:off x="960120" y="4526280"/>
-            <a:ext cx="4800600" cy="1645920"/>
+              <a:t>🏆 Winning Conditions</a:t>
+            </a:r>
+            <a:endParaRPr lang="en-US" sz="1600" dirty="0"/>
+          </a:p>
+        </p:txBody>
+      </p:sp>
+      <p:sp>
+        <p:nvSpPr>
+          <p:cNvPr id="12" name="Text 10"/>
+          <p:cNvSpPr/>
+          <p:nvPr/>
+        </p:nvSpPr>
+        <p:spPr>
+          <a:xfrm>
+            <a:off x="6428232" y="2971800"/>
+            <a:ext cx="4800600" cy="2926080"/>
           </a:xfrm>
           <a:prstGeom prst="rect">
             <a:avLst/>
@@ -4324,7 +3714,7 @@
               <a:buNone/>
             </a:pPr>
             <a:r>
-              <a:rPr lang="en-US" sz="1050" b="1" dirty="0">
+              <a:rPr lang="en-US" sz="1100" b="1" dirty="0">
                 <a:solidFill>
                   <a:srgbClr val="E2E8F0"/>
                 </a:solidFill>
@@ -4338,12 +3728,12 @@
               <a:buNone/>
             </a:pPr>
             <a:r>
-              <a:rPr lang="en-US" sz="1050" dirty="0">
+              <a:rPr lang="en-US" sz="1100" dirty="0">
                 <a:solidFill>
                   <a:srgbClr val="94A3B8"/>
                 </a:solidFill>
               </a:rPr>
-              <a:t>Points from R1 &amp; R2 convert into starting meters (+75m honor bonus).
+              <a:t>Total points accumulated in Rounds 1 &amp; 2 convert directly into starting river meters.
 </a:t>
             </a:r>
             <a:pPr indent="0" marL="0">
@@ -4353,26 +3743,26 @@
               <a:buNone/>
             </a:pPr>
             <a:r>
-              <a:rPr lang="en-US" sz="1050" b="1" dirty="0">
+              <a:rPr lang="en-US" sz="1100" b="1" dirty="0">
                 <a:solidFill>
                   <a:srgbClr val="E2E8F0"/>
                 </a:solidFill>
               </a:rPr>
-              <a:t>• Podium Victory: </a:t>
-            </a:r>
-            <a:pPr indent="0" marL="0">
-              <a:lnSpc>
-                <a:spcPct val="115000"/>
-              </a:lnSpc>
-              <a:buNone/>
-            </a:pPr>
-            <a:r>
-              <a:rPr lang="en-US" sz="1050" dirty="0">
+              <a:t>• The Victory Gate: </a:t>
+            </a:r>
+            <a:pPr indent="0" marL="0">
+              <a:lnSpc>
+                <a:spcPct val="115000"/>
+              </a:lnSpc>
+              <a:buNone/>
+            </a:pPr>
+            <a:r>
+              <a:rPr lang="en-US" sz="1100" dirty="0">
                 <a:solidFill>
                   <a:srgbClr val="F59E0B"/>
                 </a:solidFill>
               </a:rPr>
-              <a:t>First 3 crews across the 1,000m line win Gold, Silver &amp; Bronze medals!
+              <a:t>First 3 crews to reach 1,000 meters win Gold, Silver &amp; Bronze medals!
 </a:t>
             </a:r>
             <a:pPr indent="0" marL="0">
@@ -4382,205 +3772,57 @@
               <a:buNone/>
             </a:pPr>
             <a:r>
-              <a:rPr lang="en-US" sz="1050" b="1" dirty="0">
+              <a:rPr lang="en-US" sz="1100" b="1" dirty="0">
+                <a:solidFill>
+                  <a:srgbClr val="F43F5E"/>
+                </a:solidFill>
+              </a:rPr>
+              <a:t>• 🐕‍🦺 Stygian Leash (Cerberus Revenge): </a:t>
+            </a:r>
+            <a:pPr indent="0" marL="0">
+              <a:lnSpc>
+                <a:spcPct val="115000"/>
+              </a:lnSpc>
+              <a:buNone/>
+            </a:pPr>
+            <a:r>
+              <a:rPr lang="en-US" sz="1100" dirty="0">
                 <a:solidFill>
                   <a:srgbClr val="E2E8F0"/>
                 </a:solidFill>
               </a:rPr>
-              <a:t>• Sudden Death: </a:t>
-            </a:r>
-            <a:pPr indent="0" marL="0">
-              <a:lnSpc>
-                <a:spcPct val="115000"/>
-              </a:lnSpc>
-              <a:buNone/>
-            </a:pPr>
-            <a:r>
-              <a:rPr lang="en-US" sz="1050" dirty="0">
+              <a:t>Tether your rival's boat. If they float: steal 50m. If they crash: drag them down &amp; get +100m! (If your own boat crashes, leash snaps: 0m).
+</a:t>
+            </a:r>
+            <a:pPr indent="0" marL="0">
+              <a:lnSpc>
+                <a:spcPct val="115000"/>
+              </a:lnSpc>
+              <a:buNone/>
+            </a:pPr>
+            <a:r>
+              <a:rPr lang="en-US" sz="1100" b="1" dirty="0">
+                <a:solidFill>
+                  <a:srgbClr val="E2E8F0"/>
+                </a:solidFill>
+              </a:rPr>
+              <a:t>• Sudden Death Standoff: </a:t>
+            </a:r>
+            <a:pPr indent="0" marL="0">
+              <a:lnSpc>
+                <a:spcPct val="115000"/>
+              </a:lnSpc>
+              <a:buNone/>
+            </a:pPr>
+            <a:r>
+              <a:rPr lang="en-US" sz="1100" dirty="0">
                 <a:solidFill>
                   <a:srgbClr val="94A3B8"/>
                 </a:solidFill>
               </a:rPr>
-              <a:t>Tie-breaker duel (Shields vs Ram vs Sails) if crews cross together.</a:t>
-            </a:r>
-            <a:endParaRPr lang="en-US" sz="1050" dirty="0"/>
-          </a:p>
-        </p:txBody>
-      </p:sp>
-      <p:sp>
-        <p:nvSpPr>
-          <p:cNvPr id="20" name="Shape 18"/>
-          <p:cNvSpPr/>
-          <p:nvPr/>
-        </p:nvSpPr>
-        <p:spPr>
-          <a:xfrm>
-            <a:off x="6199632" y="4023360"/>
-            <a:ext cx="5257800" cy="2286000"/>
-          </a:xfrm>
-          <a:prstGeom prst="roundRect">
-            <a:avLst>
-              <a:gd name="adj" fmla="val 3200"/>
-            </a:avLst>
-          </a:prstGeom>
-          <a:solidFill>
-            <a:srgbClr val="141A2A"/>
-          </a:solidFill>
-          <a:ln w="12700">
-            <a:solidFill>
-              <a:srgbClr val="334155"/>
-            </a:solidFill>
-            <a:prstDash val="solid"/>
-          </a:ln>
-        </p:spPr>
-      </p:sp>
-      <p:sp>
-        <p:nvSpPr>
-          <p:cNvPr id="21" name="Text 19"/>
-          <p:cNvSpPr/>
-          <p:nvPr/>
-        </p:nvSpPr>
-        <p:spPr>
-          <a:xfrm>
-            <a:off x="6428232" y="4160520"/>
-            <a:ext cx="4800600" cy="320040"/>
-          </a:xfrm>
-          <a:prstGeom prst="rect">
-            <a:avLst/>
-          </a:prstGeom>
-          <a:noFill/>
-          <a:ln/>
-        </p:spPr>
-        <p:txBody>
-          <a:bodyPr wrap="square" rtlCol="0" anchor="ctr"/>
-          <a:lstStyle/>
-          <a:p>
-            <a:pPr indent="0" marL="0">
-              <a:buNone/>
-            </a:pPr>
-            <a:r>
-              <a:rPr lang="en-US" sz="1400" b="1" dirty="0">
-                <a:solidFill>
-                  <a:srgbClr val="FEF3C7"/>
-                </a:solidFill>
-              </a:rPr>
-              <a:t>🐕 Cerberus Revenge Attack</a:t>
-            </a:r>
-            <a:endParaRPr lang="en-US" sz="1400" dirty="0"/>
-          </a:p>
-        </p:txBody>
-      </p:sp>
-      <p:sp>
-        <p:nvSpPr>
-          <p:cNvPr id="22" name="Text 20"/>
-          <p:cNvSpPr/>
-          <p:nvPr/>
-        </p:nvSpPr>
-        <p:spPr>
-          <a:xfrm>
-            <a:off x="6428232" y="4526280"/>
-            <a:ext cx="4800600" cy="1645920"/>
-          </a:xfrm>
-          <a:prstGeom prst="rect">
-            <a:avLst/>
-          </a:prstGeom>
-          <a:noFill/>
-          <a:ln/>
-        </p:spPr>
-        <p:txBody>
-          <a:bodyPr wrap="square" rtlCol="0" anchor="ctr"/>
-          <a:lstStyle/>
-          <a:p>
-            <a:pPr indent="0" marL="0">
-              <a:lnSpc>
-                <a:spcPct val="115000"/>
-              </a:lnSpc>
-              <a:buNone/>
-            </a:pPr>
-            <a:r>
-              <a:rPr lang="en-US" sz="1050" b="1" dirty="0">
-                <a:solidFill>
-                  <a:srgbClr val="E2E8F0"/>
-                </a:solidFill>
-              </a:rPr>
-              <a:t>• Retaliation for Betrayal: </a:t>
-            </a:r>
-            <a:pPr indent="0" marL="0">
-              <a:lnSpc>
-                <a:spcPct val="115000"/>
-              </a:lnSpc>
-              <a:buNone/>
-            </a:pPr>
-            <a:r>
-              <a:rPr lang="en-US" sz="1050" dirty="0">
-                <a:solidFill>
-                  <a:srgbClr val="94A3B8"/>
-                </a:solidFill>
-              </a:rPr>
-              <a:t>Teams backstabbed in Round 2 hold a Cerberus honey-cake treat.
-</a:t>
-            </a:r>
-            <a:pPr indent="0" marL="0">
-              <a:lnSpc>
-                <a:spcPct val="115000"/>
-              </a:lnSpc>
-              <a:buNone/>
-            </a:pPr>
-            <a:r>
-              <a:rPr lang="en-US" sz="1050" b="1" dirty="0">
-                <a:solidFill>
-                  <a:srgbClr val="E2E8F0"/>
-                </a:solidFill>
-              </a:rPr>
-              <a:t>• The Interception: </a:t>
-            </a:r>
-            <a:pPr indent="0" marL="0">
-              <a:lnSpc>
-                <a:spcPct val="115000"/>
-              </a:lnSpc>
-              <a:buNone/>
-            </a:pPr>
-            <a:r>
-              <a:rPr lang="en-US" sz="1050" dirty="0">
-                <a:solidFill>
-                  <a:srgbClr val="94A3B8"/>
-                </a:solidFill>
-              </a:rPr>
-              <a:t>Guess which boat your nemesis will pick this wave. If correct:
-</a:t>
-            </a:r>
-            <a:pPr indent="0" marL="0">
-              <a:lnSpc>
-                <a:spcPct val="115000"/>
-              </a:lnSpc>
-              <a:buNone/>
-            </a:pPr>
-            <a:r>
-              <a:rPr lang="en-US" sz="1050" b="1" dirty="0">
-                <a:solidFill>
-                  <a:srgbClr val="F43F5E"/>
-                </a:solidFill>
-              </a:rPr>
-              <a:t>  ➔ Nemesis dragged back -150m!</a:t>
-            </a:r>
-            <a:endParaRPr lang="en-US" sz="1050" dirty="0"/>
-          </a:p>
-          <a:p>
-            <a:pPr indent="0" marL="0">
-              <a:lnSpc>
-                <a:spcPct val="115000"/>
-              </a:lnSpc>
-              <a:buNone/>
-            </a:pPr>
-            <a:r>
-              <a:rPr lang="en-US" sz="1050" b="1" dirty="0">
-                <a:solidFill>
-                  <a:srgbClr val="F43F5E"/>
-                </a:solidFill>
-              </a:rPr>
-              <a:t>  ➔ Your crew surges forward +150m!</a:t>
-            </a:r>
-            <a:endParaRPr lang="en-US" sz="1050" dirty="0"/>
+              <a:t>Tie-breaker duel (Shields vs Ram vs Sails) if crews cross the portal simultaneously.</a:t>
+            </a:r>
+            <a:endParaRPr lang="en-US" sz="1100" dirty="0"/>
           </a:p>
         </p:txBody>
       </p:sp>
@@ -4625,7 +3867,7 @@
         <p:spPr>
           <a:xfrm>
             <a:off x="731520" y="411480"/>
-            <a:ext cx="7315200" cy="274320"/>
+            <a:ext cx="7315200" cy="256032"/>
           </a:xfrm>
           <a:prstGeom prst="rect">
             <a:avLst/>
@@ -4660,8 +3902,8 @@
         </p:nvSpPr>
         <p:spPr>
           <a:xfrm>
-            <a:off x="731520" y="685800"/>
-            <a:ext cx="10698480" cy="548640"/>
+            <a:off x="731520" y="658368"/>
+            <a:ext cx="10725912" cy="502920"/>
           </a:xfrm>
           <a:prstGeom prst="rect">
             <a:avLst/>
@@ -4696,8 +3938,8 @@
         </p:nvSpPr>
         <p:spPr>
           <a:xfrm>
-            <a:off x="731520" y="1234440"/>
-            <a:ext cx="10698480" cy="320040"/>
+            <a:off x="731520" y="1170432"/>
+            <a:ext cx="10725912" cy="292608"/>
           </a:xfrm>
           <a:prstGeom prst="rect">
             <a:avLst/>
@@ -5088,7 +4330,7 @@
                             <a:srgbClr val="94A3B8"/>
                           </a:solidFill>
                         </a:rPr>
-                        <a:t>Place 5 phones side-by-side in order (#1 to #5) across the table to connect carved lines.</a:t>
+                        <a:t>Align 5 phones physically (#1 to #5) on table to connect carved fracture lines.</a:t>
                       </a:r>
                       <a:endParaRPr lang="en-US" sz="1050" dirty="0"/>
                     </a:p>
@@ -5149,7 +4391,7 @@
                             <a:srgbClr val="94A3B8"/>
                           </a:solidFill>
                         </a:rPr>
-                        <a:t>Fast solve = top points (up to 300). Progressive hints cost -30 PTS each. 50 PTS floor.</a:t>
+                        <a:t>Fast solve = top points. 50 PTS safety floor. No elimination.</a:t>
                       </a:r>
                       <a:endParaRPr lang="en-US" sz="1050" dirty="0"/>
                     </a:p>
@@ -5210,7 +4452,7 @@
                             <a:srgbClr val="10B981"/>
                           </a:solidFill>
                         </a:rPr>
-                        <a:t>2-word codeword entered or timer expires.</a:t>
+                        <a:t>Codeword entered or timer expires.</a:t>
                       </a:r>
                       <a:endParaRPr lang="en-US" sz="1050" dirty="0"/>
                     </a:p>
@@ -5348,7 +4590,7 @@
                             <a:srgbClr val="94A3B8"/>
                           </a:solidFill>
                         </a:rPr>
-                        <a:t>Face rival table across 3 clashes. Whisper in huddle, negotiate across room, vote secretly.</a:t>
+                        <a:t>Prisoner's Dilemma: Face rival table across 3 clashes. Talk across room &amp; vote secretly.</a:t>
                       </a:r>
                       <a:endParaRPr lang="en-US" sz="1050" dirty="0"/>
                     </a:p>
@@ -5409,7 +4651,7 @@
                             <a:srgbClr val="94A3B8"/>
                           </a:solidFill>
                         </a:rPr>
-                        <a:t>Truce = steady points. Backstab = massive points or 0. Stakes triple in Clash 3.</a:t>
+                        <a:t>Truce = steady points. Backstab = huge points or 0. Stakes triple in Clash 3.</a:t>
                       </a:r>
                       <a:endParaRPr lang="en-US" sz="1050" dirty="0"/>
                     </a:p>
@@ -5470,7 +4712,7 @@
                             <a:srgbClr val="10B981"/>
                           </a:solidFill>
                         </a:rPr>
-                        <a:t>All 3 clashes resolved. Sets R3 headstart &amp; revenge tokens.</a:t>
+                        <a:t>All 3 clashes resolved.</a:t>
                       </a:r>
                       <a:endParaRPr lang="en-US" sz="1050" dirty="0"/>
                     </a:p>
@@ -5608,7 +4850,7 @@
                             <a:srgbClr val="94A3B8"/>
                           </a:solidFill>
                         </a:rPr>
-                        <a:t>Pick vessels secretly (Rowboat: safe, Sailboat: 30% cap, Ghost Ship: solo).</a:t>
+                        <a:t>Congestion race: Pick vessels (Rowboat: safe, Sailboat: 30% cap, Ghost: solo).</a:t>
                       </a:r>
                       <a:endParaRPr lang="en-US" sz="1050" dirty="0"/>
                     </a:p>
@@ -5669,7 +4911,7 @@
                             <a:srgbClr val="94A3B8"/>
                           </a:solidFill>
                         </a:rPr>
-                        <a:t>Points become river meters. Avoid congestion and unleash Cerberus revenge.</a:t>
+                        <a:t>Points become starting meters. Avoid congestion and unleash Cerberus revenge.</a:t>
                       </a:r>
                       <a:endParaRPr lang="en-US" sz="1050" dirty="0"/>
                     </a:p>

</xml_diff>